<commit_message>
Changed font on PPT and updated card top margin by 20px
</commit_message>
<xml_diff>
--- a/documentation/HireLens_Capstone_Final_Submission.pptx
+++ b/documentation/HireLens_Capstone_Final_Submission.pptx
@@ -26,16 +26,9 @@
   <p:notesSz cx="6858000" cy="9144000"/>
   <p:embeddedFontLst>
     <p:embeddedFont>
-      <p:font typeface="Poppins" panose="00000500000000000000" pitchFamily="2" charset="0"/>
+      <p:font typeface="Roboto Slab" pitchFamily="2" charset="0"/>
       <p:regular r:id="rId16"/>
       <p:bold r:id="rId17"/>
-      <p:italic r:id="rId18"/>
-      <p:boldItalic r:id="rId19"/>
-    </p:embeddedFont>
-    <p:embeddedFont>
-      <p:font typeface="Roboto Slab" panose="020F0502020204030204" pitchFamily="2" charset="0"/>
-      <p:regular r:id="rId20"/>
-      <p:bold r:id="rId21"/>
     </p:embeddedFont>
   </p:embeddedFontLst>
   <p:defaultTextStyle>
@@ -223,7 +216,7 @@
           <a:p>
             <a:fld id="{2C04DF3A-0132-4104-943D-4F8CBB4A4F3A}" type="datetimeFigureOut">
               <a:rPr lang="en-IN" smtClean="0"/>
-              <a:t>22-09-2026</a:t>
+              <a:t>23-09-2026</a:t>
             </a:fld>
             <a:endParaRPr lang="en-IN"/>
           </a:p>
@@ -838,7 +831,7 @@
           <a:p>
             <a:fld id="{AAC11897-8BC6-4790-9AEE-8382E829BD46}" type="datetimeFigureOut">
               <a:rPr lang="en-IN" smtClean="0"/>
-              <a:t>22-09-2026</a:t>
+              <a:t>23-09-2026</a:t>
             </a:fld>
             <a:endParaRPr lang="en-IN"/>
           </a:p>
@@ -1882,7 +1875,7 @@
           <a:p>
             <a:fld id="{AAC11897-8BC6-4790-9AEE-8382E829BD46}" type="datetimeFigureOut">
               <a:rPr lang="en-IN" smtClean="0"/>
-              <a:t>22-09-2026</a:t>
+              <a:t>23-09-2026</a:t>
             </a:fld>
             <a:endParaRPr lang="en-IN"/>
           </a:p>
@@ -2070,7 +2063,7 @@
           <a:p>
             <a:fld id="{F935C567-AFCF-4E1C-AA0E-C8D9AC99B565}" type="datetime1">
               <a:rPr lang="en-IN" smtClean="0"/>
-              <a:t>22-09-2026</a:t>
+              <a:t>23-09-2026</a:t>
             </a:fld>
             <a:endParaRPr lang="en-IN"/>
           </a:p>
@@ -10676,7 +10669,7 @@
           <a:p>
             <a:fld id="{AAC11897-8BC6-4790-9AEE-8382E829BD46}" type="datetimeFigureOut">
               <a:rPr lang="en-IN" smtClean="0"/>
-              <a:t>22-09-2026</a:t>
+              <a:t>23-09-2026</a:t>
             </a:fld>
             <a:endParaRPr lang="en-IN"/>
           </a:p>
@@ -11768,20 +11761,20 @@
           <a:lstStyle/>
           <a:p>
             <a:r>
-              <a:rPr lang="en-US" sz="2800" dirty="0">
+              <a:rPr lang="en-US" sz="3200" dirty="0">
                 <a:solidFill>
                   <a:srgbClr val="4A4C55"/>
                 </a:solidFill>
-                <a:latin typeface="Roboto Slab" pitchFamily="2" charset="0"/>
-                <a:ea typeface="Roboto Slab" pitchFamily="2" charset="0"/>
+                <a:latin typeface="Aptos" panose="020B0004020202020204" pitchFamily="34" charset="0"/>
                 <a:cs typeface="Poppins" panose="00000500000000000000" pitchFamily="2" charset="0"/>
               </a:rPr>
               <a:t>Analysis and Results</a:t>
             </a:r>
-            <a:endParaRPr lang="en-IN" dirty="0">
+            <a:endParaRPr lang="en-IN" sz="3200" dirty="0">
               <a:solidFill>
                 <a:srgbClr val="4A4C55"/>
               </a:solidFill>
+              <a:latin typeface="Aptos" panose="020B0004020202020204" pitchFamily="34" charset="0"/>
             </a:endParaRPr>
           </a:p>
         </p:txBody>
@@ -11933,7 +11926,7 @@
         <p:spPr>
           <a:xfrm>
             <a:off x="402336" y="1000107"/>
-            <a:ext cx="10094976" cy="369332"/>
+            <a:ext cx="10094976" cy="400110"/>
           </a:xfrm>
           <a:prstGeom prst="rect">
             <a:avLst/>
@@ -11952,24 +11945,16 @@
               </a:tabLst>
             </a:pPr>
             <a:r>
-              <a:rPr lang="en-IN" dirty="0">
+              <a:rPr lang="en-IN" sz="2000" dirty="0">
                 <a:solidFill>
                   <a:srgbClr val="4A4C55"/>
                 </a:solidFill>
-                <a:latin typeface="Roboto Slab" pitchFamily="2" charset="0"/>
+                <a:latin typeface="Aptos" panose="020B0004020202020204" pitchFamily="34" charset="0"/>
                 <a:ea typeface="Roboto Slab" pitchFamily="2" charset="0"/>
                 <a:cs typeface="Poppins" panose="00000500000000000000" pitchFamily="2" charset="0"/>
               </a:rPr>
               <a:t>What we validated, what the evidence shows, and how feedback loops back.</a:t>
             </a:r>
-            <a:endParaRPr lang="en-IN" sz="1800" dirty="0">
-              <a:solidFill>
-                <a:srgbClr val="4A4C55"/>
-              </a:solidFill>
-              <a:latin typeface="Roboto Slab" pitchFamily="2" charset="0"/>
-              <a:ea typeface="Roboto Slab" pitchFamily="2" charset="0"/>
-              <a:cs typeface="Poppins" panose="00000500000000000000" pitchFamily="2" charset="0"/>
-            </a:endParaRPr>
           </a:p>
         </p:txBody>
       </p:sp>
@@ -11982,7 +11967,7 @@
         <p:spPr>
           <a:xfrm>
             <a:off x="457200" y="1600200"/>
-            <a:ext cx="11247120" cy="4206240"/>
+            <a:ext cx="11247120" cy="3200620"/>
           </a:xfrm>
           <a:prstGeom prst="rect">
             <a:avLst/>
@@ -12001,56 +11986,86 @@
               </a:spcBef>
             </a:pPr>
             <a:r>
-              <a:rPr sz="1500" b="1">
+              <a:rPr sz="1600" b="1" dirty="0">
                 <a:solidFill>
                   <a:srgbClr val="4A4C55"/>
                 </a:solidFill>
-                <a:latin typeface="Roboto Slab"/>
+                <a:latin typeface="Aptos" panose="020B0004020202020204" pitchFamily="34" charset="0"/>
               </a:rPr>
               <a:t>Validation coverage</a:t>
             </a:r>
           </a:p>
           <a:p>
             <a:pPr>
+              <a:lnSpc>
+                <a:spcPct val="150000"/>
+              </a:lnSpc>
               <a:spcAft>
                 <a:spcPts val="400"/>
               </a:spcAft>
             </a:pPr>
             <a:r>
-              <a:rPr sz="1250">
+              <a:rPr sz="1400" dirty="0">
                 <a:solidFill>
                   <a:srgbClr val="333333"/>
                 </a:solidFill>
+                <a:latin typeface="Aptos" panose="020B0004020202020204" pitchFamily="34" charset="0"/>
               </a:rPr>
               <a:t>•  Schema validation on every structured output; quote verification against source documents; retrieved case IDs checked against what was actually fetched.</a:t>
             </a:r>
           </a:p>
           <a:p>
             <a:pPr>
+              <a:lnSpc>
+                <a:spcPct val="150000"/>
+              </a:lnSpc>
               <a:spcAft>
                 <a:spcPts val="400"/>
               </a:spcAft>
             </a:pPr>
             <a:r>
-              <a:rPr sz="1250">
+              <a:rPr sz="1400" dirty="0">
                 <a:solidFill>
                   <a:srgbClr val="333333"/>
                 </a:solidFill>
+                <a:latin typeface="Aptos" panose="020B0004020202020204" pitchFamily="34" charset="0"/>
               </a:rPr>
-              <a:t>•  Reflexion loops recover invalid outputs; systematic failures are written to shared agent memory as bias warnings.</a:t>
+              <a:t>•  </a:t>
+            </a:r>
+            <a:r>
+              <a:rPr sz="1400" dirty="0" err="1">
+                <a:solidFill>
+                  <a:srgbClr val="333333"/>
+                </a:solidFill>
+                <a:latin typeface="Aptos" panose="020B0004020202020204" pitchFamily="34" charset="0"/>
+              </a:rPr>
+              <a:t>Reflexion</a:t>
+            </a:r>
+            <a:r>
+              <a:rPr sz="1400" dirty="0">
+                <a:solidFill>
+                  <a:srgbClr val="333333"/>
+                </a:solidFill>
+                <a:latin typeface="Aptos" panose="020B0004020202020204" pitchFamily="34" charset="0"/>
+              </a:rPr>
+              <a:t> loops recover invalid outputs; systematic failures are written to shared agent memory as bias warnings.</a:t>
             </a:r>
           </a:p>
           <a:p>
             <a:pPr>
+              <a:lnSpc>
+                <a:spcPct val="150000"/>
+              </a:lnSpc>
               <a:spcAft>
                 <a:spcPts val="400"/>
               </a:spcAft>
             </a:pPr>
             <a:r>
-              <a:rPr sz="1250">
+              <a:rPr sz="1400" dirty="0">
                 <a:solidFill>
                   <a:srgbClr val="333333"/>
                 </a:solidFill>
+                <a:latin typeface="Aptos" panose="020B0004020202020204" pitchFamily="34" charset="0"/>
               </a:rPr>
               <a:t>•  Edge cases exercised: missing sections, weak resumes, contradictory transcripts, duplicate skill phrasing, PII-heavy documents.</a:t>
             </a:r>
@@ -12062,56 +12077,68 @@
               </a:spcBef>
             </a:pPr>
             <a:r>
-              <a:rPr sz="1500" b="1">
+              <a:rPr sz="1600" b="1" dirty="0">
                 <a:solidFill>
                   <a:srgbClr val="4A4C55"/>
                 </a:solidFill>
-                <a:latin typeface="Roboto Slab"/>
+                <a:latin typeface="Aptos" panose="020B0004020202020204" pitchFamily="34" charset="0"/>
               </a:rPr>
               <a:t>Results</a:t>
             </a:r>
           </a:p>
           <a:p>
             <a:pPr>
+              <a:lnSpc>
+                <a:spcPct val="150000"/>
+              </a:lnSpc>
               <a:spcAft>
                 <a:spcPts val="400"/>
               </a:spcAft>
             </a:pPr>
             <a:r>
-              <a:rPr sz="1250">
+              <a:rPr sz="1400" dirty="0">
                 <a:solidFill>
                   <a:srgbClr val="333333"/>
                 </a:solidFill>
+                <a:latin typeface="Aptos" panose="020B0004020202020204" pitchFamily="34" charset="0"/>
               </a:rPr>
               <a:t>•  Deterministic coverage anchor keeps LLM scores within a fixed tolerance, preventing score drift between runs.</a:t>
             </a:r>
           </a:p>
           <a:p>
             <a:pPr>
+              <a:lnSpc>
+                <a:spcPct val="150000"/>
+              </a:lnSpc>
               <a:spcAft>
                 <a:spcPts val="400"/>
               </a:spcAft>
             </a:pPr>
             <a:r>
-              <a:rPr sz="1250">
+              <a:rPr sz="1400" dirty="0">
                 <a:solidFill>
                   <a:srgbClr val="333333"/>
                 </a:solidFill>
+                <a:latin typeface="Aptos" panose="020B0004020202020204" pitchFamily="34" charset="0"/>
               </a:rPr>
               <a:t>•  Red flags without both a direct quote and a retrieved case ID are rejected by validators — no unsupported claims reach reviewers.</a:t>
             </a:r>
           </a:p>
           <a:p>
             <a:pPr>
+              <a:lnSpc>
+                <a:spcPct val="150000"/>
+              </a:lnSpc>
               <a:spcAft>
                 <a:spcPts val="400"/>
               </a:spcAft>
             </a:pPr>
             <a:r>
-              <a:rPr sz="1250">
+              <a:rPr sz="1400" dirty="0">
                 <a:solidFill>
                   <a:srgbClr val="333333"/>
                 </a:solidFill>
+                <a:latin typeface="Aptos" panose="020B0004020202020204" pitchFamily="34" charset="0"/>
               </a:rPr>
               <a:t>•  Expert-verified gaps become embedded precedent, measurably improving subsequent retrieval relevance.</a:t>
             </a:r>
@@ -12177,10 +12204,11 @@
           <a:lstStyle/>
           <a:p>
             <a:r>
-              <a:rPr lang="en-US" dirty="0">
+              <a:rPr lang="en-US" sz="3200" dirty="0">
                 <a:solidFill>
                   <a:srgbClr val="4A4C55"/>
                 </a:solidFill>
+                <a:latin typeface="Aptos" panose="020B0004020202020204" pitchFamily="34" charset="0"/>
                 <a:cs typeface="Poppins" panose="00000500000000000000" pitchFamily="2" charset="0"/>
               </a:rPr>
               <a:t>Suggestions and Conclusions</a:t>
@@ -12335,7 +12363,7 @@
         <p:spPr>
           <a:xfrm>
             <a:off x="436696" y="1006270"/>
-            <a:ext cx="6096000" cy="369332"/>
+            <a:ext cx="6096000" cy="400110"/>
           </a:xfrm>
           <a:prstGeom prst="rect">
             <a:avLst/>
@@ -12349,21 +12377,21 @@
           <a:lstStyle/>
           <a:p>
             <a:r>
-              <a:rPr lang="en-IN" dirty="0">
+              <a:rPr lang="en-IN" sz="2000" dirty="0">
                 <a:solidFill>
                   <a:srgbClr val="4A4C55"/>
                 </a:solidFill>
-                <a:latin typeface="Roboto Slab" pitchFamily="2" charset="0"/>
+                <a:latin typeface="Aptos" panose="020B0004020202020204" pitchFamily="34" charset="0"/>
                 <a:ea typeface="Roboto Slab" pitchFamily="2" charset="0"/>
                 <a:cs typeface="Poppins" panose="00000500000000000000" pitchFamily="2" charset="0"/>
               </a:rPr>
               <a:t>Insights  |  Next steps  |  Future scope</a:t>
             </a:r>
-            <a:endParaRPr lang="en-US" dirty="0">
+            <a:endParaRPr lang="en-US" sz="2000" dirty="0">
               <a:solidFill>
                 <a:srgbClr val="4A4C55"/>
               </a:solidFill>
-              <a:latin typeface="Roboto Slab" pitchFamily="2" charset="0"/>
+              <a:latin typeface="Aptos" panose="020B0004020202020204" pitchFamily="34" charset="0"/>
               <a:ea typeface="Roboto Slab" pitchFamily="2" charset="0"/>
               <a:cs typeface="Poppins" panose="00000500000000000000" pitchFamily="2" charset="0"/>
             </a:endParaRPr>
@@ -12379,7 +12407,7 @@
         <p:spPr>
           <a:xfrm>
             <a:off x="457200" y="1600200"/>
-            <a:ext cx="5486400" cy="4206240"/>
+            <a:ext cx="5486400" cy="3046731"/>
           </a:xfrm>
           <a:prstGeom prst="rect">
             <a:avLst/>
@@ -12398,71 +12426,87 @@
               </a:spcBef>
             </a:pPr>
             <a:r>
-              <a:rPr sz="1500" b="1">
+              <a:rPr sz="1600" b="1" dirty="0">
                 <a:solidFill>
                   <a:srgbClr val="4A4C55"/>
                 </a:solidFill>
-                <a:latin typeface="Roboto Slab"/>
+                <a:latin typeface="Aptos" panose="020B0004020202020204" pitchFamily="34" charset="0"/>
               </a:rPr>
               <a:t>Insights</a:t>
             </a:r>
           </a:p>
           <a:p>
             <a:pPr>
+              <a:lnSpc>
+                <a:spcPct val="150000"/>
+              </a:lnSpc>
               <a:spcAft>
                 <a:spcPts val="400"/>
               </a:spcAft>
             </a:pPr>
             <a:r>
-              <a:rPr sz="1250">
+              <a:rPr sz="1400" dirty="0">
                 <a:solidFill>
                   <a:srgbClr val="333333"/>
                 </a:solidFill>
+                <a:latin typeface="Aptos" panose="020B0004020202020204" pitchFamily="34" charset="0"/>
               </a:rPr>
               <a:t>•  Grounding AI claims in quotes and retrieved cases is what makes reviewers trust the system.</a:t>
             </a:r>
           </a:p>
           <a:p>
             <a:pPr>
+              <a:lnSpc>
+                <a:spcPct val="150000"/>
+              </a:lnSpc>
               <a:spcAft>
                 <a:spcPts val="400"/>
               </a:spcAft>
             </a:pPr>
             <a:r>
-              <a:rPr sz="1250">
+              <a:rPr sz="1400" dirty="0">
                 <a:solidFill>
                   <a:srgbClr val="333333"/>
                 </a:solidFill>
+                <a:latin typeface="Aptos" panose="020B0004020202020204" pitchFamily="34" charset="0"/>
               </a:rPr>
               <a:t>•  A deterministic anchor plus LLM reasoning beats either approach alone.</a:t>
             </a:r>
           </a:p>
           <a:p>
             <a:pPr>
+              <a:lnSpc>
+                <a:spcPct val="150000"/>
+              </a:lnSpc>
               <a:spcAft>
                 <a:spcPts val="400"/>
               </a:spcAft>
             </a:pPr>
             <a:r>
-              <a:rPr sz="1250">
+              <a:rPr sz="1400" dirty="0">
                 <a:solidFill>
                   <a:srgbClr val="333333"/>
                 </a:solidFill>
+                <a:latin typeface="Aptos" panose="020B0004020202020204" pitchFamily="34" charset="0"/>
               </a:rPr>
               <a:t>•  Privacy filtering at a central boundary is simpler to audit than per-agent rules.</a:t>
             </a:r>
           </a:p>
           <a:p>
             <a:pPr>
+              <a:lnSpc>
+                <a:spcPct val="150000"/>
+              </a:lnSpc>
               <a:spcAft>
                 <a:spcPts val="400"/>
               </a:spcAft>
             </a:pPr>
             <a:r>
-              <a:rPr sz="1250">
+              <a:rPr sz="1400" dirty="0">
                 <a:solidFill>
                   <a:srgbClr val="333333"/>
                 </a:solidFill>
+                <a:latin typeface="Aptos" panose="020B0004020202020204" pitchFamily="34" charset="0"/>
               </a:rPr>
               <a:t>•  Observability (run history, workflow path, token metrics) turned AI behavior into something recruiters can inspect and correct.</a:t>
             </a:r>
@@ -12478,7 +12522,7 @@
         <p:spPr>
           <a:xfrm>
             <a:off x="6309360" y="1600200"/>
-            <a:ext cx="5486400" cy="4206240"/>
+            <a:ext cx="5486400" cy="2723566"/>
           </a:xfrm>
           <a:prstGeom prst="rect">
             <a:avLst/>
@@ -12497,71 +12541,87 @@
               </a:spcBef>
             </a:pPr>
             <a:r>
-              <a:rPr sz="1500" b="1">
+              <a:rPr sz="1600" b="1" dirty="0">
                 <a:solidFill>
                   <a:srgbClr val="4A4C55"/>
                 </a:solidFill>
-                <a:latin typeface="Roboto Slab"/>
+                <a:latin typeface="Aptos" panose="020B0004020202020204" pitchFamily="34" charset="0"/>
               </a:rPr>
               <a:t>Next steps &amp; future scope</a:t>
             </a:r>
           </a:p>
           <a:p>
             <a:pPr>
+              <a:lnSpc>
+                <a:spcPct val="150000"/>
+              </a:lnSpc>
               <a:spcAft>
                 <a:spcPts val="400"/>
               </a:spcAft>
             </a:pPr>
             <a:r>
-              <a:rPr sz="1250">
+              <a:rPr sz="1400" dirty="0">
                 <a:solidFill>
                   <a:srgbClr val="333333"/>
                 </a:solidFill>
+                <a:latin typeface="Aptos" panose="020B0004020202020204" pitchFamily="34" charset="0"/>
               </a:rPr>
               <a:t>•  Calendar and ATS integrations for end-to-end pipeline coverage.</a:t>
             </a:r>
           </a:p>
           <a:p>
             <a:pPr>
+              <a:lnSpc>
+                <a:spcPct val="150000"/>
+              </a:lnSpc>
               <a:spcAft>
                 <a:spcPts val="400"/>
               </a:spcAft>
             </a:pPr>
             <a:r>
-              <a:rPr sz="1250">
+              <a:rPr sz="1400" dirty="0">
                 <a:solidFill>
                   <a:srgbClr val="333333"/>
                 </a:solidFill>
+                <a:latin typeface="Aptos" panose="020B0004020202020204" pitchFamily="34" charset="0"/>
               </a:rPr>
               <a:t>•  Calibration analytics: track override rates per agent to tune prompts and thresholds.</a:t>
             </a:r>
           </a:p>
           <a:p>
             <a:pPr>
+              <a:lnSpc>
+                <a:spcPct val="150000"/>
+              </a:lnSpc>
               <a:spcAft>
                 <a:spcPts val="400"/>
               </a:spcAft>
             </a:pPr>
             <a:r>
-              <a:rPr sz="1250">
+              <a:rPr sz="1400" dirty="0">
                 <a:solidFill>
                   <a:srgbClr val="333333"/>
                 </a:solidFill>
+                <a:latin typeface="Aptos" panose="020B0004020202020204" pitchFamily="34" charset="0"/>
               </a:rPr>
               <a:t>•  Richer knowledge base: outcome data (hired/not) as retrieval precedent.</a:t>
             </a:r>
           </a:p>
           <a:p>
             <a:pPr>
+              <a:lnSpc>
+                <a:spcPct val="150000"/>
+              </a:lnSpc>
               <a:spcAft>
                 <a:spcPts val="400"/>
               </a:spcAft>
             </a:pPr>
             <a:r>
-              <a:rPr sz="1250">
+              <a:rPr sz="1400" dirty="0">
                 <a:solidFill>
                   <a:srgbClr val="333333"/>
                 </a:solidFill>
+                <a:latin typeface="Aptos" panose="020B0004020202020204" pitchFamily="34" charset="0"/>
               </a:rPr>
               <a:t>•  Role-based access and per-team workspaces on top of the shared model.</a:t>
             </a:r>
@@ -12632,6 +12692,7 @@
                 <a:solidFill>
                   <a:srgbClr val="4A4C55"/>
                 </a:solidFill>
+                <a:latin typeface="Aptos" panose="020B0004020202020204" pitchFamily="34" charset="0"/>
                 <a:cs typeface="Poppins" panose="00000500000000000000" pitchFamily="2" charset="0"/>
               </a:rPr>
               <a:t>Annexure</a:t>
@@ -12804,7 +12865,7 @@
                 <a:solidFill>
                   <a:srgbClr val="4A4C55"/>
                 </a:solidFill>
-                <a:latin typeface="Roboto Slab" pitchFamily="2" charset="0"/>
+                <a:latin typeface="Aptos" panose="020B0004020202020204" pitchFamily="34" charset="0"/>
                 <a:ea typeface="Roboto Slab" pitchFamily="2" charset="0"/>
                 <a:cs typeface="Poppins" panose="00000500000000000000" pitchFamily="2" charset="0"/>
               </a:rPr>
@@ -12814,7 +12875,7 @@
               <a:solidFill>
                 <a:srgbClr val="4A4C55"/>
               </a:solidFill>
-              <a:latin typeface="Roboto Slab" pitchFamily="2" charset="0"/>
+              <a:latin typeface="Aptos" panose="020B0004020202020204" pitchFamily="34" charset="0"/>
               <a:ea typeface="Roboto Slab" pitchFamily="2" charset="0"/>
               <a:cs typeface="Poppins" panose="00000500000000000000" pitchFamily="2" charset="0"/>
             </a:endParaRPr>
@@ -12830,7 +12891,7 @@
         <p:spPr>
           <a:xfrm>
             <a:off x="457200" y="1600200"/>
-            <a:ext cx="11247120" cy="4206240"/>
+            <a:ext cx="11247120" cy="2826158"/>
           </a:xfrm>
           <a:prstGeom prst="rect">
             <a:avLst/>
@@ -12849,43 +12910,159 @@
               </a:spcBef>
             </a:pPr>
             <a:r>
-              <a:rPr sz="1500" b="1">
+              <a:rPr sz="1600" b="1" dirty="0">
                 <a:solidFill>
                   <a:srgbClr val="4A4C55"/>
                 </a:solidFill>
-                <a:latin typeface="Roboto Slab"/>
+                <a:latin typeface="Aptos" panose="020B0004020202020204" pitchFamily="34" charset="0"/>
               </a:rPr>
               <a:t>Codebase &amp; artefacts</a:t>
             </a:r>
           </a:p>
           <a:p>
             <a:pPr>
+              <a:lnSpc>
+                <a:spcPct val="150000"/>
+              </a:lnSpc>
               <a:spcAft>
                 <a:spcPts val="400"/>
               </a:spcAft>
             </a:pPr>
             <a:r>
-              <a:rPr sz="1250">
+              <a:rPr sz="1400" dirty="0">
                 <a:solidFill>
                   <a:srgbClr val="333333"/>
                 </a:solidFill>
+                <a:latin typeface="Aptos" panose="020B0004020202020204" pitchFamily="34" charset="0"/>
               </a:rPr>
-              <a:t>•  HireLens application — Next.js 16, React 19, LangChain/LangGraph, Supabase + pgvector, OpenAI chat and embedding models.</a:t>
+              <a:t>•  </a:t>
+            </a:r>
+            <a:r>
+              <a:rPr sz="1400" dirty="0" err="1">
+                <a:solidFill>
+                  <a:srgbClr val="333333"/>
+                </a:solidFill>
+                <a:latin typeface="Aptos" panose="020B0004020202020204" pitchFamily="34" charset="0"/>
+              </a:rPr>
+              <a:t>HireLens</a:t>
+            </a:r>
+            <a:r>
+              <a:rPr sz="1400" dirty="0">
+                <a:solidFill>
+                  <a:srgbClr val="333333"/>
+                </a:solidFill>
+                <a:latin typeface="Aptos" panose="020B0004020202020204" pitchFamily="34" charset="0"/>
+              </a:rPr>
+              <a:t> application — Next.js 16, React 19, </a:t>
+            </a:r>
+            <a:r>
+              <a:rPr sz="1400" dirty="0" err="1">
+                <a:solidFill>
+                  <a:srgbClr val="333333"/>
+                </a:solidFill>
+                <a:latin typeface="Aptos" panose="020B0004020202020204" pitchFamily="34" charset="0"/>
+              </a:rPr>
+              <a:t>LangChain</a:t>
+            </a:r>
+            <a:r>
+              <a:rPr sz="1400" dirty="0">
+                <a:solidFill>
+                  <a:srgbClr val="333333"/>
+                </a:solidFill>
+                <a:latin typeface="Aptos" panose="020B0004020202020204" pitchFamily="34" charset="0"/>
+              </a:rPr>
+              <a:t>/</a:t>
+            </a:r>
+            <a:r>
+              <a:rPr sz="1400" dirty="0" err="1">
+                <a:solidFill>
+                  <a:srgbClr val="333333"/>
+                </a:solidFill>
+                <a:latin typeface="Aptos" panose="020B0004020202020204" pitchFamily="34" charset="0"/>
+              </a:rPr>
+              <a:t>LangGraph</a:t>
+            </a:r>
+            <a:r>
+              <a:rPr sz="1400" dirty="0">
+                <a:solidFill>
+                  <a:srgbClr val="333333"/>
+                </a:solidFill>
+                <a:latin typeface="Aptos" panose="020B0004020202020204" pitchFamily="34" charset="0"/>
+              </a:rPr>
+              <a:t>, </a:t>
+            </a:r>
+            <a:r>
+              <a:rPr sz="1400" dirty="0" err="1">
+                <a:solidFill>
+                  <a:srgbClr val="333333"/>
+                </a:solidFill>
+                <a:latin typeface="Aptos" panose="020B0004020202020204" pitchFamily="34" charset="0"/>
+              </a:rPr>
+              <a:t>Supabase</a:t>
+            </a:r>
+            <a:r>
+              <a:rPr sz="1400" dirty="0">
+                <a:solidFill>
+                  <a:srgbClr val="333333"/>
+                </a:solidFill>
+                <a:latin typeface="Aptos" panose="020B0004020202020204" pitchFamily="34" charset="0"/>
+              </a:rPr>
+              <a:t> + </a:t>
+            </a:r>
+            <a:r>
+              <a:rPr sz="1400" dirty="0" err="1">
+                <a:solidFill>
+                  <a:srgbClr val="333333"/>
+                </a:solidFill>
+                <a:latin typeface="Aptos" panose="020B0004020202020204" pitchFamily="34" charset="0"/>
+              </a:rPr>
+              <a:t>pgvector</a:t>
+            </a:r>
+            <a:r>
+              <a:rPr sz="1400" dirty="0">
+                <a:solidFill>
+                  <a:srgbClr val="333333"/>
+                </a:solidFill>
+                <a:latin typeface="Aptos" panose="020B0004020202020204" pitchFamily="34" charset="0"/>
+              </a:rPr>
+              <a:t>, OpenAI chat and embedding models.</a:t>
             </a:r>
           </a:p>
           <a:p>
             <a:pPr>
+              <a:lnSpc>
+                <a:spcPct val="150000"/>
+              </a:lnSpc>
               <a:spcAft>
                 <a:spcPts val="400"/>
               </a:spcAft>
             </a:pPr>
             <a:r>
-              <a:rPr sz="1250">
+              <a:rPr sz="1400" dirty="0">
                 <a:solidFill>
                   <a:srgbClr val="333333"/>
                 </a:solidFill>
+                <a:latin typeface="Aptos" panose="020B0004020202020204" pitchFamily="34" charset="0"/>
               </a:rPr>
-              <a:t>•  Project documentation — PRD, multi-agent architecture notes, token usage optimisation plan, knowledge-base usage guide (documentation/ folder).</a:t>
+              <a:t>•  Project documentation — PRD, multi-agent architecture notes, token usage </a:t>
+            </a:r>
+            <a:r>
+              <a:rPr sz="1400" dirty="0" err="1">
+                <a:solidFill>
+                  <a:srgbClr val="333333"/>
+                </a:solidFill>
+                <a:latin typeface="Aptos" panose="020B0004020202020204" pitchFamily="34" charset="0"/>
+              </a:rPr>
+              <a:t>optimisation</a:t>
+            </a:r>
+            <a:r>
+              <a:rPr sz="1400" dirty="0">
+                <a:solidFill>
+                  <a:srgbClr val="333333"/>
+                </a:solidFill>
+                <a:latin typeface="Aptos" panose="020B0004020202020204" pitchFamily="34" charset="0"/>
+              </a:rPr>
+              <a:t> plan, knowledge-base usage guide (documentation/ folder).</a:t>
             </a:r>
           </a:p>
           <a:p>
@@ -12895,58 +13072,142 @@
               </a:spcBef>
             </a:pPr>
             <a:r>
-              <a:rPr sz="1500" b="1">
+              <a:rPr sz="1600" b="1" dirty="0">
                 <a:solidFill>
                   <a:srgbClr val="4A4C55"/>
                 </a:solidFill>
-                <a:latin typeface="Roboto Slab"/>
+                <a:latin typeface="Aptos" panose="020B0004020202020204" pitchFamily="34" charset="0"/>
               </a:rPr>
               <a:t>References</a:t>
             </a:r>
           </a:p>
           <a:p>
             <a:pPr>
+              <a:lnSpc>
+                <a:spcPct val="150000"/>
+              </a:lnSpc>
               <a:spcAft>
                 <a:spcPts val="400"/>
               </a:spcAft>
             </a:pPr>
             <a:r>
-              <a:rPr sz="1250">
+              <a:rPr sz="1400" dirty="0">
                 <a:solidFill>
                   <a:srgbClr val="333333"/>
                 </a:solidFill>
+                <a:latin typeface="Aptos" panose="020B0004020202020204" pitchFamily="34" charset="0"/>
               </a:rPr>
-              <a:t>•  LangGraph and LangChain documentation — agent orchestration and structured output.</a:t>
+              <a:t>•  </a:t>
+            </a:r>
+            <a:r>
+              <a:rPr sz="1400" dirty="0" err="1">
+                <a:solidFill>
+                  <a:srgbClr val="333333"/>
+                </a:solidFill>
+                <a:latin typeface="Aptos" panose="020B0004020202020204" pitchFamily="34" charset="0"/>
+              </a:rPr>
+              <a:t>LangGraph</a:t>
+            </a:r>
+            <a:r>
+              <a:rPr sz="1400" dirty="0">
+                <a:solidFill>
+                  <a:srgbClr val="333333"/>
+                </a:solidFill>
+                <a:latin typeface="Aptos" panose="020B0004020202020204" pitchFamily="34" charset="0"/>
+              </a:rPr>
+              <a:t> and </a:t>
+            </a:r>
+            <a:r>
+              <a:rPr sz="1400" dirty="0" err="1">
+                <a:solidFill>
+                  <a:srgbClr val="333333"/>
+                </a:solidFill>
+                <a:latin typeface="Aptos" panose="020B0004020202020204" pitchFamily="34" charset="0"/>
+              </a:rPr>
+              <a:t>LangChain</a:t>
+            </a:r>
+            <a:r>
+              <a:rPr sz="1400" dirty="0">
+                <a:solidFill>
+                  <a:srgbClr val="333333"/>
+                </a:solidFill>
+                <a:latin typeface="Aptos" panose="020B0004020202020204" pitchFamily="34" charset="0"/>
+              </a:rPr>
+              <a:t> documentation — agent orchestration and structured output.</a:t>
             </a:r>
           </a:p>
           <a:p>
             <a:pPr>
+              <a:lnSpc>
+                <a:spcPct val="150000"/>
+              </a:lnSpc>
               <a:spcAft>
                 <a:spcPts val="400"/>
               </a:spcAft>
             </a:pPr>
             <a:r>
-              <a:rPr sz="1250">
+              <a:rPr sz="1400" dirty="0">
                 <a:solidFill>
                   <a:srgbClr val="333333"/>
                 </a:solidFill>
+                <a:latin typeface="Aptos" panose="020B0004020202020204" pitchFamily="34" charset="0"/>
               </a:rPr>
               <a:t>•  OpenAI API documentation — chat models, embeddings, structured outputs.</a:t>
             </a:r>
           </a:p>
           <a:p>
             <a:pPr>
+              <a:lnSpc>
+                <a:spcPct val="150000"/>
+              </a:lnSpc>
               <a:spcAft>
                 <a:spcPts val="400"/>
               </a:spcAft>
             </a:pPr>
             <a:r>
-              <a:rPr sz="1250">
+              <a:rPr sz="1400" dirty="0">
                 <a:solidFill>
                   <a:srgbClr val="333333"/>
                 </a:solidFill>
+                <a:latin typeface="Aptos" panose="020B0004020202020204" pitchFamily="34" charset="0"/>
               </a:rPr>
-              <a:t>•  Supabase documentation — Postgres, pgvector similarity search, Auth with RLS.</a:t>
+              <a:t>•  </a:t>
+            </a:r>
+            <a:r>
+              <a:rPr sz="1400" dirty="0" err="1">
+                <a:solidFill>
+                  <a:srgbClr val="333333"/>
+                </a:solidFill>
+                <a:latin typeface="Aptos" panose="020B0004020202020204" pitchFamily="34" charset="0"/>
+              </a:rPr>
+              <a:t>Supabase</a:t>
+            </a:r>
+            <a:r>
+              <a:rPr sz="1400" dirty="0">
+                <a:solidFill>
+                  <a:srgbClr val="333333"/>
+                </a:solidFill>
+                <a:latin typeface="Aptos" panose="020B0004020202020204" pitchFamily="34" charset="0"/>
+              </a:rPr>
+              <a:t> documentation — Postgres, </a:t>
+            </a:r>
+            <a:r>
+              <a:rPr sz="1400" dirty="0" err="1">
+                <a:solidFill>
+                  <a:srgbClr val="333333"/>
+                </a:solidFill>
+                <a:latin typeface="Aptos" panose="020B0004020202020204" pitchFamily="34" charset="0"/>
+              </a:rPr>
+              <a:t>pgvector</a:t>
+            </a:r>
+            <a:r>
+              <a:rPr sz="1400" dirty="0">
+                <a:solidFill>
+                  <a:srgbClr val="333333"/>
+                </a:solidFill>
+                <a:latin typeface="Aptos" panose="020B0004020202020204" pitchFamily="34" charset="0"/>
+              </a:rPr>
+              <a:t> similarity search, Auth with RLS.</a:t>
             </a:r>
           </a:p>
         </p:txBody>
@@ -21538,14 +21799,16 @@
                 <a:solidFill>
                   <a:srgbClr val="4A4C55"/>
                 </a:solidFill>
-                <a:latin typeface="+mj-lt"/>
+                <a:latin typeface="Aptos" panose="020B0004020202020204" pitchFamily="34" charset="0"/>
                 <a:ea typeface="+mn-ea"/>
                 <a:cs typeface="+mn-cs"/>
               </a:rPr>
               <a:t>Problem Statement and Context</a:t>
             </a:r>
             <a:r>
-              <a:rPr lang="en-IN" dirty="0"/>
+              <a:rPr lang="en-IN" dirty="0">
+                <a:latin typeface="Aptos" panose="020B0004020202020204" pitchFamily="34" charset="0"/>
+              </a:rPr>
               <a:t> </a:t>
             </a:r>
           </a:p>
@@ -21697,8 +21960,8 @@
         </p:nvSpPr>
         <p:spPr>
           <a:xfrm>
-            <a:off x="405395" y="1118666"/>
-            <a:ext cx="7183074" cy="361637"/>
+            <a:off x="405394" y="1118666"/>
+            <a:ext cx="7851099" cy="361637"/>
           </a:xfrm>
           <a:prstGeom prst="rect">
             <a:avLst/>
@@ -21722,7 +21985,7 @@
                   <a:srgbClr val="4A4C55"/>
                 </a:solidFill>
                 <a:effectLst/>
-                <a:latin typeface="+mj-lt"/>
+                <a:latin typeface="Aptos" panose="020B0004020202020204" pitchFamily="34" charset="0"/>
               </a:rPr>
               <a:t>Who is affected | What is broken today | Why agentic AI, why now</a:t>
             </a:r>
@@ -21730,7 +21993,7 @@
               <a:solidFill>
                 <a:srgbClr val="4A4C55"/>
               </a:solidFill>
-              <a:latin typeface="+mj-lt"/>
+              <a:latin typeface="Aptos" panose="020B0004020202020204" pitchFamily="34" charset="0"/>
             </a:endParaRPr>
           </a:p>
         </p:txBody>
@@ -21744,7 +22007,7 @@
         <p:spPr>
           <a:xfrm>
             <a:off x="457200" y="1600200"/>
-            <a:ext cx="5577840" cy="4206240"/>
+            <a:ext cx="5577840" cy="3288080"/>
           </a:xfrm>
           <a:prstGeom prst="rect">
             <a:avLst/>
@@ -21763,11 +22026,11 @@
               </a:spcBef>
             </a:pPr>
             <a:r>
-              <a:rPr sz="1500" b="1" dirty="0">
+              <a:rPr sz="1600" b="1" dirty="0">
                 <a:solidFill>
                   <a:srgbClr val="4A4C55"/>
                 </a:solidFill>
-                <a:latin typeface="Roboto Slab"/>
+                <a:latin typeface="Aptos" panose="020B0004020202020204" pitchFamily="34" charset="0"/>
               </a:rPr>
               <a:t>Personas &amp; stakeholders</a:t>
             </a:r>
@@ -21779,10 +22042,11 @@
               </a:spcAft>
             </a:pPr>
             <a:r>
-              <a:rPr sz="1250" dirty="0">
+              <a:rPr sz="1400" dirty="0">
                 <a:solidFill>
                   <a:srgbClr val="333333"/>
                 </a:solidFill>
+                <a:latin typeface="Aptos" panose="020B0004020202020204" pitchFamily="34" charset="0"/>
               </a:rPr>
               <a:t>•  Recruiters / talent partners — screen every resume manually against loosely structured JDs.</a:t>
             </a:r>
@@ -21794,10 +22058,11 @@
               </a:spcAft>
             </a:pPr>
             <a:r>
-              <a:rPr sz="1250" dirty="0">
+              <a:rPr sz="1400" dirty="0">
                 <a:solidFill>
                   <a:srgbClr val="333333"/>
                 </a:solidFill>
+                <a:latin typeface="Aptos" panose="020B0004020202020204" pitchFamily="34" charset="0"/>
               </a:rPr>
               <a:t>•  Hiring managers — receive inconsistent, unverifiable interview feedback.</a:t>
             </a:r>
@@ -21809,10 +22074,11 @@
               </a:spcAft>
             </a:pPr>
             <a:r>
-              <a:rPr sz="1250" dirty="0">
+              <a:rPr sz="1400" dirty="0">
                 <a:solidFill>
                   <a:srgbClr val="333333"/>
                 </a:solidFill>
+                <a:latin typeface="Aptos" panose="020B0004020202020204" pitchFamily="34" charset="0"/>
               </a:rPr>
               <a:t>•  Reviewers — make final calls with no audit trail of how AI reached them.</a:t>
             </a:r>
@@ -21824,10 +22090,11 @@
               </a:spcAft>
             </a:pPr>
             <a:r>
-              <a:rPr sz="1250" dirty="0">
+              <a:rPr sz="1400" dirty="0">
                 <a:solidFill>
                   <a:srgbClr val="333333"/>
                 </a:solidFill>
+                <a:latin typeface="Aptos" panose="020B0004020202020204" pitchFamily="34" charset="0"/>
               </a:rPr>
               <a:t>•  Candidates — personal data is often pasted wholesale into external AI tools.</a:t>
             </a:r>
@@ -21839,11 +22106,11 @@
               </a:spcBef>
             </a:pPr>
             <a:r>
-              <a:rPr sz="1500" b="1" dirty="0">
+              <a:rPr sz="1600" b="1" dirty="0">
                 <a:solidFill>
                   <a:srgbClr val="4A4C55"/>
                 </a:solidFill>
-                <a:latin typeface="Roboto Slab"/>
+                <a:latin typeface="Aptos" panose="020B0004020202020204" pitchFamily="34" charset="0"/>
               </a:rPr>
               <a:t>Why this topic</a:t>
             </a:r>
@@ -21855,10 +22122,11 @@
               </a:spcAft>
             </a:pPr>
             <a:r>
-              <a:rPr sz="1250" dirty="0">
+              <a:rPr sz="1400" dirty="0">
                 <a:solidFill>
                   <a:srgbClr val="333333"/>
                 </a:solidFill>
+                <a:latin typeface="Aptos" panose="020B0004020202020204" pitchFamily="34" charset="0"/>
               </a:rPr>
               <a:t>Hiring quality and compliance pressure demand evidence, consistency, and privacy — agentic AI can deliver all three while humans keep the final decision.</a:t>
             </a:r>
@@ -21874,7 +22142,7 @@
         <p:spPr>
           <a:xfrm>
             <a:off x="6309360" y="1600200"/>
-            <a:ext cx="5486400" cy="4206240"/>
+            <a:ext cx="5486400" cy="3529171"/>
           </a:xfrm>
           <a:prstGeom prst="rect">
             <a:avLst/>
@@ -21893,11 +22161,11 @@
               </a:spcBef>
             </a:pPr>
             <a:r>
-              <a:rPr sz="1500" b="1">
+              <a:rPr sz="1600" b="1" dirty="0">
                 <a:solidFill>
                   <a:srgbClr val="4A4C55"/>
                 </a:solidFill>
-                <a:latin typeface="Roboto Slab"/>
+                <a:latin typeface="Aptos" panose="020B0004020202020204" pitchFamily="34" charset="0"/>
               </a:rPr>
               <a:t>Problem statement</a:t>
             </a:r>
@@ -21909,10 +22177,11 @@
               </a:spcAft>
             </a:pPr>
             <a:r>
-              <a:rPr sz="1250">
+              <a:rPr sz="1400" dirty="0">
                 <a:solidFill>
                   <a:srgbClr val="333333"/>
                 </a:solidFill>
+                <a:latin typeface="Aptos" panose="020B0004020202020204" pitchFamily="34" charset="0"/>
               </a:rPr>
               <a:t>Resume screening and interview evaluation are slow, subjective, and hard to audit. Keyword filters miss qualified candidates; generic AI tools produce ungrounded claims and leak candidate PII to model providers.</a:t>
             </a:r>
@@ -21924,11 +22193,11 @@
               </a:spcBef>
             </a:pPr>
             <a:r>
-              <a:rPr sz="1500" b="1">
+              <a:rPr sz="1600" b="1" dirty="0">
                 <a:solidFill>
                   <a:srgbClr val="4A4C55"/>
                 </a:solidFill>
-                <a:latin typeface="Roboto Slab"/>
+                <a:latin typeface="Aptos" panose="020B0004020202020204" pitchFamily="34" charset="0"/>
               </a:rPr>
               <a:t>Pain points today</a:t>
             </a:r>
@@ -21940,10 +22209,11 @@
               </a:spcAft>
             </a:pPr>
             <a:r>
-              <a:rPr sz="1250">
+              <a:rPr sz="1400" dirty="0">
                 <a:solidFill>
                   <a:srgbClr val="333333"/>
                 </a:solidFill>
+                <a:latin typeface="Aptos" panose="020B0004020202020204" pitchFamily="34" charset="0"/>
               </a:rPr>
               <a:t>•  Manual JD and resume reading does not scale and varies by reviewer.</a:t>
             </a:r>
@@ -21955,10 +22225,11 @@
               </a:spcAft>
             </a:pPr>
             <a:r>
-              <a:rPr sz="1250">
+              <a:rPr sz="1400" dirty="0">
                 <a:solidFill>
                   <a:srgbClr val="333333"/>
                 </a:solidFill>
+                <a:latin typeface="Aptos" panose="020B0004020202020204" pitchFamily="34" charset="0"/>
               </a:rPr>
               <a:t>•  Keyword matching cannot weigh requirement importance or cite evidence.</a:t>
             </a:r>
@@ -21970,10 +22241,11 @@
               </a:spcAft>
             </a:pPr>
             <a:r>
-              <a:rPr sz="1250">
+              <a:rPr sz="1400" dirty="0">
                 <a:solidFill>
                   <a:srgbClr val="333333"/>
                 </a:solidFill>
+                <a:latin typeface="Aptos" panose="020B0004020202020204" pitchFamily="34" charset="0"/>
               </a:rPr>
               <a:t>•  Interview feedback is unstructured — quotes, signals, and flags are lost.</a:t>
             </a:r>
@@ -21985,10 +22257,11 @@
               </a:spcAft>
             </a:pPr>
             <a:r>
-              <a:rPr sz="1250">
+              <a:rPr sz="1400" dirty="0">
                 <a:solidFill>
                   <a:srgbClr val="333333"/>
                 </a:solidFill>
+                <a:latin typeface="Aptos" panose="020B0004020202020204" pitchFamily="34" charset="0"/>
               </a:rPr>
               <a:t>•  Existing AI features are black boxes: no provenance, no reviewability.</a:t>
             </a:r>
@@ -22064,8 +22337,7 @@
                 <a:solidFill>
                   <a:srgbClr val="4A4C55"/>
                 </a:solidFill>
-                <a:latin typeface="Roboto Slab" pitchFamily="2" charset="0"/>
-                <a:ea typeface="Roboto Slab" pitchFamily="2" charset="0"/>
+                <a:latin typeface="Aptos" panose="020B0004020202020204" pitchFamily="34" charset="0"/>
                 <a:cs typeface="Poppins" panose="00000500000000000000" pitchFamily="2" charset="0"/>
               </a:rPr>
               <a:t>Project Objectives</a:t>
@@ -22074,6 +22346,7 @@
               <a:solidFill>
                 <a:srgbClr val="4A4C55"/>
               </a:solidFill>
+              <a:latin typeface="Aptos" panose="020B0004020202020204" pitchFamily="34" charset="0"/>
             </a:endParaRPr>
           </a:p>
         </p:txBody>
@@ -22248,7 +22521,7 @@
                 <a:solidFill>
                   <a:srgbClr val="4A4C55"/>
                 </a:solidFill>
-                <a:latin typeface="Roboto Slab" pitchFamily="2" charset="0"/>
+                <a:latin typeface="Aptos" panose="020B0004020202020204" pitchFamily="34" charset="0"/>
                 <a:ea typeface="Roboto Slab" pitchFamily="2" charset="0"/>
                 <a:cs typeface="Poppins" panose="00000500000000000000" pitchFamily="2" charset="0"/>
               </a:rPr>
@@ -22272,7 +22545,7 @@
         <p:spPr>
           <a:xfrm>
             <a:off x="883227" y="1894259"/>
-            <a:ext cx="10092634" cy="1994777"/>
+            <a:ext cx="10092634" cy="2492990"/>
           </a:xfrm>
           <a:prstGeom prst="rect">
             <a:avLst/>
@@ -22294,12 +22567,31 @@
               </a:spcAft>
             </a:pPr>
             <a:r>
-              <a:rPr sz="1400">
+              <a:rPr sz="1400" dirty="0">
                 <a:solidFill>
                   <a:srgbClr val="000000"/>
                 </a:solidFill>
+                <a:latin typeface="Aptos" panose="020B0004020202020204" pitchFamily="34" charset="0"/>
               </a:rPr>
-              <a:t>1.  Automate structured extraction of weighted job requirements and anonymised candidate profiles, filtering PII before any content reaches a model provider.</a:t>
+              <a:t>1.  Automate structured extraction of weighted job requirements and </a:t>
+            </a:r>
+            <a:r>
+              <a:rPr sz="1400" dirty="0" err="1">
+                <a:solidFill>
+                  <a:srgbClr val="000000"/>
+                </a:solidFill>
+                <a:latin typeface="Aptos" panose="020B0004020202020204" pitchFamily="34" charset="0"/>
+              </a:rPr>
+              <a:t>anonymised</a:t>
+            </a:r>
+            <a:r>
+              <a:rPr sz="1400" dirty="0">
+                <a:solidFill>
+                  <a:srgbClr val="000000"/>
+                </a:solidFill>
+                <a:latin typeface="Aptos" panose="020B0004020202020204" pitchFamily="34" charset="0"/>
+              </a:rPr>
+              <a:t> candidate profiles, filtering PII before any content reaches a model provider.</a:t>
             </a:r>
           </a:p>
           <a:p>
@@ -22309,10 +22601,11 @@
               </a:spcAft>
             </a:pPr>
             <a:r>
-              <a:rPr sz="1400">
+              <a:rPr sz="1400" dirty="0">
                 <a:solidFill>
                   <a:srgbClr val="000000"/>
                 </a:solidFill>
+                <a:latin typeface="Aptos" panose="020B0004020202020204" pitchFamily="34" charset="0"/>
               </a:rPr>
               <a:t>2.  Generate evidence-grounded match analyses and tailored interview plans using intent-driven Agentic RAG over a privacy-filtered case knowledge base.</a:t>
             </a:r>
@@ -22324,10 +22617,11 @@
               </a:spcAft>
             </a:pPr>
             <a:r>
-              <a:rPr sz="1400">
+              <a:rPr sz="1400" dirty="0">
                 <a:solidFill>
                   <a:srgbClr val="000000"/>
                 </a:solidFill>
+                <a:latin typeface="Aptos" panose="020B0004020202020204" pitchFamily="34" charset="0"/>
               </a:rPr>
               <a:t>3.  Evaluate interview transcripts with quote-grounded scoring and case-grounded red-flag detection, keeping a human reviewer in control of every outcome.</a:t>
             </a:r>
@@ -22339,10 +22633,11 @@
               </a:spcAft>
             </a:pPr>
             <a:r>
-              <a:rPr sz="1400">
+              <a:rPr sz="1400" dirty="0">
                 <a:solidFill>
                   <a:srgbClr val="000000"/>
                 </a:solidFill>
+                <a:latin typeface="Aptos" panose="020B0004020202020204" pitchFamily="34" charset="0"/>
               </a:rPr>
               <a:t>4.  Reduce screening and evaluation effort per candidate while improving consistency, auditability, and reviewer trust in AI recommendations.</a:t>
             </a:r>
@@ -22418,8 +22713,7 @@
                 <a:solidFill>
                   <a:srgbClr val="4A4C55"/>
                 </a:solidFill>
-                <a:latin typeface="Roboto Slab" pitchFamily="2" charset="0"/>
-                <a:ea typeface="Roboto Slab" pitchFamily="2" charset="0"/>
+                <a:latin typeface="Aptos" panose="020B0004020202020204" pitchFamily="34" charset="0"/>
                 <a:cs typeface="Poppins" panose="00000500000000000000" pitchFamily="2" charset="0"/>
               </a:rPr>
               <a:t>Current Vs Proposed Approach</a:t>
@@ -22428,6 +22722,7 @@
               <a:solidFill>
                 <a:srgbClr val="4A4C55"/>
               </a:solidFill>
+              <a:latin typeface="Aptos" panose="020B0004020202020204" pitchFamily="34" charset="0"/>
             </a:endParaRPr>
           </a:p>
         </p:txBody>
@@ -22602,7 +22897,7 @@
                 <a:solidFill>
                   <a:srgbClr val="4A4C55"/>
                 </a:solidFill>
-                <a:latin typeface="Roboto Slab" pitchFamily="2" charset="0"/>
+                <a:latin typeface="Aptos" panose="020B0004020202020204" pitchFamily="34" charset="0"/>
                 <a:ea typeface="Roboto Slab" pitchFamily="2" charset="0"/>
                 <a:cs typeface="Poppins" panose="00000500000000000000" pitchFamily="2" charset="0"/>
               </a:rPr>
@@ -22612,7 +22907,7 @@
               <a:solidFill>
                 <a:srgbClr val="4A4C55"/>
               </a:solidFill>
-              <a:latin typeface="Roboto Slab" pitchFamily="2" charset="0"/>
+              <a:latin typeface="Aptos" panose="020B0004020202020204" pitchFamily="34" charset="0"/>
               <a:ea typeface="Roboto Slab" pitchFamily="2" charset="0"/>
               <a:cs typeface="Poppins" panose="00000500000000000000" pitchFamily="2" charset="0"/>
             </a:endParaRPr>
@@ -22628,7 +22923,7 @@
         <p:spPr>
           <a:xfrm>
             <a:off x="548640" y="1645920"/>
-            <a:ext cx="5212080" cy="4023360"/>
+            <a:ext cx="5212080" cy="1887696"/>
           </a:xfrm>
           <a:prstGeom prst="rect">
             <a:avLst/>
@@ -22647,11 +22942,11 @@
               </a:spcBef>
             </a:pPr>
             <a:r>
-              <a:rPr sz="1500" b="1">
+              <a:rPr sz="1600" b="1" dirty="0">
                 <a:solidFill>
                   <a:srgbClr val="4A4C55"/>
                 </a:solidFill>
-                <a:latin typeface="Roboto Slab"/>
+                <a:latin typeface="Aptos" panose="020B0004020202020204" pitchFamily="34" charset="0"/>
               </a:rPr>
               <a:t>Current approach</a:t>
             </a:r>
@@ -22663,10 +22958,11 @@
               </a:spcAft>
             </a:pPr>
             <a:r>
-              <a:rPr sz="1250">
+              <a:rPr sz="1400" dirty="0">
                 <a:solidFill>
                   <a:srgbClr val="333333"/>
                 </a:solidFill>
+                <a:latin typeface="Aptos" panose="020B0004020202020204" pitchFamily="34" charset="0"/>
               </a:rPr>
               <a:t>•  Recruiter reads each JD and resume by hand.</a:t>
             </a:r>
@@ -22678,10 +22974,11 @@
               </a:spcAft>
             </a:pPr>
             <a:r>
-              <a:rPr sz="1250">
+              <a:rPr sz="1400" dirty="0">
                 <a:solidFill>
                   <a:srgbClr val="333333"/>
                 </a:solidFill>
+                <a:latin typeface="Aptos" panose="020B0004020202020204" pitchFamily="34" charset="0"/>
               </a:rPr>
               <a:t>•  Keyword search and gut feel decide shortlists.</a:t>
             </a:r>
@@ -22693,10 +22990,11 @@
               </a:spcAft>
             </a:pPr>
             <a:r>
-              <a:rPr sz="1250">
+              <a:rPr sz="1400" dirty="0">
                 <a:solidFill>
                   <a:srgbClr val="333333"/>
                 </a:solidFill>
+                <a:latin typeface="Aptos" panose="020B0004020202020204" pitchFamily="34" charset="0"/>
               </a:rPr>
               <a:t>•  Interviews produce free-text notes; no scoring rubric.</a:t>
             </a:r>
@@ -22708,10 +23006,11 @@
               </a:spcAft>
             </a:pPr>
             <a:r>
-              <a:rPr sz="1250">
+              <a:rPr sz="1400" dirty="0">
                 <a:solidFill>
                   <a:srgbClr val="333333"/>
                 </a:solidFill>
+                <a:latin typeface="Aptos" panose="020B0004020202020204" pitchFamily="34" charset="0"/>
               </a:rPr>
               <a:t>•  Flags and inconsistencies surface only if a human spots them.</a:t>
             </a:r>
@@ -22723,10 +23022,11 @@
               </a:spcAft>
             </a:pPr>
             <a:r>
-              <a:rPr sz="1250">
+              <a:rPr sz="1400" dirty="0">
                 <a:solidFill>
                   <a:srgbClr val="333333"/>
                 </a:solidFill>
+                <a:latin typeface="Aptos" panose="020B0004020202020204" pitchFamily="34" charset="0"/>
               </a:rPr>
               <a:t>•  No memory — every requisition starts from zero.</a:t>
             </a:r>
@@ -22738,10 +23038,11 @@
               </a:spcAft>
             </a:pPr>
             <a:r>
-              <a:rPr sz="1250">
+              <a:rPr sz="1400" dirty="0">
                 <a:solidFill>
                   <a:srgbClr val="333333"/>
                 </a:solidFill>
+                <a:latin typeface="Aptos" panose="020B0004020202020204" pitchFamily="34" charset="0"/>
               </a:rPr>
               <a:t>•  PII pasted into generic AI chat tools for summaries.</a:t>
             </a:r>
@@ -22796,7 +23097,7 @@
         <p:spPr>
           <a:xfrm>
             <a:off x="6400800" y="1645920"/>
-            <a:ext cx="5303520" cy="4023360"/>
+            <a:ext cx="5303520" cy="2964914"/>
           </a:xfrm>
           <a:prstGeom prst="rect">
             <a:avLst/>
@@ -22815,13 +23116,31 @@
               </a:spcBef>
             </a:pPr>
             <a:r>
-              <a:rPr sz="1500" b="1">
+              <a:rPr sz="1600" b="1" dirty="0">
                 <a:solidFill>
                   <a:srgbClr val="4A4C55"/>
                 </a:solidFill>
-                <a:latin typeface="Roboto Slab"/>
+                <a:latin typeface="Aptos" panose="020B0004020202020204" pitchFamily="34" charset="0"/>
               </a:rPr>
-              <a:t>Proposed: HireLens agentic workflow</a:t>
+              <a:t>Proposed: </a:t>
+            </a:r>
+            <a:r>
+              <a:rPr sz="1600" b="1" dirty="0" err="1">
+                <a:solidFill>
+                  <a:srgbClr val="4A4C55"/>
+                </a:solidFill>
+                <a:latin typeface="Aptos" panose="020B0004020202020204" pitchFamily="34" charset="0"/>
+              </a:rPr>
+              <a:t>HireLens</a:t>
+            </a:r>
+            <a:r>
+              <a:rPr sz="1600" b="1" dirty="0">
+                <a:solidFill>
+                  <a:srgbClr val="4A4C55"/>
+                </a:solidFill>
+                <a:latin typeface="Aptos" panose="020B0004020202020204" pitchFamily="34" charset="0"/>
+              </a:rPr>
+              <a:t> agentic workflow</a:t>
             </a:r>
           </a:p>
           <a:p>
@@ -22831,10 +23150,11 @@
               </a:spcAft>
             </a:pPr>
             <a:r>
-              <a:rPr sz="1250">
+              <a:rPr sz="1400" dirty="0">
                 <a:solidFill>
                   <a:srgbClr val="333333"/>
                 </a:solidFill>
+                <a:latin typeface="Aptos" panose="020B0004020202020204" pitchFamily="34" charset="0"/>
               </a:rPr>
               <a:t>•  JD and Resume Agents extract weighted, structured profiles.</a:t>
             </a:r>
@@ -22846,10 +23166,11 @@
               </a:spcAft>
             </a:pPr>
             <a:r>
-              <a:rPr sz="1250">
+              <a:rPr sz="1400" dirty="0">
                 <a:solidFill>
                   <a:srgbClr val="333333"/>
                 </a:solidFill>
+                <a:latin typeface="Aptos" panose="020B0004020202020204" pitchFamily="34" charset="0"/>
               </a:rPr>
               <a:t>•  Evidence match score: deterministic coverage anchored, LLM-reasoned.</a:t>
             </a:r>
@@ -22861,10 +23182,11 @@
               </a:spcAft>
             </a:pPr>
             <a:r>
-              <a:rPr sz="1250">
+              <a:rPr sz="1400" dirty="0">
                 <a:solidFill>
                   <a:srgbClr val="333333"/>
                 </a:solidFill>
+                <a:latin typeface="Aptos" panose="020B0004020202020204" pitchFamily="34" charset="0"/>
               </a:rPr>
               <a:t>•  Transcript evaluation scores technical + communication with direct quotes.</a:t>
             </a:r>
@@ -22876,10 +23198,11 @@
               </a:spcAft>
             </a:pPr>
             <a:r>
-              <a:rPr sz="1250">
+              <a:rPr sz="1400" dirty="0">
                 <a:solidFill>
                   <a:srgbClr val="333333"/>
                 </a:solidFill>
+                <a:latin typeface="Aptos" panose="020B0004020202020204" pitchFamily="34" charset="0"/>
               </a:rPr>
               <a:t>•  Red Flag Agent only flags when a quote AND a retrieved case support it.</a:t>
             </a:r>
@@ -22891,10 +23214,11 @@
               </a:spcAft>
             </a:pPr>
             <a:r>
-              <a:rPr sz="1250">
+              <a:rPr sz="1400" dirty="0">
                 <a:solidFill>
                   <a:srgbClr val="333333"/>
                 </a:solidFill>
+                <a:latin typeface="Aptos" panose="020B0004020202020204" pitchFamily="34" charset="0"/>
               </a:rPr>
               <a:t>•  Reviewer decisions and verified gaps feed memory and RAG precedent.</a:t>
             </a:r>
@@ -22906,10 +23230,11 @@
               </a:spcAft>
             </a:pPr>
             <a:r>
-              <a:rPr sz="1250">
+              <a:rPr sz="1400" dirty="0">
                 <a:solidFill>
                   <a:srgbClr val="333333"/>
                 </a:solidFill>
+                <a:latin typeface="Aptos" panose="020B0004020202020204" pitchFamily="34" charset="0"/>
               </a:rPr>
               <a:t>•  Central PII filter strips identity before any model call or embedding.</a:t>
             </a:r>
@@ -22985,8 +23310,7 @@
                 <a:solidFill>
                   <a:srgbClr val="4A4C55"/>
                 </a:solidFill>
-                <a:latin typeface="Roboto Slab" pitchFamily="2" charset="0"/>
-                <a:ea typeface="Roboto Slab" pitchFamily="2" charset="0"/>
+                <a:latin typeface="Aptos" panose="020B0004020202020204" pitchFamily="34" charset="0"/>
                 <a:cs typeface="Poppins" panose="00000500000000000000" pitchFamily="2" charset="0"/>
               </a:rPr>
               <a:t>System Architecture</a:t>
@@ -22995,6 +23319,7 @@
               <a:solidFill>
                 <a:srgbClr val="4A4C55"/>
               </a:solidFill>
+              <a:latin typeface="Aptos" panose="020B0004020202020204" pitchFamily="34" charset="0"/>
             </a:endParaRPr>
           </a:p>
         </p:txBody>
@@ -23169,7 +23494,7 @@
                 <a:solidFill>
                   <a:srgbClr val="4A4C55"/>
                 </a:solidFill>
-                <a:latin typeface="Roboto Slab" pitchFamily="2" charset="0"/>
+                <a:latin typeface="Aptos" panose="020B0004020202020204" pitchFamily="34" charset="0"/>
                 <a:ea typeface="Roboto Slab" pitchFamily="2" charset="0"/>
                 <a:cs typeface="Poppins" panose="00000500000000000000" pitchFamily="2" charset="0"/>
               </a:rPr>
@@ -23179,7 +23504,7 @@
               <a:solidFill>
                 <a:srgbClr val="4A4C55"/>
               </a:solidFill>
-              <a:latin typeface="Roboto Slab" pitchFamily="2" charset="0"/>
+              <a:latin typeface="Aptos" panose="020B0004020202020204" pitchFamily="34" charset="0"/>
               <a:ea typeface="Roboto Slab" pitchFamily="2" charset="0"/>
               <a:cs typeface="Poppins" panose="00000500000000000000" pitchFamily="2" charset="0"/>
             </a:endParaRPr>
@@ -23221,14 +23546,14 @@
                 <a:solidFill>
                   <a:srgbClr val="1A2B5E"/>
                 </a:solidFill>
-                <a:latin typeface="Roboto Slab" pitchFamily="2" charset="0"/>
+                <a:latin typeface="Aptos" panose="020B0004020202020204" pitchFamily="34" charset="0"/>
                 <a:ea typeface="Roboto Slab" pitchFamily="2" charset="0"/>
                 <a:cs typeface="Roboto Slab" pitchFamily="2" charset="0"/>
               </a:rPr>
               <a:t>HireLens — Candidate Analysis &amp; Transcript Review</a:t>
             </a:r>
             <a:endParaRPr lang="en-US" sz="1300" dirty="0">
-              <a:latin typeface="Roboto Slab" pitchFamily="2" charset="0"/>
+              <a:latin typeface="Aptos" panose="020B0004020202020204" pitchFamily="34" charset="0"/>
               <a:ea typeface="Roboto Slab" pitchFamily="2" charset="0"/>
               <a:cs typeface="Roboto Slab" pitchFamily="2" charset="0"/>
             </a:endParaRPr>
@@ -23357,18 +23682,18 @@
               <a:buNone/>
             </a:pPr>
             <a:r>
-              <a:rPr lang="en-US" sz="850" b="1" kern="0" spc="100" dirty="0">
+              <a:rPr lang="en-US" sz="1100" b="1" kern="0" spc="100" dirty="0">
                 <a:solidFill>
                   <a:srgbClr val="065A82"/>
                 </a:solidFill>
-                <a:latin typeface="Roboto Slab" pitchFamily="2" charset="0"/>
+                <a:latin typeface="Aptos" panose="020B0004020202020204" pitchFamily="34" charset="0"/>
                 <a:ea typeface="Roboto Slab" pitchFamily="2" charset="0"/>
                 <a:cs typeface="Roboto Slab" pitchFamily="2" charset="0"/>
               </a:rPr>
               <a:t>TRIGGER</a:t>
             </a:r>
-            <a:endParaRPr lang="en-US" sz="850" dirty="0">
-              <a:latin typeface="Roboto Slab" pitchFamily="2" charset="0"/>
+            <a:endParaRPr lang="en-US" sz="1100" dirty="0">
+              <a:latin typeface="Aptos" panose="020B0004020202020204" pitchFamily="34" charset="0"/>
               <a:ea typeface="Roboto Slab" pitchFamily="2" charset="0"/>
               <a:cs typeface="Roboto Slab" pitchFamily="2" charset="0"/>
             </a:endParaRPr>
@@ -23390,7 +23715,7 @@
         <p:spPr>
           <a:xfrm>
             <a:off x="1477588" y="2861935"/>
-            <a:ext cx="1572768" cy="1417320"/>
+            <a:ext cx="1572768" cy="2211012"/>
           </a:xfrm>
           <a:prstGeom prst="rect">
             <a:avLst/>
@@ -23448,18 +23773,18 @@
               <a:buNone/>
             </a:pPr>
             <a:r>
-              <a:rPr lang="en-US" sz="850" dirty="0">
+              <a:rPr lang="en-US" sz="1200" dirty="0">
                 <a:solidFill>
                   <a:srgbClr val="374151"/>
                 </a:solidFill>
-                <a:latin typeface="Roboto Slab" pitchFamily="2" charset="0"/>
+                <a:latin typeface="Aptos" panose="020B0004020202020204" pitchFamily="34" charset="0"/>
                 <a:ea typeface="Roboto Slab" pitchFamily="2" charset="0"/>
                 <a:cs typeface="Roboto Slab" pitchFamily="2" charset="0"/>
               </a:rPr>
               <a:t>Recruiter uploads a JD, resume, or interview transcript in the app.</a:t>
             </a:r>
-            <a:endParaRPr lang="en-US" sz="850" dirty="0">
-              <a:latin typeface="Roboto Slab" pitchFamily="2" charset="0"/>
+            <a:endParaRPr lang="en-US" sz="1200" dirty="0">
+              <a:latin typeface="Aptos" panose="020B0004020202020204" pitchFamily="34" charset="0"/>
               <a:ea typeface="Roboto Slab" pitchFamily="2" charset="0"/>
               <a:cs typeface="Roboto Slab" pitchFamily="2" charset="0"/>
             </a:endParaRPr>
@@ -23630,18 +23955,18 @@
               <a:buNone/>
             </a:pPr>
             <a:r>
-              <a:rPr lang="en-US" sz="850" b="1" kern="0" spc="100" dirty="0">
+              <a:rPr lang="en-US" sz="1100" b="1" kern="0" spc="100" dirty="0">
                 <a:solidFill>
                   <a:srgbClr val="1A2B5E"/>
                 </a:solidFill>
-                <a:latin typeface="Roboto Slab" pitchFamily="2" charset="0"/>
+                <a:latin typeface="Aptos" panose="020B0004020202020204" pitchFamily="34" charset="0"/>
                 <a:ea typeface="Roboto Slab" pitchFamily="2" charset="0"/>
                 <a:cs typeface="Roboto Slab" pitchFamily="2" charset="0"/>
               </a:rPr>
               <a:t>SENSE</a:t>
             </a:r>
-            <a:endParaRPr lang="en-US" sz="850" dirty="0">
-              <a:latin typeface="Roboto Slab" pitchFamily="2" charset="0"/>
+            <a:endParaRPr lang="en-US" sz="1100" dirty="0">
+              <a:latin typeface="Aptos" panose="020B0004020202020204" pitchFamily="34" charset="0"/>
               <a:ea typeface="Roboto Slab" pitchFamily="2" charset="0"/>
               <a:cs typeface="Roboto Slab" pitchFamily="2" charset="0"/>
             </a:endParaRPr>
@@ -23663,7 +23988,7 @@
         <p:spPr>
           <a:xfrm>
             <a:off x="3196660" y="2861935"/>
-            <a:ext cx="1572768" cy="1417320"/>
+            <a:ext cx="1572768" cy="2211012"/>
           </a:xfrm>
           <a:prstGeom prst="rect">
             <a:avLst/>
@@ -23721,18 +24046,18 @@
               <a:buNone/>
             </a:pPr>
             <a:r>
-              <a:rPr lang="en-US" sz="850" dirty="0">
+              <a:rPr lang="en-US" sz="1200" dirty="0">
                 <a:solidFill>
                   <a:srgbClr val="374151"/>
                 </a:solidFill>
-                <a:latin typeface="Roboto Slab" pitchFamily="2" charset="0"/>
+                <a:latin typeface="Aptos" panose="020B0004020202020204" pitchFamily="34" charset="0"/>
                 <a:ea typeface="Roboto Slab" pitchFamily="2" charset="0"/>
                 <a:cs typeface="Roboto Slab" pitchFamily="2" charset="0"/>
               </a:rPr>
               <a:t>Structured extraction of requirements and anonymised profile; privacy-filtered embeddings and historical cases retrieved via pgvector.</a:t>
             </a:r>
-            <a:endParaRPr lang="en-US" sz="850" dirty="0">
-              <a:latin typeface="Roboto Slab" pitchFamily="2" charset="0"/>
+            <a:endParaRPr lang="en-US" sz="1200" dirty="0">
+              <a:latin typeface="Aptos" panose="020B0004020202020204" pitchFamily="34" charset="0"/>
               <a:ea typeface="Roboto Slab" pitchFamily="2" charset="0"/>
               <a:cs typeface="Roboto Slab" pitchFamily="2" charset="0"/>
             </a:endParaRPr>
@@ -23903,18 +24228,18 @@
               <a:buNone/>
             </a:pPr>
             <a:r>
-              <a:rPr lang="en-US" sz="850" b="1" kern="0" spc="100" dirty="0">
+              <a:rPr lang="en-US" sz="1100" b="1" kern="0" spc="100" dirty="0">
                 <a:solidFill>
                   <a:srgbClr val="0D7377"/>
                 </a:solidFill>
-                <a:latin typeface="Roboto Slab" pitchFamily="2" charset="0"/>
+                <a:latin typeface="Aptos" panose="020B0004020202020204" pitchFamily="34" charset="0"/>
                 <a:ea typeface="Roboto Slab" pitchFamily="2" charset="0"/>
                 <a:cs typeface="Roboto Slab" pitchFamily="2" charset="0"/>
               </a:rPr>
               <a:t>REASON</a:t>
             </a:r>
-            <a:endParaRPr lang="en-US" sz="850" dirty="0">
-              <a:latin typeface="Roboto Slab" pitchFamily="2" charset="0"/>
+            <a:endParaRPr lang="en-US" sz="1100" dirty="0">
+              <a:latin typeface="Aptos" panose="020B0004020202020204" pitchFamily="34" charset="0"/>
               <a:ea typeface="Roboto Slab" pitchFamily="2" charset="0"/>
               <a:cs typeface="Roboto Slab" pitchFamily="2" charset="0"/>
             </a:endParaRPr>
@@ -23936,7 +24261,7 @@
         <p:spPr>
           <a:xfrm>
             <a:off x="4915732" y="2861935"/>
-            <a:ext cx="1572768" cy="1417320"/>
+            <a:ext cx="1572768" cy="2211012"/>
           </a:xfrm>
           <a:prstGeom prst="rect">
             <a:avLst/>
@@ -23994,18 +24319,18 @@
               <a:buNone/>
             </a:pPr>
             <a:r>
-              <a:rPr lang="en-US" sz="850" dirty="0">
+              <a:rPr lang="en-US" sz="1200" dirty="0">
                 <a:solidFill>
                   <a:srgbClr val="374151"/>
                 </a:solidFill>
-                <a:latin typeface="Roboto Slab" pitchFamily="2" charset="0"/>
+                <a:latin typeface="Aptos" panose="020B0004020202020204" pitchFamily="34" charset="0"/>
                 <a:ea typeface="Roboto Slab" pitchFamily="2" charset="0"/>
                 <a:cs typeface="Roboto Slab" pitchFamily="2" charset="0"/>
               </a:rPr>
               <a:t>Supervisor routes depth; Evidence Retrieval plans 2–4 semantic queries; Gap Analysis reconciles LLM judgment with a deterministic coverage anchor.</a:t>
             </a:r>
-            <a:endParaRPr lang="en-US" sz="850" dirty="0">
-              <a:latin typeface="Roboto Slab" pitchFamily="2" charset="0"/>
+            <a:endParaRPr lang="en-US" sz="1200" dirty="0">
+              <a:latin typeface="Aptos" panose="020B0004020202020204" pitchFamily="34" charset="0"/>
               <a:ea typeface="Roboto Slab" pitchFamily="2" charset="0"/>
               <a:cs typeface="Roboto Slab" pitchFamily="2" charset="0"/>
             </a:endParaRPr>
@@ -24176,18 +24501,18 @@
               <a:buNone/>
             </a:pPr>
             <a:r>
-              <a:rPr lang="en-US" sz="850" b="1" kern="0" spc="100" dirty="0">
+              <a:rPr lang="en-US" sz="1100" b="1" kern="0" spc="100" dirty="0">
                 <a:solidFill>
                   <a:srgbClr val="E8620A"/>
                 </a:solidFill>
-                <a:latin typeface="Roboto Slab" pitchFamily="2" charset="0"/>
+                <a:latin typeface="Aptos" panose="020B0004020202020204" pitchFamily="34" charset="0"/>
                 <a:ea typeface="Roboto Slab" pitchFamily="2" charset="0"/>
                 <a:cs typeface="Roboto Slab" pitchFamily="2" charset="0"/>
               </a:rPr>
               <a:t>ACT</a:t>
             </a:r>
-            <a:endParaRPr lang="en-US" sz="850" dirty="0">
-              <a:latin typeface="Roboto Slab" pitchFamily="2" charset="0"/>
+            <a:endParaRPr lang="en-US" sz="1100" dirty="0">
+              <a:latin typeface="Aptos" panose="020B0004020202020204" pitchFamily="34" charset="0"/>
               <a:ea typeface="Roboto Slab" pitchFamily="2" charset="0"/>
               <a:cs typeface="Roboto Slab" pitchFamily="2" charset="0"/>
             </a:endParaRPr>
@@ -24209,7 +24534,7 @@
         <p:spPr>
           <a:xfrm>
             <a:off x="6634804" y="2861935"/>
-            <a:ext cx="1572768" cy="1417320"/>
+            <a:ext cx="1572768" cy="2211012"/>
           </a:xfrm>
           <a:prstGeom prst="rect">
             <a:avLst/>
@@ -24267,18 +24592,18 @@
               <a:buNone/>
             </a:pPr>
             <a:r>
-              <a:rPr lang="en-US" sz="850" dirty="0">
+              <a:rPr lang="en-US" sz="1200" dirty="0">
                 <a:solidFill>
                   <a:srgbClr val="374151"/>
                 </a:solidFill>
-                <a:latin typeface="Roboto Slab" pitchFamily="2" charset="0"/>
+                <a:latin typeface="Aptos" panose="020B0004020202020204" pitchFamily="34" charset="0"/>
                 <a:ea typeface="Roboto Slab" pitchFamily="2" charset="0"/>
                 <a:cs typeface="Roboto Slab" pitchFamily="2" charset="0"/>
               </a:rPr>
               <a:t>Persist match analysis, question sets, evaluations, red flags; index verified outcomes; assemble the reviewer decision packet.</a:t>
             </a:r>
-            <a:endParaRPr lang="en-US" sz="850" dirty="0">
-              <a:latin typeface="Roboto Slab" pitchFamily="2" charset="0"/>
+            <a:endParaRPr lang="en-US" sz="1200" dirty="0">
+              <a:latin typeface="Aptos" panose="020B0004020202020204" pitchFamily="34" charset="0"/>
               <a:ea typeface="Roboto Slab" pitchFamily="2" charset="0"/>
               <a:cs typeface="Roboto Slab" pitchFamily="2" charset="0"/>
             </a:endParaRPr>
@@ -24449,18 +24774,18 @@
               <a:buNone/>
             </a:pPr>
             <a:r>
-              <a:rPr lang="en-US" sz="850" b="1" kern="0" spc="100" dirty="0">
+              <a:rPr lang="en-US" sz="1100" b="1" kern="0" spc="100" dirty="0">
                 <a:solidFill>
                   <a:srgbClr val="6D2E46"/>
                 </a:solidFill>
-                <a:latin typeface="Roboto Slab" pitchFamily="2" charset="0"/>
+                <a:latin typeface="Aptos" panose="020B0004020202020204" pitchFamily="34" charset="0"/>
                 <a:ea typeface="Roboto Slab" pitchFamily="2" charset="0"/>
                 <a:cs typeface="Roboto Slab" pitchFamily="2" charset="0"/>
               </a:rPr>
               <a:t>OBSERVE</a:t>
             </a:r>
-            <a:endParaRPr lang="en-US" sz="850" dirty="0">
-              <a:latin typeface="Roboto Slab" pitchFamily="2" charset="0"/>
+            <a:endParaRPr lang="en-US" sz="1100" dirty="0">
+              <a:latin typeface="Aptos" panose="020B0004020202020204" pitchFamily="34" charset="0"/>
               <a:ea typeface="Roboto Slab" pitchFamily="2" charset="0"/>
               <a:cs typeface="Roboto Slab" pitchFamily="2" charset="0"/>
             </a:endParaRPr>
@@ -24482,7 +24807,7 @@
         <p:spPr>
           <a:xfrm>
             <a:off x="8353876" y="2861935"/>
-            <a:ext cx="1572768" cy="1417320"/>
+            <a:ext cx="1572768" cy="2211012"/>
           </a:xfrm>
           <a:prstGeom prst="rect">
             <a:avLst/>
@@ -24540,18 +24865,18 @@
               <a:buNone/>
             </a:pPr>
             <a:r>
-              <a:rPr lang="en-US" sz="850" dirty="0">
+              <a:rPr lang="en-US" sz="1200" dirty="0">
                 <a:solidFill>
                   <a:srgbClr val="374151"/>
                 </a:solidFill>
-                <a:latin typeface="Roboto Slab" pitchFamily="2" charset="0"/>
+                <a:latin typeface="Aptos" panose="020B0004020202020204" pitchFamily="34" charset="0"/>
                 <a:ea typeface="Roboto Slab" pitchFamily="2" charset="0"/>
                 <a:cs typeface="Roboto Slab" pitchFamily="2" charset="0"/>
               </a:rPr>
               <a:t>Validators check every quote and case ID; reflexion retries failures; human review decides; overrides and verified gaps feed memory and RAG.</a:t>
             </a:r>
-            <a:endParaRPr lang="en-US" sz="850" dirty="0">
-              <a:latin typeface="Roboto Slab" pitchFamily="2" charset="0"/>
+            <a:endParaRPr lang="en-US" sz="1200" dirty="0">
+              <a:latin typeface="Aptos" panose="020B0004020202020204" pitchFamily="34" charset="0"/>
               <a:ea typeface="Roboto Slab" pitchFamily="2" charset="0"/>
               <a:cs typeface="Roboto Slab" pitchFamily="2" charset="0"/>
             </a:endParaRPr>
@@ -24627,8 +24952,7 @@
                 <a:solidFill>
                   <a:srgbClr val="4A4C55"/>
                 </a:solidFill>
-                <a:latin typeface="Roboto Slab" pitchFamily="2" charset="0"/>
-                <a:ea typeface="Roboto Slab" pitchFamily="2" charset="0"/>
+                <a:latin typeface="Aptos" panose="020B0004020202020204" pitchFamily="34" charset="0"/>
                 <a:cs typeface="Poppins" panose="00000500000000000000" pitchFamily="2" charset="0"/>
               </a:rPr>
               <a:t>Agentic Workflow</a:t>
@@ -24637,6 +24961,7 @@
               <a:solidFill>
                 <a:srgbClr val="4A4C55"/>
               </a:solidFill>
+              <a:latin typeface="Aptos" panose="020B0004020202020204" pitchFamily="34" charset="0"/>
             </a:endParaRPr>
           </a:p>
         </p:txBody>
@@ -24846,18 +25171,18 @@
               <a:buNone/>
             </a:pPr>
             <a:r>
-              <a:rPr lang="en-US" sz="1000" b="1" dirty="0">
+              <a:rPr lang="en-US" sz="1100" b="1" dirty="0">
                 <a:solidFill>
                   <a:srgbClr val="FFFFFF"/>
                 </a:solidFill>
-                <a:latin typeface="Roboto Slab" pitchFamily="2" charset="0"/>
+                <a:latin typeface="Aptos" panose="020B0004020202020204" pitchFamily="34" charset="0"/>
                 <a:ea typeface="Roboto Slab" pitchFamily="2" charset="0"/>
                 <a:cs typeface="Roboto Slab" pitchFamily="2" charset="0"/>
               </a:rPr>
               <a:t>SENSE</a:t>
             </a:r>
-            <a:endParaRPr lang="en-US" sz="1000" dirty="0">
-              <a:latin typeface="Roboto Slab" pitchFamily="2" charset="0"/>
+            <a:endParaRPr lang="en-US" sz="1100" dirty="0">
+              <a:latin typeface="Aptos" panose="020B0004020202020204" pitchFamily="34" charset="0"/>
               <a:ea typeface="Roboto Slab" pitchFamily="2" charset="0"/>
               <a:cs typeface="Roboto Slab" pitchFamily="2" charset="0"/>
             </a:endParaRPr>
@@ -24879,7 +25204,7 @@
         <p:spPr>
           <a:xfrm>
             <a:off x="1449692" y="2142308"/>
-            <a:ext cx="1965960" cy="1188720"/>
+            <a:ext cx="1965960" cy="1802163"/>
           </a:xfrm>
           <a:prstGeom prst="rect">
             <a:avLst/>
@@ -24944,18 +25269,18 @@
               <a:buNone/>
             </a:pPr>
             <a:r>
-              <a:rPr lang="en-US" sz="950" dirty="0">
+              <a:rPr lang="en-US" sz="1200" dirty="0">
                 <a:solidFill>
                   <a:srgbClr val="374151"/>
                 </a:solidFill>
-                <a:latin typeface="Roboto Slab" pitchFamily="2" charset="0"/>
+                <a:latin typeface="Aptos" panose="020B0004020202020204" pitchFamily="34" charset="0"/>
                 <a:ea typeface="Roboto Slab" pitchFamily="2" charset="0"/>
                 <a:cs typeface="Roboto Slab" pitchFamily="2" charset="0"/>
               </a:rPr>
               <a:t>JD, resume, and transcript uploads; deterministic parsing, PII redaction, and privacy-filtered vector indexing.</a:t>
             </a:r>
-            <a:endParaRPr lang="en-US" sz="950" dirty="0">
-              <a:latin typeface="Roboto Slab" pitchFamily="2" charset="0"/>
+            <a:endParaRPr lang="en-US" sz="1200" dirty="0">
+              <a:latin typeface="Aptos" panose="020B0004020202020204" pitchFamily="34" charset="0"/>
               <a:ea typeface="Roboto Slab" pitchFamily="2" charset="0"/>
               <a:cs typeface="Roboto Slab" pitchFamily="2" charset="0"/>
             </a:endParaRPr>
@@ -25077,18 +25402,18 @@
               <a:buNone/>
             </a:pPr>
             <a:r>
-              <a:rPr lang="en-US" sz="1000" b="1" dirty="0">
+              <a:rPr lang="en-US" sz="1100" b="1" dirty="0">
                 <a:solidFill>
                   <a:srgbClr val="FFFFFF"/>
                 </a:solidFill>
-                <a:latin typeface="Roboto Slab" pitchFamily="2" charset="0"/>
+                <a:latin typeface="Aptos" panose="020B0004020202020204" pitchFamily="34" charset="0"/>
                 <a:ea typeface="Roboto Slab" pitchFamily="2" charset="0"/>
                 <a:cs typeface="Roboto Slab" pitchFamily="2" charset="0"/>
               </a:rPr>
               <a:t>REASON &amp; PLAN</a:t>
             </a:r>
-            <a:endParaRPr lang="en-US" sz="1000" dirty="0">
-              <a:latin typeface="Roboto Slab" pitchFamily="2" charset="0"/>
+            <a:endParaRPr lang="en-US" sz="1100" dirty="0">
+              <a:latin typeface="Aptos" panose="020B0004020202020204" pitchFamily="34" charset="0"/>
               <a:ea typeface="Roboto Slab" pitchFamily="2" charset="0"/>
               <a:cs typeface="Roboto Slab" pitchFamily="2" charset="0"/>
             </a:endParaRPr>
@@ -25110,7 +25435,7 @@
         <p:spPr>
           <a:xfrm>
             <a:off x="3571100" y="2142308"/>
-            <a:ext cx="1965960" cy="1188720"/>
+            <a:ext cx="1965960" cy="1802163"/>
           </a:xfrm>
           <a:prstGeom prst="rect">
             <a:avLst/>
@@ -25175,18 +25500,18 @@
               <a:buNone/>
             </a:pPr>
             <a:r>
-              <a:rPr lang="en-US" sz="950" dirty="0">
+              <a:rPr lang="en-US" sz="1200" dirty="0">
                 <a:solidFill>
                   <a:srgbClr val="374151"/>
                 </a:solidFill>
-                <a:latin typeface="Roboto Slab" pitchFamily="2" charset="0"/>
+                <a:latin typeface="Aptos" panose="020B0004020202020204" pitchFamily="34" charset="0"/>
                 <a:ea typeface="Roboto Slab" pitchFamily="2" charset="0"/>
                 <a:cs typeface="Roboto Slab" pitchFamily="2" charset="0"/>
               </a:rPr>
               <a:t>Supervisor picks minimal/standard/deep depth; a retrieval planner resolves intent into semantic queries; agents reason over deduplicated cases.</a:t>
             </a:r>
-            <a:endParaRPr lang="en-US" sz="950" dirty="0">
-              <a:latin typeface="Roboto Slab" pitchFamily="2" charset="0"/>
+            <a:endParaRPr lang="en-US" sz="1200" dirty="0">
+              <a:latin typeface="Aptos" panose="020B0004020202020204" pitchFamily="34" charset="0"/>
               <a:ea typeface="Roboto Slab" pitchFamily="2" charset="0"/>
               <a:cs typeface="Roboto Slab" pitchFamily="2" charset="0"/>
             </a:endParaRPr>
@@ -25308,18 +25633,18 @@
               <a:buNone/>
             </a:pPr>
             <a:r>
-              <a:rPr lang="en-US" sz="1000" b="1" dirty="0">
+              <a:rPr lang="en-US" sz="1100" b="1" dirty="0">
                 <a:solidFill>
                   <a:srgbClr val="FFFFFF"/>
                 </a:solidFill>
-                <a:latin typeface="Roboto Slab" pitchFamily="2" charset="0"/>
+                <a:latin typeface="Aptos" panose="020B0004020202020204" pitchFamily="34" charset="0"/>
                 <a:ea typeface="Roboto Slab" pitchFamily="2" charset="0"/>
                 <a:cs typeface="Roboto Slab" pitchFamily="2" charset="0"/>
               </a:rPr>
               <a:t>ACT</a:t>
             </a:r>
-            <a:endParaRPr lang="en-US" sz="1000" dirty="0">
-              <a:latin typeface="Roboto Slab" pitchFamily="2" charset="0"/>
+            <a:endParaRPr lang="en-US" sz="1100" dirty="0">
+              <a:latin typeface="Aptos" panose="020B0004020202020204" pitchFamily="34" charset="0"/>
               <a:ea typeface="Roboto Slab" pitchFamily="2" charset="0"/>
               <a:cs typeface="Roboto Slab" pitchFamily="2" charset="0"/>
             </a:endParaRPr>
@@ -25341,7 +25666,7 @@
         <p:spPr>
           <a:xfrm>
             <a:off x="5692508" y="2142308"/>
-            <a:ext cx="1965960" cy="1188720"/>
+            <a:ext cx="1965960" cy="1802163"/>
           </a:xfrm>
           <a:prstGeom prst="rect">
             <a:avLst/>
@@ -25406,18 +25731,18 @@
               <a:buNone/>
             </a:pPr>
             <a:r>
-              <a:rPr lang="en-US" sz="950" dirty="0">
+              <a:rPr lang="en-US" sz="1200" dirty="0">
                 <a:solidFill>
                   <a:srgbClr val="374151"/>
                 </a:solidFill>
-                <a:latin typeface="Roboto Slab" pitchFamily="2" charset="0"/>
+                <a:latin typeface="Aptos" panose="020B0004020202020204" pitchFamily="34" charset="0"/>
                 <a:ea typeface="Roboto Slab" pitchFamily="2" charset="0"/>
                 <a:cs typeface="Roboto Slab" pitchFamily="2" charset="0"/>
               </a:rPr>
               <a:t>Agents write match analyses, question sets, transcript evaluations, red flags, and decision packets to Postgres; verified results index back into pgvector.</a:t>
             </a:r>
-            <a:endParaRPr lang="en-US" sz="950" dirty="0">
-              <a:latin typeface="Roboto Slab" pitchFamily="2" charset="0"/>
+            <a:endParaRPr lang="en-US" sz="1200" dirty="0">
+              <a:latin typeface="Aptos" panose="020B0004020202020204" pitchFamily="34" charset="0"/>
               <a:ea typeface="Roboto Slab" pitchFamily="2" charset="0"/>
               <a:cs typeface="Roboto Slab" pitchFamily="2" charset="0"/>
             </a:endParaRPr>
@@ -25539,18 +25864,18 @@
               <a:buNone/>
             </a:pPr>
             <a:r>
-              <a:rPr lang="en-US" sz="1000" b="1" dirty="0">
+              <a:rPr lang="en-US" sz="1100" b="1" dirty="0">
                 <a:solidFill>
                   <a:srgbClr val="FFFFFF"/>
                 </a:solidFill>
-                <a:latin typeface="Roboto Slab" pitchFamily="2" charset="0"/>
+                <a:latin typeface="Aptos" panose="020B0004020202020204" pitchFamily="34" charset="0"/>
                 <a:ea typeface="Roboto Slab" pitchFamily="2" charset="0"/>
                 <a:cs typeface="Roboto Slab" pitchFamily="2" charset="0"/>
               </a:rPr>
               <a:t>OBSERVE &amp; REFLECT</a:t>
             </a:r>
-            <a:endParaRPr lang="en-US" sz="1000" dirty="0">
-              <a:latin typeface="Roboto Slab" pitchFamily="2" charset="0"/>
+            <a:endParaRPr lang="en-US" sz="1100" dirty="0">
+              <a:latin typeface="Aptos" panose="020B0004020202020204" pitchFamily="34" charset="0"/>
               <a:ea typeface="Roboto Slab" pitchFamily="2" charset="0"/>
               <a:cs typeface="Roboto Slab" pitchFamily="2" charset="0"/>
             </a:endParaRPr>
@@ -25572,7 +25897,7 @@
         <p:spPr>
           <a:xfrm>
             <a:off x="7813916" y="2142308"/>
-            <a:ext cx="1965960" cy="1188720"/>
+            <a:ext cx="1965960" cy="1802163"/>
           </a:xfrm>
           <a:prstGeom prst="rect">
             <a:avLst/>
@@ -25637,18 +25962,18 @@
               <a:buNone/>
             </a:pPr>
             <a:r>
-              <a:rPr lang="en-US" sz="950" dirty="0">
+              <a:rPr lang="en-US" sz="1200" dirty="0">
                 <a:solidFill>
                   <a:srgbClr val="374151"/>
                 </a:solidFill>
-                <a:latin typeface="Roboto Slab" pitchFamily="2" charset="0"/>
+                <a:latin typeface="Aptos" panose="020B0004020202020204" pitchFamily="34" charset="0"/>
                 <a:ea typeface="Roboto Slab" pitchFamily="2" charset="0"/>
                 <a:cs typeface="Roboto Slab" pitchFamily="2" charset="0"/>
               </a:rPr>
               <a:t>Mechanical validators verify quotes and case IDs; reflexion retries invalid output; humans approve decisions; feedback becomes calibration memory.</a:t>
             </a:r>
-            <a:endParaRPr lang="en-US" sz="950" dirty="0">
-              <a:latin typeface="Roboto Slab" pitchFamily="2" charset="0"/>
+            <a:endParaRPr lang="en-US" sz="1200" dirty="0">
+              <a:latin typeface="Aptos" panose="020B0004020202020204" pitchFamily="34" charset="0"/>
               <a:ea typeface="Roboto Slab" pitchFamily="2" charset="0"/>
               <a:cs typeface="Roboto Slab" pitchFamily="2" charset="0"/>
             </a:endParaRPr>
@@ -25669,8 +25994,8 @@
         </p:nvSpPr>
         <p:spPr>
           <a:xfrm>
-            <a:off x="1294244" y="4255219"/>
-            <a:ext cx="1828800" cy="256032"/>
+            <a:off x="519332" y="5133763"/>
+            <a:ext cx="2708584" cy="256032"/>
           </a:xfrm>
           <a:prstGeom prst="rect">
             <a:avLst/>
@@ -25686,18 +26011,18 @@
               <a:buNone/>
             </a:pPr>
             <a:r>
-              <a:rPr lang="en-US" sz="950" b="1" dirty="0">
+              <a:rPr lang="en-US" sz="1600" b="1" dirty="0">
                 <a:solidFill>
                   <a:srgbClr val="1A2B5E"/>
                 </a:solidFill>
-                <a:latin typeface="Roboto Slab" pitchFamily="2" charset="0"/>
+                <a:latin typeface="Aptos" panose="020B0004020202020204" pitchFamily="34" charset="0"/>
                 <a:ea typeface="Roboto Slab" pitchFamily="2" charset="0"/>
                 <a:cs typeface="Roboto Slab" pitchFamily="2" charset="0"/>
               </a:rPr>
               <a:t>Agentic Techniques Used:</a:t>
             </a:r>
-            <a:endParaRPr lang="en-US" sz="950" dirty="0">
-              <a:latin typeface="Roboto Slab" pitchFamily="2" charset="0"/>
+            <a:endParaRPr lang="en-US" sz="1600" dirty="0">
+              <a:latin typeface="Aptos" panose="020B0004020202020204" pitchFamily="34" charset="0"/>
               <a:ea typeface="Roboto Slab" pitchFamily="2" charset="0"/>
               <a:cs typeface="Roboto Slab" pitchFamily="2" charset="0"/>
             </a:endParaRPr>
@@ -25718,8 +26043,8 @@
         </p:nvSpPr>
         <p:spPr>
           <a:xfrm>
-            <a:off x="3214484" y="4236931"/>
-            <a:ext cx="777240" cy="274320"/>
+            <a:off x="3135081" y="5115475"/>
+            <a:ext cx="951362" cy="274320"/>
           </a:xfrm>
           <a:prstGeom prst="roundRect">
             <a:avLst>
@@ -25740,8 +26065,8 @@
           <a:bodyPr/>
           <a:lstStyle/>
           <a:p>
-            <a:endParaRPr lang="en-US">
-              <a:latin typeface="Roboto Slab" pitchFamily="2" charset="0"/>
+            <a:endParaRPr lang="en-US" sz="4000">
+              <a:latin typeface="Aptos" panose="020B0004020202020204" pitchFamily="34" charset="0"/>
               <a:ea typeface="Roboto Slab" pitchFamily="2" charset="0"/>
               <a:cs typeface="Roboto Slab" pitchFamily="2" charset="0"/>
             </a:endParaRPr>
@@ -25762,8 +26087,8 @@
         </p:nvSpPr>
         <p:spPr>
           <a:xfrm>
-            <a:off x="3214484" y="4236931"/>
-            <a:ext cx="777240" cy="274320"/>
+            <a:off x="3135081" y="5115475"/>
+            <a:ext cx="951362" cy="274320"/>
           </a:xfrm>
           <a:prstGeom prst="rect">
             <a:avLst/>
@@ -25779,18 +26104,18 @@
               <a:buNone/>
             </a:pPr>
             <a:r>
-              <a:rPr lang="en-US" sz="750" dirty="0">
+              <a:rPr lang="en-US" sz="1200" dirty="0">
                 <a:solidFill>
                   <a:srgbClr val="1A2B5E"/>
                 </a:solidFill>
-                <a:latin typeface="Roboto Slab" pitchFamily="2" charset="0"/>
+                <a:latin typeface="Aptos" panose="020B0004020202020204" pitchFamily="34" charset="0"/>
                 <a:ea typeface="Roboto Slab" pitchFamily="2" charset="0"/>
                 <a:cs typeface="Roboto Slab" pitchFamily="2" charset="0"/>
               </a:rPr>
               <a:t>LLM Agent</a:t>
             </a:r>
-            <a:endParaRPr lang="en-US" sz="750" dirty="0">
-              <a:latin typeface="Roboto Slab" pitchFamily="2" charset="0"/>
+            <a:endParaRPr lang="en-US" sz="1200" dirty="0">
+              <a:latin typeface="Aptos" panose="020B0004020202020204" pitchFamily="34" charset="0"/>
               <a:ea typeface="Roboto Slab" pitchFamily="2" charset="0"/>
               <a:cs typeface="Roboto Slab" pitchFamily="2" charset="0"/>
             </a:endParaRPr>
@@ -25811,8 +26136,8 @@
         </p:nvSpPr>
         <p:spPr>
           <a:xfrm>
-            <a:off x="4064876" y="4236931"/>
-            <a:ext cx="777240" cy="274320"/>
+            <a:off x="4173734" y="5115475"/>
+            <a:ext cx="951362" cy="274320"/>
           </a:xfrm>
           <a:prstGeom prst="roundRect">
             <a:avLst>
@@ -25833,8 +26158,8 @@
           <a:bodyPr/>
           <a:lstStyle/>
           <a:p>
-            <a:endParaRPr lang="en-US">
-              <a:latin typeface="Roboto Slab" pitchFamily="2" charset="0"/>
+            <a:endParaRPr lang="en-US" sz="4000">
+              <a:latin typeface="Aptos" panose="020B0004020202020204" pitchFamily="34" charset="0"/>
               <a:ea typeface="Roboto Slab" pitchFamily="2" charset="0"/>
               <a:cs typeface="Roboto Slab" pitchFamily="2" charset="0"/>
             </a:endParaRPr>
@@ -25855,8 +26180,8 @@
         </p:nvSpPr>
         <p:spPr>
           <a:xfrm>
-            <a:off x="4064876" y="4236931"/>
-            <a:ext cx="777240" cy="274320"/>
+            <a:off x="4173734" y="5115475"/>
+            <a:ext cx="951362" cy="274320"/>
           </a:xfrm>
           <a:prstGeom prst="rect">
             <a:avLst/>
@@ -25872,18 +26197,18 @@
               <a:buNone/>
             </a:pPr>
             <a:r>
-              <a:rPr lang="en-US" sz="750" dirty="0">
+              <a:rPr lang="en-US" sz="1200" dirty="0">
                 <a:solidFill>
                   <a:srgbClr val="1A2B5E"/>
                 </a:solidFill>
-                <a:latin typeface="Roboto Slab" pitchFamily="2" charset="0"/>
+                <a:latin typeface="Aptos" panose="020B0004020202020204" pitchFamily="34" charset="0"/>
                 <a:ea typeface="Roboto Slab" pitchFamily="2" charset="0"/>
                 <a:cs typeface="Roboto Slab" pitchFamily="2" charset="0"/>
               </a:rPr>
               <a:t>Tool Calling</a:t>
             </a:r>
-            <a:endParaRPr lang="en-US" sz="750" dirty="0">
-              <a:latin typeface="Roboto Slab" pitchFamily="2" charset="0"/>
+            <a:endParaRPr lang="en-US" sz="1200" dirty="0">
+              <a:latin typeface="Aptos" panose="020B0004020202020204" pitchFamily="34" charset="0"/>
               <a:ea typeface="Roboto Slab" pitchFamily="2" charset="0"/>
               <a:cs typeface="Roboto Slab" pitchFamily="2" charset="0"/>
             </a:endParaRPr>
@@ -25904,8 +26229,8 @@
         </p:nvSpPr>
         <p:spPr>
           <a:xfrm>
-            <a:off x="4915268" y="4236931"/>
-            <a:ext cx="777240" cy="274320"/>
+            <a:off x="5214259" y="5115475"/>
+            <a:ext cx="786250" cy="274320"/>
           </a:xfrm>
           <a:prstGeom prst="roundRect">
             <a:avLst>
@@ -25926,8 +26251,8 @@
           <a:bodyPr/>
           <a:lstStyle/>
           <a:p>
-            <a:endParaRPr lang="en-US">
-              <a:latin typeface="Roboto Slab" pitchFamily="2" charset="0"/>
+            <a:endParaRPr lang="en-US" sz="4000">
+              <a:latin typeface="Aptos" panose="020B0004020202020204" pitchFamily="34" charset="0"/>
               <a:ea typeface="Roboto Slab" pitchFamily="2" charset="0"/>
               <a:cs typeface="Roboto Slab" pitchFamily="2" charset="0"/>
             </a:endParaRPr>
@@ -25948,8 +26273,8 @@
         </p:nvSpPr>
         <p:spPr>
           <a:xfrm>
-            <a:off x="4915268" y="4236931"/>
-            <a:ext cx="777240" cy="274320"/>
+            <a:off x="5214259" y="5115475"/>
+            <a:ext cx="786250" cy="274320"/>
           </a:xfrm>
           <a:prstGeom prst="rect">
             <a:avLst/>
@@ -25965,18 +26290,18 @@
               <a:buNone/>
             </a:pPr>
             <a:r>
-              <a:rPr lang="en-US" sz="750" dirty="0">
+              <a:rPr lang="en-US" sz="1200" dirty="0">
                 <a:solidFill>
                   <a:srgbClr val="1A2B5E"/>
                 </a:solidFill>
-                <a:latin typeface="Roboto Slab" pitchFamily="2" charset="0"/>
+                <a:latin typeface="Aptos" panose="020B0004020202020204" pitchFamily="34" charset="0"/>
                 <a:ea typeface="Roboto Slab" pitchFamily="2" charset="0"/>
                 <a:cs typeface="Roboto Slab" pitchFamily="2" charset="0"/>
               </a:rPr>
               <a:t>RAG</a:t>
             </a:r>
-            <a:endParaRPr lang="en-US" sz="750" dirty="0">
-              <a:latin typeface="Roboto Slab" pitchFamily="2" charset="0"/>
+            <a:endParaRPr lang="en-US" sz="1200" dirty="0">
+              <a:latin typeface="Aptos" panose="020B0004020202020204" pitchFamily="34" charset="0"/>
               <a:ea typeface="Roboto Slab" pitchFamily="2" charset="0"/>
               <a:cs typeface="Roboto Slab" pitchFamily="2" charset="0"/>
             </a:endParaRPr>
@@ -25997,8 +26322,8 @@
         </p:nvSpPr>
         <p:spPr>
           <a:xfrm>
-            <a:off x="5765660" y="4236931"/>
-            <a:ext cx="777240" cy="274320"/>
+            <a:off x="6088389" y="5115475"/>
+            <a:ext cx="1151148" cy="274320"/>
           </a:xfrm>
           <a:prstGeom prst="roundRect">
             <a:avLst>
@@ -26019,8 +26344,8 @@
           <a:bodyPr/>
           <a:lstStyle/>
           <a:p>
-            <a:endParaRPr lang="en-US">
-              <a:latin typeface="Roboto Slab" pitchFamily="2" charset="0"/>
+            <a:endParaRPr lang="en-US" sz="4000">
+              <a:latin typeface="Aptos" panose="020B0004020202020204" pitchFamily="34" charset="0"/>
               <a:ea typeface="Roboto Slab" pitchFamily="2" charset="0"/>
               <a:cs typeface="Roboto Slab" pitchFamily="2" charset="0"/>
             </a:endParaRPr>
@@ -26041,8 +26366,8 @@
         </p:nvSpPr>
         <p:spPr>
           <a:xfrm>
-            <a:off x="5765660" y="4236931"/>
-            <a:ext cx="777240" cy="274320"/>
+            <a:off x="6088389" y="5115475"/>
+            <a:ext cx="1151148" cy="274320"/>
           </a:xfrm>
           <a:prstGeom prst="rect">
             <a:avLst/>
@@ -26058,18 +26383,18 @@
               <a:buNone/>
             </a:pPr>
             <a:r>
-              <a:rPr lang="en-US" sz="750" dirty="0">
+              <a:rPr lang="en-US" sz="1200" dirty="0">
                 <a:solidFill>
                   <a:srgbClr val="1A2B5E"/>
                 </a:solidFill>
-                <a:latin typeface="Roboto Slab" pitchFamily="2" charset="0"/>
+                <a:latin typeface="Aptos" panose="020B0004020202020204" pitchFamily="34" charset="0"/>
                 <a:ea typeface="Roboto Slab" pitchFamily="2" charset="0"/>
                 <a:cs typeface="Roboto Slab" pitchFamily="2" charset="0"/>
               </a:rPr>
               <a:t>Multi-Agent</a:t>
             </a:r>
-            <a:endParaRPr lang="en-US" sz="750" dirty="0">
-              <a:latin typeface="Roboto Slab" pitchFamily="2" charset="0"/>
+            <a:endParaRPr lang="en-US" sz="1200" dirty="0">
+              <a:latin typeface="Aptos" panose="020B0004020202020204" pitchFamily="34" charset="0"/>
               <a:ea typeface="Roboto Slab" pitchFamily="2" charset="0"/>
               <a:cs typeface="Roboto Slab" pitchFamily="2" charset="0"/>
             </a:endParaRPr>
@@ -26090,8 +26415,8 @@
         </p:nvSpPr>
         <p:spPr>
           <a:xfrm>
-            <a:off x="6616052" y="4236931"/>
-            <a:ext cx="777240" cy="274320"/>
+            <a:off x="7343480" y="5115475"/>
+            <a:ext cx="951362" cy="274320"/>
           </a:xfrm>
           <a:prstGeom prst="roundRect">
             <a:avLst>
@@ -26112,8 +26437,8 @@
           <a:bodyPr/>
           <a:lstStyle/>
           <a:p>
-            <a:endParaRPr lang="en-US">
-              <a:latin typeface="Roboto Slab" pitchFamily="2" charset="0"/>
+            <a:endParaRPr lang="en-US" sz="4000">
+              <a:latin typeface="Aptos" panose="020B0004020202020204" pitchFamily="34" charset="0"/>
               <a:ea typeface="Roboto Slab" pitchFamily="2" charset="0"/>
               <a:cs typeface="Roboto Slab" pitchFamily="2" charset="0"/>
             </a:endParaRPr>
@@ -26134,8 +26459,8 @@
         </p:nvSpPr>
         <p:spPr>
           <a:xfrm>
-            <a:off x="6616052" y="4236931"/>
-            <a:ext cx="777240" cy="274320"/>
+            <a:off x="7343480" y="5115475"/>
+            <a:ext cx="951362" cy="274320"/>
           </a:xfrm>
           <a:prstGeom prst="rect">
             <a:avLst/>
@@ -26151,18 +26476,18 @@
               <a:buNone/>
             </a:pPr>
             <a:r>
-              <a:rPr lang="en-US" sz="750" dirty="0">
+              <a:rPr lang="en-US" sz="1200" dirty="0">
                 <a:solidFill>
                   <a:srgbClr val="1A2B5E"/>
                 </a:solidFill>
-                <a:latin typeface="Roboto Slab" pitchFamily="2" charset="0"/>
+                <a:latin typeface="Aptos" panose="020B0004020202020204" pitchFamily="34" charset="0"/>
                 <a:ea typeface="Roboto Slab" pitchFamily="2" charset="0"/>
                 <a:cs typeface="Roboto Slab" pitchFamily="2" charset="0"/>
               </a:rPr>
               <a:t>Planning</a:t>
             </a:r>
-            <a:endParaRPr lang="en-US" sz="750" dirty="0">
-              <a:latin typeface="Roboto Slab" pitchFamily="2" charset="0"/>
+            <a:endParaRPr lang="en-US" sz="1200" dirty="0">
+              <a:latin typeface="Aptos" panose="020B0004020202020204" pitchFamily="34" charset="0"/>
               <a:ea typeface="Roboto Slab" pitchFamily="2" charset="0"/>
               <a:cs typeface="Roboto Slab" pitchFamily="2" charset="0"/>
             </a:endParaRPr>
@@ -26183,8 +26508,8 @@
         </p:nvSpPr>
         <p:spPr>
           <a:xfrm>
-            <a:off x="7466444" y="4236931"/>
-            <a:ext cx="777240" cy="274320"/>
+            <a:off x="8382128" y="5115475"/>
+            <a:ext cx="951362" cy="274320"/>
           </a:xfrm>
           <a:prstGeom prst="roundRect">
             <a:avLst>
@@ -26205,8 +26530,8 @@
           <a:bodyPr/>
           <a:lstStyle/>
           <a:p>
-            <a:endParaRPr lang="en-US">
-              <a:latin typeface="Roboto Slab" pitchFamily="2" charset="0"/>
+            <a:endParaRPr lang="en-US" sz="4000">
+              <a:latin typeface="Aptos" panose="020B0004020202020204" pitchFamily="34" charset="0"/>
               <a:ea typeface="Roboto Slab" pitchFamily="2" charset="0"/>
               <a:cs typeface="Roboto Slab" pitchFamily="2" charset="0"/>
             </a:endParaRPr>
@@ -26227,8 +26552,8 @@
         </p:nvSpPr>
         <p:spPr>
           <a:xfrm>
-            <a:off x="7466444" y="4236931"/>
-            <a:ext cx="777240" cy="274320"/>
+            <a:off x="8382128" y="5115475"/>
+            <a:ext cx="951362" cy="274320"/>
           </a:xfrm>
           <a:prstGeom prst="rect">
             <a:avLst/>
@@ -26244,18 +26569,18 @@
               <a:buNone/>
             </a:pPr>
             <a:r>
-              <a:rPr lang="en-US" sz="750" dirty="0">
+              <a:rPr lang="en-US" sz="1200" dirty="0">
                 <a:solidFill>
                   <a:srgbClr val="1A2B5E"/>
                 </a:solidFill>
-                <a:latin typeface="Roboto Slab" pitchFamily="2" charset="0"/>
+                <a:latin typeface="Aptos" panose="020B0004020202020204" pitchFamily="34" charset="0"/>
                 <a:ea typeface="Roboto Slab" pitchFamily="2" charset="0"/>
                 <a:cs typeface="Roboto Slab" pitchFamily="2" charset="0"/>
               </a:rPr>
               <a:t>Memory</a:t>
             </a:r>
-            <a:endParaRPr lang="en-US" sz="750" dirty="0">
-              <a:latin typeface="Roboto Slab" pitchFamily="2" charset="0"/>
+            <a:endParaRPr lang="en-US" sz="1200" dirty="0">
+              <a:latin typeface="Aptos" panose="020B0004020202020204" pitchFamily="34" charset="0"/>
               <a:ea typeface="Roboto Slab" pitchFamily="2" charset="0"/>
               <a:cs typeface="Roboto Slab" pitchFamily="2" charset="0"/>
             </a:endParaRPr>
@@ -26276,8 +26601,8 @@
         </p:nvSpPr>
         <p:spPr>
           <a:xfrm>
-            <a:off x="8316836" y="4236931"/>
-            <a:ext cx="777240" cy="274320"/>
+            <a:off x="9422652" y="5115475"/>
+            <a:ext cx="786250" cy="274320"/>
           </a:xfrm>
           <a:prstGeom prst="roundRect">
             <a:avLst>
@@ -26298,8 +26623,8 @@
           <a:bodyPr/>
           <a:lstStyle/>
           <a:p>
-            <a:endParaRPr lang="en-US">
-              <a:latin typeface="Roboto Slab" pitchFamily="2" charset="0"/>
+            <a:endParaRPr lang="en-US" sz="4000">
+              <a:latin typeface="Aptos" panose="020B0004020202020204" pitchFamily="34" charset="0"/>
               <a:ea typeface="Roboto Slab" pitchFamily="2" charset="0"/>
               <a:cs typeface="Roboto Slab" pitchFamily="2" charset="0"/>
             </a:endParaRPr>
@@ -26320,8 +26645,8 @@
         </p:nvSpPr>
         <p:spPr>
           <a:xfrm>
-            <a:off x="8316836" y="4236931"/>
-            <a:ext cx="777240" cy="274320"/>
+            <a:off x="9422652" y="5115475"/>
+            <a:ext cx="786250" cy="274320"/>
           </a:xfrm>
           <a:prstGeom prst="rect">
             <a:avLst/>
@@ -26337,18 +26662,18 @@
               <a:buNone/>
             </a:pPr>
             <a:r>
-              <a:rPr lang="en-US" sz="750" dirty="0">
+              <a:rPr lang="en-US" sz="1200" dirty="0">
                 <a:solidFill>
                   <a:srgbClr val="1A2B5E"/>
                 </a:solidFill>
-                <a:latin typeface="Roboto Slab" pitchFamily="2" charset="0"/>
+                <a:latin typeface="Aptos" panose="020B0004020202020204" pitchFamily="34" charset="0"/>
                 <a:ea typeface="Roboto Slab" pitchFamily="2" charset="0"/>
                 <a:cs typeface="Roboto Slab" pitchFamily="2" charset="0"/>
               </a:rPr>
               <a:t>HITL</a:t>
             </a:r>
-            <a:endParaRPr lang="en-US" sz="750" dirty="0">
-              <a:latin typeface="Roboto Slab" pitchFamily="2" charset="0"/>
+            <a:endParaRPr lang="en-US" sz="1200" dirty="0">
+              <a:latin typeface="Aptos" panose="020B0004020202020204" pitchFamily="34" charset="0"/>
               <a:ea typeface="Roboto Slab" pitchFamily="2" charset="0"/>
               <a:cs typeface="Roboto Slab" pitchFamily="2" charset="0"/>
             </a:endParaRPr>
@@ -26369,8 +26694,8 @@
         </p:nvSpPr>
         <p:spPr>
           <a:xfrm>
-            <a:off x="9167228" y="4236931"/>
-            <a:ext cx="777240" cy="274320"/>
+            <a:off x="10317865" y="5115475"/>
+            <a:ext cx="786250" cy="274320"/>
           </a:xfrm>
           <a:prstGeom prst="roundRect">
             <a:avLst>
@@ -26391,8 +26716,8 @@
           <a:bodyPr/>
           <a:lstStyle/>
           <a:p>
-            <a:endParaRPr lang="en-US">
-              <a:latin typeface="Roboto Slab" pitchFamily="2" charset="0"/>
+            <a:endParaRPr lang="en-US" sz="4000">
+              <a:latin typeface="Aptos" panose="020B0004020202020204" pitchFamily="34" charset="0"/>
               <a:ea typeface="Roboto Slab" pitchFamily="2" charset="0"/>
               <a:cs typeface="Roboto Slab" pitchFamily="2" charset="0"/>
             </a:endParaRPr>
@@ -26413,8 +26738,8 @@
         </p:nvSpPr>
         <p:spPr>
           <a:xfrm>
-            <a:off x="9167228" y="4236931"/>
-            <a:ext cx="777240" cy="274320"/>
+            <a:off x="10317865" y="5115475"/>
+            <a:ext cx="786250" cy="274320"/>
           </a:xfrm>
           <a:prstGeom prst="rect">
             <a:avLst/>
@@ -26430,18 +26755,18 @@
               <a:buNone/>
             </a:pPr>
             <a:r>
-              <a:rPr lang="en-US" sz="750" dirty="0">
+              <a:rPr lang="en-US" sz="1200" dirty="0">
                 <a:solidFill>
                   <a:srgbClr val="B0B0B0"/>
                 </a:solidFill>
-                <a:latin typeface="Roboto Slab" pitchFamily="2" charset="0"/>
+                <a:latin typeface="Aptos" panose="020B0004020202020204" pitchFamily="34" charset="0"/>
                 <a:ea typeface="Roboto Slab" pitchFamily="2" charset="0"/>
                 <a:cs typeface="Roboto Slab" pitchFamily="2" charset="0"/>
               </a:rPr>
               <a:t>RL</a:t>
             </a:r>
-            <a:endParaRPr lang="en-US" sz="750" dirty="0">
-              <a:latin typeface="Roboto Slab" pitchFamily="2" charset="0"/>
+            <a:endParaRPr lang="en-US" sz="1200" dirty="0">
+              <a:latin typeface="Aptos" panose="020B0004020202020204" pitchFamily="34" charset="0"/>
               <a:ea typeface="Roboto Slab" pitchFamily="2" charset="0"/>
               <a:cs typeface="Roboto Slab" pitchFamily="2" charset="0"/>
             </a:endParaRPr>
@@ -26517,8 +26842,7 @@
                 <a:solidFill>
                   <a:srgbClr val="4A4C55"/>
                 </a:solidFill>
-                <a:latin typeface="Roboto Slab" pitchFamily="2" charset="0"/>
-                <a:ea typeface="Roboto Slab" pitchFamily="2" charset="0"/>
+                <a:latin typeface="Aptos" panose="020B0004020202020204" pitchFamily="34" charset="0"/>
                 <a:cs typeface="Poppins" panose="00000500000000000000" pitchFamily="2" charset="0"/>
               </a:rPr>
               <a:t>Implementation and Demo</a:t>
@@ -26527,6 +26851,7 @@
               <a:solidFill>
                 <a:srgbClr val="4A4C55"/>
               </a:solidFill>
+              <a:latin typeface="Aptos" panose="020B0004020202020204" pitchFamily="34" charset="0"/>
             </a:endParaRPr>
           </a:p>
         </p:txBody>
@@ -26701,7 +27026,7 @@
                 <a:solidFill>
                   <a:srgbClr val="4A4C55"/>
                 </a:solidFill>
-                <a:latin typeface="Roboto Slab" pitchFamily="2" charset="0"/>
+                <a:latin typeface="Aptos" panose="020B0004020202020204" pitchFamily="34" charset="0"/>
                 <a:ea typeface="Roboto Slab" pitchFamily="2" charset="0"/>
                 <a:cs typeface="Poppins" panose="00000500000000000000" pitchFamily="2" charset="0"/>
               </a:rPr>
@@ -26719,7 +27044,7 @@
         <p:spPr>
           <a:xfrm>
             <a:off x="457200" y="1600200"/>
-            <a:ext cx="11247120" cy="4206240"/>
+            <a:ext cx="11247120" cy="2877454"/>
           </a:xfrm>
           <a:prstGeom prst="rect">
             <a:avLst/>
@@ -26738,116 +27063,144 @@
               </a:spcBef>
             </a:pPr>
             <a:r>
-              <a:rPr sz="1500" b="1">
+              <a:rPr sz="1600" b="1" dirty="0">
                 <a:solidFill>
                   <a:srgbClr val="4A4C55"/>
                 </a:solidFill>
-                <a:latin typeface="Roboto Slab"/>
+                <a:latin typeface="Aptos" panose="020B0004020202020204" pitchFamily="34" charset="0"/>
               </a:rPr>
               <a:t>Demo flow</a:t>
             </a:r>
           </a:p>
           <a:p>
             <a:pPr>
+              <a:lnSpc>
+                <a:spcPct val="150000"/>
+              </a:lnSpc>
               <a:spcAft>
                 <a:spcPts val="400"/>
               </a:spcAft>
             </a:pPr>
             <a:r>
-              <a:rPr sz="1250">
+              <a:rPr sz="1400" dirty="0">
                 <a:solidFill>
                   <a:srgbClr val="333333"/>
                 </a:solidFill>
+                <a:latin typeface="Aptos" panose="020B0004020202020204" pitchFamily="34" charset="0"/>
               </a:rPr>
               <a:t>•  Dashboard — open/closed positions, expandable candidate rows, pipeline stats.</a:t>
             </a:r>
           </a:p>
           <a:p>
             <a:pPr>
+              <a:lnSpc>
+                <a:spcPct val="150000"/>
+              </a:lnSpc>
               <a:spcAft>
                 <a:spcPts val="400"/>
               </a:spcAft>
             </a:pPr>
             <a:r>
-              <a:rPr sz="1250">
+              <a:rPr sz="1400" dirty="0">
                 <a:solidFill>
                   <a:srgbClr val="333333"/>
                 </a:solidFill>
+                <a:latin typeface="Aptos" panose="020B0004020202020204" pitchFamily="34" charset="0"/>
               </a:rPr>
               <a:t>•  Job intake — JD Agent extracts weighted requirements; candidate added via job picker.</a:t>
             </a:r>
           </a:p>
           <a:p>
             <a:pPr>
+              <a:lnSpc>
+                <a:spcPct val="150000"/>
+              </a:lnSpc>
               <a:spcAft>
                 <a:spcPts val="400"/>
               </a:spcAft>
             </a:pPr>
             <a:r>
-              <a:rPr sz="1250">
+              <a:rPr sz="1400" dirty="0">
                 <a:solidFill>
                   <a:srgbClr val="333333"/>
                 </a:solidFill>
+                <a:latin typeface="Aptos" panose="020B0004020202020204" pitchFamily="34" charset="0"/>
               </a:rPr>
               <a:t>•  Candidate analysis — evidence match score, gaps, peer context, generated questions.</a:t>
             </a:r>
           </a:p>
           <a:p>
             <a:pPr>
+              <a:lnSpc>
+                <a:spcPct val="150000"/>
+              </a:lnSpc>
               <a:spcAft>
                 <a:spcPts val="400"/>
               </a:spcAft>
             </a:pPr>
             <a:r>
-              <a:rPr sz="1250">
+              <a:rPr sz="1400" dirty="0">
                 <a:solidFill>
                   <a:srgbClr val="333333"/>
                 </a:solidFill>
+                <a:latin typeface="Aptos" panose="020B0004020202020204" pitchFamily="34" charset="0"/>
               </a:rPr>
               <a:t>•  Transcript review — evaluation scores with quotes; red flags grounded in retrieved cases.</a:t>
             </a:r>
           </a:p>
           <a:p>
             <a:pPr>
+              <a:lnSpc>
+                <a:spcPct val="150000"/>
+              </a:lnSpc>
               <a:spcAft>
                 <a:spcPts val="400"/>
               </a:spcAft>
             </a:pPr>
             <a:r>
-              <a:rPr sz="1250">
+              <a:rPr sz="1400" dirty="0">
                 <a:solidFill>
                   <a:srgbClr val="333333"/>
                 </a:solidFill>
+                <a:latin typeface="Aptos" panose="020B0004020202020204" pitchFamily="34" charset="0"/>
               </a:rPr>
               <a:t>•  Under the Hood (Demo mode) — live agent runs, workflow path, prompt overrides.</a:t>
             </a:r>
           </a:p>
           <a:p>
             <a:pPr>
+              <a:lnSpc>
+                <a:spcPct val="150000"/>
+              </a:lnSpc>
               <a:spcAft>
                 <a:spcPts val="400"/>
               </a:spcAft>
             </a:pPr>
             <a:r>
-              <a:rPr sz="1250">
+              <a:rPr sz="1400" dirty="0">
                 <a:solidFill>
                   <a:srgbClr val="333333"/>
                 </a:solidFill>
+                <a:latin typeface="Aptos" panose="020B0004020202020204" pitchFamily="34" charset="0"/>
               </a:rPr>
               <a:t>•  Settings → Tokens usage — per-agent and per-candidate token and cost metrics.</a:t>
             </a:r>
           </a:p>
           <a:p>
             <a:pPr>
+              <a:lnSpc>
+                <a:spcPct val="150000"/>
+              </a:lnSpc>
               <a:spcAft>
                 <a:spcPts val="400"/>
               </a:spcAft>
             </a:pPr>
             <a:r>
-              <a:rPr sz="1250">
+              <a:rPr sz="1400" dirty="0">
                 <a:solidFill>
                   <a:srgbClr val="333333"/>
                 </a:solidFill>
+                <a:latin typeface="Aptos" panose="020B0004020202020204" pitchFamily="34" charset="0"/>
               </a:rPr>
               <a:t>•  Human review — decision packet, overrides, and expert-verified gap capture.</a:t>
             </a:r>
@@ -26923,8 +27276,7 @@
                 <a:solidFill>
                   <a:srgbClr val="4A4C55"/>
                 </a:solidFill>
-                <a:latin typeface="Roboto Slab" pitchFamily="2" charset="0"/>
-                <a:ea typeface="Roboto Slab" pitchFamily="2" charset="0"/>
+                <a:latin typeface="Aptos" panose="020B0004020202020204" pitchFamily="34" charset="0"/>
                 <a:cs typeface="Poppins" panose="00000500000000000000" pitchFamily="2" charset="0"/>
               </a:rPr>
               <a:t>Testing and Validation</a:t>
@@ -26933,6 +27285,7 @@
               <a:solidFill>
                 <a:srgbClr val="4A4C55"/>
               </a:solidFill>
+              <a:latin typeface="Aptos" panose="020B0004020202020204" pitchFamily="34" charset="0"/>
             </a:endParaRPr>
           </a:p>
         </p:txBody>
@@ -27084,7 +27437,7 @@
         <p:spPr>
           <a:xfrm>
             <a:off x="412727" y="937248"/>
-            <a:ext cx="10094976" cy="369332"/>
+            <a:ext cx="10094976" cy="646331"/>
           </a:xfrm>
           <a:prstGeom prst="rect">
             <a:avLst/>
@@ -27107,7 +27460,7 @@
                 <a:solidFill>
                   <a:srgbClr val="4A4C55"/>
                 </a:solidFill>
-                <a:latin typeface="Roboto Slab" pitchFamily="2" charset="0"/>
+                <a:latin typeface="Aptos" panose="020B0004020202020204" pitchFamily="34" charset="0"/>
                 <a:ea typeface="Roboto Slab" pitchFamily="2" charset="0"/>
                 <a:cs typeface="Poppins" panose="00000500000000000000" pitchFamily="2" charset="0"/>
               </a:rPr>
@@ -27130,7 +27483,7 @@
         </p:nvSpPr>
         <p:spPr>
           <a:xfrm>
-            <a:off x="1517442" y="1604045"/>
+            <a:off x="1517442" y="1971599"/>
             <a:ext cx="2377440" cy="320040"/>
           </a:xfrm>
           <a:prstGeom prst="rect">
@@ -27150,8 +27503,8 @@
           <a:bodyPr/>
           <a:lstStyle/>
           <a:p>
-            <a:endParaRPr lang="en-US">
-              <a:latin typeface="Roboto Slab" pitchFamily="2" charset="0"/>
+            <a:endParaRPr lang="en-US" sz="3200">
+              <a:latin typeface="Aptos" panose="020B0004020202020204" pitchFamily="34" charset="0"/>
               <a:ea typeface="Roboto Slab" pitchFamily="2" charset="0"/>
               <a:cs typeface="Roboto Slab" pitchFamily="2" charset="0"/>
             </a:endParaRPr>
@@ -27172,7 +27525,7 @@
         </p:nvSpPr>
         <p:spPr>
           <a:xfrm>
-            <a:off x="1517442" y="1604045"/>
+            <a:off x="1517442" y="1971599"/>
             <a:ext cx="2377440" cy="320040"/>
           </a:xfrm>
           <a:prstGeom prst="rect">
@@ -27189,18 +27542,18 @@
               <a:buNone/>
             </a:pPr>
             <a:r>
-              <a:rPr lang="en-US" sz="900" b="1" dirty="0">
+              <a:rPr lang="en-US" sz="1200" b="1" dirty="0">
                 <a:solidFill>
                   <a:srgbClr val="FFFFFF"/>
                 </a:solidFill>
-                <a:latin typeface="Roboto Slab" pitchFamily="2" charset="0"/>
+                <a:latin typeface="Aptos" panose="020B0004020202020204" pitchFamily="34" charset="0"/>
                 <a:ea typeface="Roboto Slab" pitchFamily="2" charset="0"/>
                 <a:cs typeface="Roboto Slab" pitchFamily="2" charset="0"/>
               </a:rPr>
               <a:t>Metric</a:t>
             </a:r>
-            <a:endParaRPr lang="en-US" sz="900" dirty="0">
-              <a:latin typeface="Roboto Slab" pitchFamily="2" charset="0"/>
+            <a:endParaRPr lang="en-US" sz="1200" dirty="0">
+              <a:latin typeface="Aptos" panose="020B0004020202020204" pitchFamily="34" charset="0"/>
               <a:ea typeface="Roboto Slab" pitchFamily="2" charset="0"/>
               <a:cs typeface="Roboto Slab" pitchFamily="2" charset="0"/>
             </a:endParaRPr>
@@ -27221,7 +27574,7 @@
         </p:nvSpPr>
         <p:spPr>
           <a:xfrm>
-            <a:off x="3894882" y="1604045"/>
+            <a:off x="3894882" y="1971599"/>
             <a:ext cx="1874520" cy="320040"/>
           </a:xfrm>
           <a:prstGeom prst="rect">
@@ -27241,8 +27594,8 @@
           <a:bodyPr/>
           <a:lstStyle/>
           <a:p>
-            <a:endParaRPr lang="en-US">
-              <a:latin typeface="Roboto Slab" pitchFamily="2" charset="0"/>
+            <a:endParaRPr lang="en-US" sz="3200">
+              <a:latin typeface="Aptos" panose="020B0004020202020204" pitchFamily="34" charset="0"/>
               <a:ea typeface="Roboto Slab" pitchFamily="2" charset="0"/>
               <a:cs typeface="Roboto Slab" pitchFamily="2" charset="0"/>
             </a:endParaRPr>
@@ -27263,7 +27616,7 @@
         </p:nvSpPr>
         <p:spPr>
           <a:xfrm>
-            <a:off x="3894882" y="1604045"/>
+            <a:off x="3894882" y="1971599"/>
             <a:ext cx="1874520" cy="320040"/>
           </a:xfrm>
           <a:prstGeom prst="rect">
@@ -27280,18 +27633,18 @@
               <a:buNone/>
             </a:pPr>
             <a:r>
-              <a:rPr lang="en-US" sz="900" b="1" dirty="0">
+              <a:rPr lang="en-US" sz="1200" b="1" dirty="0">
                 <a:solidFill>
                   <a:srgbClr val="FFFFFF"/>
                 </a:solidFill>
-                <a:latin typeface="Roboto Slab" pitchFamily="2" charset="0"/>
+                <a:latin typeface="Aptos" panose="020B0004020202020204" pitchFamily="34" charset="0"/>
                 <a:ea typeface="Roboto Slab" pitchFamily="2" charset="0"/>
                 <a:cs typeface="Roboto Slab" pitchFamily="2" charset="0"/>
               </a:rPr>
               <a:t>Current (Manual)</a:t>
             </a:r>
-            <a:endParaRPr lang="en-US" sz="900" dirty="0">
-              <a:latin typeface="Roboto Slab" pitchFamily="2" charset="0"/>
+            <a:endParaRPr lang="en-US" sz="1200" dirty="0">
+              <a:latin typeface="Aptos" panose="020B0004020202020204" pitchFamily="34" charset="0"/>
               <a:ea typeface="Roboto Slab" pitchFamily="2" charset="0"/>
               <a:cs typeface="Roboto Slab" pitchFamily="2" charset="0"/>
             </a:endParaRPr>
@@ -27312,7 +27665,7 @@
         </p:nvSpPr>
         <p:spPr>
           <a:xfrm>
-            <a:off x="5769402" y="1604045"/>
+            <a:off x="5769402" y="1971599"/>
             <a:ext cx="1874520" cy="320040"/>
           </a:xfrm>
           <a:prstGeom prst="rect">
@@ -27332,8 +27685,8 @@
           <a:bodyPr/>
           <a:lstStyle/>
           <a:p>
-            <a:endParaRPr lang="en-US">
-              <a:latin typeface="Roboto Slab" pitchFamily="2" charset="0"/>
+            <a:endParaRPr lang="en-US" sz="3200">
+              <a:latin typeface="Aptos" panose="020B0004020202020204" pitchFamily="34" charset="0"/>
               <a:ea typeface="Roboto Slab" pitchFamily="2" charset="0"/>
               <a:cs typeface="Roboto Slab" pitchFamily="2" charset="0"/>
             </a:endParaRPr>
@@ -27354,7 +27707,7 @@
         </p:nvSpPr>
         <p:spPr>
           <a:xfrm>
-            <a:off x="5769402" y="1604045"/>
+            <a:off x="5769402" y="1971599"/>
             <a:ext cx="1874520" cy="320040"/>
           </a:xfrm>
           <a:prstGeom prst="rect">
@@ -27371,18 +27724,18 @@
               <a:buNone/>
             </a:pPr>
             <a:r>
-              <a:rPr lang="en-US" sz="900" b="1" dirty="0">
+              <a:rPr lang="en-US" sz="1200" b="1" dirty="0">
                 <a:solidFill>
                   <a:srgbClr val="FFFFFF"/>
                 </a:solidFill>
-                <a:latin typeface="Roboto Slab" pitchFamily="2" charset="0"/>
+                <a:latin typeface="Aptos" panose="020B0004020202020204" pitchFamily="34" charset="0"/>
                 <a:ea typeface="Roboto Slab" pitchFamily="2" charset="0"/>
                 <a:cs typeface="Roboto Slab" pitchFamily="2" charset="0"/>
               </a:rPr>
               <a:t>With Agentic AI</a:t>
             </a:r>
-            <a:endParaRPr lang="en-US" sz="900" dirty="0">
-              <a:latin typeface="Roboto Slab" pitchFamily="2" charset="0"/>
+            <a:endParaRPr lang="en-US" sz="1200" dirty="0">
+              <a:latin typeface="Aptos" panose="020B0004020202020204" pitchFamily="34" charset="0"/>
               <a:ea typeface="Roboto Slab" pitchFamily="2" charset="0"/>
               <a:cs typeface="Roboto Slab" pitchFamily="2" charset="0"/>
             </a:endParaRPr>
@@ -27403,7 +27756,7 @@
         </p:nvSpPr>
         <p:spPr>
           <a:xfrm>
-            <a:off x="7643922" y="1604045"/>
+            <a:off x="7643922" y="1971599"/>
             <a:ext cx="1874520" cy="320040"/>
           </a:xfrm>
           <a:prstGeom prst="rect">
@@ -27423,8 +27776,8 @@
           <a:bodyPr/>
           <a:lstStyle/>
           <a:p>
-            <a:endParaRPr lang="en-US">
-              <a:latin typeface="Roboto Slab" pitchFamily="2" charset="0"/>
+            <a:endParaRPr lang="en-US" sz="3200">
+              <a:latin typeface="Aptos" panose="020B0004020202020204" pitchFamily="34" charset="0"/>
               <a:ea typeface="Roboto Slab" pitchFamily="2" charset="0"/>
               <a:cs typeface="Roboto Slab" pitchFamily="2" charset="0"/>
             </a:endParaRPr>
@@ -27445,7 +27798,7 @@
         </p:nvSpPr>
         <p:spPr>
           <a:xfrm>
-            <a:off x="7643922" y="1604045"/>
+            <a:off x="7643922" y="1971599"/>
             <a:ext cx="1874520" cy="320040"/>
           </a:xfrm>
           <a:prstGeom prst="rect">
@@ -27462,18 +27815,18 @@
               <a:buNone/>
             </a:pPr>
             <a:r>
-              <a:rPr lang="en-US" sz="900" b="1" dirty="0">
+              <a:rPr lang="en-US" sz="1200" b="1" dirty="0">
                 <a:solidFill>
                   <a:srgbClr val="FFFFFF"/>
                 </a:solidFill>
-                <a:latin typeface="Roboto Slab" pitchFamily="2" charset="0"/>
+                <a:latin typeface="Aptos" panose="020B0004020202020204" pitchFamily="34" charset="0"/>
                 <a:ea typeface="Roboto Slab" pitchFamily="2" charset="0"/>
                 <a:cs typeface="Roboto Slab" pitchFamily="2" charset="0"/>
               </a:rPr>
               <a:t>Improvement</a:t>
             </a:r>
-            <a:endParaRPr lang="en-US" sz="900" dirty="0">
-              <a:latin typeface="Roboto Slab" pitchFamily="2" charset="0"/>
+            <a:endParaRPr lang="en-US" sz="1200" dirty="0">
+              <a:latin typeface="Aptos" panose="020B0004020202020204" pitchFamily="34" charset="0"/>
               <a:ea typeface="Roboto Slab" pitchFamily="2" charset="0"/>
               <a:cs typeface="Roboto Slab" pitchFamily="2" charset="0"/>
             </a:endParaRPr>
@@ -27494,7 +27847,7 @@
         </p:nvSpPr>
         <p:spPr>
           <a:xfrm>
-            <a:off x="1517442" y="1924085"/>
+            <a:off x="1517442" y="2291639"/>
             <a:ext cx="2377440" cy="438912"/>
           </a:xfrm>
           <a:prstGeom prst="rect">
@@ -27514,8 +27867,8 @@
           <a:bodyPr/>
           <a:lstStyle/>
           <a:p>
-            <a:endParaRPr lang="en-US">
-              <a:latin typeface="Roboto Slab" pitchFamily="2" charset="0"/>
+            <a:endParaRPr lang="en-US" sz="3200">
+              <a:latin typeface="Aptos" panose="020B0004020202020204" pitchFamily="34" charset="0"/>
               <a:ea typeface="Roboto Slab" pitchFamily="2" charset="0"/>
               <a:cs typeface="Roboto Slab" pitchFamily="2" charset="0"/>
             </a:endParaRPr>
@@ -27536,7 +27889,7 @@
         </p:nvSpPr>
         <p:spPr>
           <a:xfrm>
-            <a:off x="1608882" y="1924085"/>
+            <a:off x="1608882" y="2291639"/>
             <a:ext cx="2194560" cy="438912"/>
           </a:xfrm>
           <a:prstGeom prst="rect">
@@ -27553,18 +27906,18 @@
               <a:buNone/>
             </a:pPr>
             <a:r>
-              <a:rPr lang="en-US" sz="900" b="1" dirty="0">
+              <a:rPr lang="en-US" sz="1200" b="1" dirty="0">
                 <a:solidFill>
                   <a:srgbClr val="1A2B5E"/>
                 </a:solidFill>
-                <a:latin typeface="Roboto Slab" pitchFamily="2" charset="0"/>
+                <a:latin typeface="Aptos" panose="020B0004020202020204" pitchFamily="34" charset="0"/>
                 <a:ea typeface="Roboto Slab" pitchFamily="2" charset="0"/>
                 <a:cs typeface="Roboto Slab" pitchFamily="2" charset="0"/>
               </a:rPr>
               <a:t>Screening time per candidate</a:t>
             </a:r>
-            <a:endParaRPr lang="en-US" sz="900" dirty="0">
-              <a:latin typeface="Roboto Slab" pitchFamily="2" charset="0"/>
+            <a:endParaRPr lang="en-US" sz="1200" dirty="0">
+              <a:latin typeface="Aptos" panose="020B0004020202020204" pitchFamily="34" charset="0"/>
               <a:ea typeface="Roboto Slab" pitchFamily="2" charset="0"/>
               <a:cs typeface="Roboto Slab" pitchFamily="2" charset="0"/>
             </a:endParaRPr>
@@ -27585,7 +27938,7 @@
         </p:nvSpPr>
         <p:spPr>
           <a:xfrm>
-            <a:off x="3894882" y="1924085"/>
+            <a:off x="3894882" y="2291639"/>
             <a:ext cx="1874520" cy="438912"/>
           </a:xfrm>
           <a:prstGeom prst="rect">
@@ -27605,8 +27958,8 @@
           <a:bodyPr/>
           <a:lstStyle/>
           <a:p>
-            <a:endParaRPr lang="en-US">
-              <a:latin typeface="Roboto Slab" pitchFamily="2" charset="0"/>
+            <a:endParaRPr lang="en-US" sz="3200">
+              <a:latin typeface="Aptos" panose="020B0004020202020204" pitchFamily="34" charset="0"/>
               <a:ea typeface="Roboto Slab" pitchFamily="2" charset="0"/>
               <a:cs typeface="Roboto Slab" pitchFamily="2" charset="0"/>
             </a:endParaRPr>
@@ -27627,7 +27980,7 @@
         </p:nvSpPr>
         <p:spPr>
           <a:xfrm>
-            <a:off x="3986322" y="1924085"/>
+            <a:off x="3986322" y="2291639"/>
             <a:ext cx="1691640" cy="438912"/>
           </a:xfrm>
           <a:prstGeom prst="rect">
@@ -27644,18 +27997,18 @@
               <a:buNone/>
             </a:pPr>
             <a:r>
-              <a:rPr lang="en-US" sz="850" i="1" dirty="0">
+              <a:rPr lang="en-US" sz="1100" i="1" dirty="0">
                 <a:solidFill>
                   <a:srgbClr val="374151"/>
                 </a:solidFill>
-                <a:latin typeface="Roboto Slab" pitchFamily="2" charset="0"/>
+                <a:latin typeface="Aptos" panose="020B0004020202020204" pitchFamily="34" charset="0"/>
                 <a:ea typeface="Roboto Slab" pitchFamily="2" charset="0"/>
                 <a:cs typeface="Roboto Slab" pitchFamily="2" charset="0"/>
               </a:rPr>
               <a:t>~20–30 min manual</a:t>
             </a:r>
-            <a:endParaRPr lang="en-US" sz="850" dirty="0">
-              <a:latin typeface="Roboto Slab" pitchFamily="2" charset="0"/>
+            <a:endParaRPr lang="en-US" sz="1100" dirty="0">
+              <a:latin typeface="Aptos" panose="020B0004020202020204" pitchFamily="34" charset="0"/>
               <a:ea typeface="Roboto Slab" pitchFamily="2" charset="0"/>
               <a:cs typeface="Roboto Slab" pitchFamily="2" charset="0"/>
             </a:endParaRPr>
@@ -27676,7 +28029,7 @@
         </p:nvSpPr>
         <p:spPr>
           <a:xfrm>
-            <a:off x="5769402" y="1924085"/>
+            <a:off x="5769402" y="2291639"/>
             <a:ext cx="1874520" cy="438912"/>
           </a:xfrm>
           <a:prstGeom prst="rect">
@@ -27696,8 +28049,8 @@
           <a:bodyPr/>
           <a:lstStyle/>
           <a:p>
-            <a:endParaRPr lang="en-US">
-              <a:latin typeface="Roboto Slab" pitchFamily="2" charset="0"/>
+            <a:endParaRPr lang="en-US" sz="3200">
+              <a:latin typeface="Aptos" panose="020B0004020202020204" pitchFamily="34" charset="0"/>
               <a:ea typeface="Roboto Slab" pitchFamily="2" charset="0"/>
               <a:cs typeface="Roboto Slab" pitchFamily="2" charset="0"/>
             </a:endParaRPr>
@@ -27718,7 +28071,7 @@
         </p:nvSpPr>
         <p:spPr>
           <a:xfrm>
-            <a:off x="5860842" y="1924085"/>
+            <a:off x="5860842" y="2291639"/>
             <a:ext cx="1691640" cy="438912"/>
           </a:xfrm>
           <a:prstGeom prst="rect">
@@ -27735,18 +28088,18 @@
               <a:buNone/>
             </a:pPr>
             <a:r>
-              <a:rPr lang="en-US" sz="850" i="1" dirty="0">
+              <a:rPr lang="en-US" sz="1100" i="1" dirty="0">
                 <a:solidFill>
                   <a:srgbClr val="374151"/>
                 </a:solidFill>
-                <a:latin typeface="Roboto Slab" pitchFamily="2" charset="0"/>
+                <a:latin typeface="Aptos" panose="020B0004020202020204" pitchFamily="34" charset="0"/>
                 <a:ea typeface="Roboto Slab" pitchFamily="2" charset="0"/>
                 <a:cs typeface="Roboto Slab" pitchFamily="2" charset="0"/>
               </a:rPr>
               <a:t>~2–3 min automated</a:t>
             </a:r>
-            <a:endParaRPr lang="en-US" sz="850" dirty="0">
-              <a:latin typeface="Roboto Slab" pitchFamily="2" charset="0"/>
+            <a:endParaRPr lang="en-US" sz="1100" dirty="0">
+              <a:latin typeface="Aptos" panose="020B0004020202020204" pitchFamily="34" charset="0"/>
               <a:ea typeface="Roboto Slab" pitchFamily="2" charset="0"/>
               <a:cs typeface="Roboto Slab" pitchFamily="2" charset="0"/>
             </a:endParaRPr>
@@ -27767,7 +28120,7 @@
         </p:nvSpPr>
         <p:spPr>
           <a:xfrm>
-            <a:off x="7643922" y="1924085"/>
+            <a:off x="7643922" y="2291639"/>
             <a:ext cx="1874520" cy="438912"/>
           </a:xfrm>
           <a:prstGeom prst="rect">
@@ -27787,8 +28140,8 @@
           <a:bodyPr/>
           <a:lstStyle/>
           <a:p>
-            <a:endParaRPr lang="en-US">
-              <a:latin typeface="Roboto Slab" pitchFamily="2" charset="0"/>
+            <a:endParaRPr lang="en-US" sz="3200">
+              <a:latin typeface="Aptos" panose="020B0004020202020204" pitchFamily="34" charset="0"/>
               <a:ea typeface="Roboto Slab" pitchFamily="2" charset="0"/>
               <a:cs typeface="Roboto Slab" pitchFamily="2" charset="0"/>
             </a:endParaRPr>
@@ -27809,7 +28162,7 @@
         </p:nvSpPr>
         <p:spPr>
           <a:xfrm>
-            <a:off x="7735362" y="1924085"/>
+            <a:off x="7735362" y="2291639"/>
             <a:ext cx="1691640" cy="438912"/>
           </a:xfrm>
           <a:prstGeom prst="rect">
@@ -27826,18 +28179,18 @@
               <a:buNone/>
             </a:pPr>
             <a:r>
-              <a:rPr lang="en-US" sz="850" i="1" dirty="0">
+              <a:rPr lang="en-US" sz="1100" i="1" dirty="0">
                 <a:solidFill>
                   <a:srgbClr val="374151"/>
                 </a:solidFill>
-                <a:latin typeface="Roboto Slab" pitchFamily="2" charset="0"/>
+                <a:latin typeface="Aptos" panose="020B0004020202020204" pitchFamily="34" charset="0"/>
                 <a:ea typeface="Roboto Slab" pitchFamily="2" charset="0"/>
                 <a:cs typeface="Roboto Slab" pitchFamily="2" charset="0"/>
               </a:rPr>
               <a:t>~85–90% faster</a:t>
             </a:r>
-            <a:endParaRPr lang="en-US" sz="850" dirty="0">
-              <a:latin typeface="Roboto Slab" pitchFamily="2" charset="0"/>
+            <a:endParaRPr lang="en-US" sz="1100" dirty="0">
+              <a:latin typeface="Aptos" panose="020B0004020202020204" pitchFamily="34" charset="0"/>
               <a:ea typeface="Roboto Slab" pitchFamily="2" charset="0"/>
               <a:cs typeface="Roboto Slab" pitchFamily="2" charset="0"/>
             </a:endParaRPr>
@@ -27858,7 +28211,7 @@
         </p:nvSpPr>
         <p:spPr>
           <a:xfrm>
-            <a:off x="1517442" y="2399573"/>
+            <a:off x="1517442" y="2767127"/>
             <a:ext cx="2377440" cy="438912"/>
           </a:xfrm>
           <a:prstGeom prst="rect">
@@ -27878,8 +28231,8 @@
           <a:bodyPr/>
           <a:lstStyle/>
           <a:p>
-            <a:endParaRPr lang="en-US">
-              <a:latin typeface="Roboto Slab" pitchFamily="2" charset="0"/>
+            <a:endParaRPr lang="en-US" sz="3200">
+              <a:latin typeface="Aptos" panose="020B0004020202020204" pitchFamily="34" charset="0"/>
               <a:ea typeface="Roboto Slab" pitchFamily="2" charset="0"/>
               <a:cs typeface="Roboto Slab" pitchFamily="2" charset="0"/>
             </a:endParaRPr>
@@ -27900,7 +28253,7 @@
         </p:nvSpPr>
         <p:spPr>
           <a:xfrm>
-            <a:off x="1608882" y="2399573"/>
+            <a:off x="1608882" y="2767127"/>
             <a:ext cx="2194560" cy="438912"/>
           </a:xfrm>
           <a:prstGeom prst="rect">
@@ -27917,18 +28270,18 @@
               <a:buNone/>
             </a:pPr>
             <a:r>
-              <a:rPr lang="en-US" sz="900" b="1" dirty="0">
+              <a:rPr lang="en-US" sz="1200" b="1" dirty="0">
                 <a:solidFill>
                   <a:srgbClr val="1A2B5E"/>
                 </a:solidFill>
-                <a:latin typeface="Roboto Slab" pitchFamily="2" charset="0"/>
+                <a:latin typeface="Aptos" panose="020B0004020202020204" pitchFamily="34" charset="0"/>
                 <a:ea typeface="Roboto Slab" pitchFamily="2" charset="0"/>
                 <a:cs typeface="Roboto Slab" pitchFamily="2" charset="0"/>
               </a:rPr>
               <a:t>Interview evaluation turnaround</a:t>
             </a:r>
-            <a:endParaRPr lang="en-US" sz="900" dirty="0">
-              <a:latin typeface="Roboto Slab" pitchFamily="2" charset="0"/>
+            <a:endParaRPr lang="en-US" sz="1200" dirty="0">
+              <a:latin typeface="Aptos" panose="020B0004020202020204" pitchFamily="34" charset="0"/>
               <a:ea typeface="Roboto Slab" pitchFamily="2" charset="0"/>
               <a:cs typeface="Roboto Slab" pitchFamily="2" charset="0"/>
             </a:endParaRPr>
@@ -27949,7 +28302,7 @@
         </p:nvSpPr>
         <p:spPr>
           <a:xfrm>
-            <a:off x="3894882" y="2399573"/>
+            <a:off x="3894882" y="2767127"/>
             <a:ext cx="1874520" cy="438912"/>
           </a:xfrm>
           <a:prstGeom prst="rect">
@@ -27969,8 +28322,8 @@
           <a:bodyPr/>
           <a:lstStyle/>
           <a:p>
-            <a:endParaRPr lang="en-US">
-              <a:latin typeface="Roboto Slab" pitchFamily="2" charset="0"/>
+            <a:endParaRPr lang="en-US" sz="3200">
+              <a:latin typeface="Aptos" panose="020B0004020202020204" pitchFamily="34" charset="0"/>
               <a:ea typeface="Roboto Slab" pitchFamily="2" charset="0"/>
               <a:cs typeface="Roboto Slab" pitchFamily="2" charset="0"/>
             </a:endParaRPr>
@@ -27991,7 +28344,7 @@
         </p:nvSpPr>
         <p:spPr>
           <a:xfrm>
-            <a:off x="3986322" y="2399573"/>
+            <a:off x="3986322" y="2767127"/>
             <a:ext cx="1691640" cy="438912"/>
           </a:xfrm>
           <a:prstGeom prst="rect">
@@ -28008,18 +28361,18 @@
               <a:buNone/>
             </a:pPr>
             <a:r>
-              <a:rPr lang="en-US" sz="850" i="1" dirty="0">
+              <a:rPr lang="en-US" sz="1100" i="1" dirty="0">
                 <a:solidFill>
                   <a:srgbClr val="374151"/>
                 </a:solidFill>
-                <a:latin typeface="Roboto Slab" pitchFamily="2" charset="0"/>
+                <a:latin typeface="Aptos" panose="020B0004020202020204" pitchFamily="34" charset="0"/>
                 <a:ea typeface="Roboto Slab" pitchFamily="2" charset="0"/>
                 <a:cs typeface="Roboto Slab" pitchFamily="2" charset="0"/>
               </a:rPr>
               <a:t>Hours to days</a:t>
             </a:r>
-            <a:endParaRPr lang="en-US" sz="850" dirty="0">
-              <a:latin typeface="Roboto Slab" pitchFamily="2" charset="0"/>
+            <a:endParaRPr lang="en-US" sz="1100" dirty="0">
+              <a:latin typeface="Aptos" panose="020B0004020202020204" pitchFamily="34" charset="0"/>
               <a:ea typeface="Roboto Slab" pitchFamily="2" charset="0"/>
               <a:cs typeface="Roboto Slab" pitchFamily="2" charset="0"/>
             </a:endParaRPr>
@@ -28040,7 +28393,7 @@
         </p:nvSpPr>
         <p:spPr>
           <a:xfrm>
-            <a:off x="5769402" y="2399573"/>
+            <a:off x="5769402" y="2767127"/>
             <a:ext cx="1874520" cy="438912"/>
           </a:xfrm>
           <a:prstGeom prst="rect">
@@ -28060,8 +28413,8 @@
           <a:bodyPr/>
           <a:lstStyle/>
           <a:p>
-            <a:endParaRPr lang="en-US">
-              <a:latin typeface="Roboto Slab" pitchFamily="2" charset="0"/>
+            <a:endParaRPr lang="en-US" sz="3200">
+              <a:latin typeface="Aptos" panose="020B0004020202020204" pitchFamily="34" charset="0"/>
               <a:ea typeface="Roboto Slab" pitchFamily="2" charset="0"/>
               <a:cs typeface="Roboto Slab" pitchFamily="2" charset="0"/>
             </a:endParaRPr>
@@ -28082,7 +28435,7 @@
         </p:nvSpPr>
         <p:spPr>
           <a:xfrm>
-            <a:off x="5860842" y="2399573"/>
+            <a:off x="5860842" y="2767127"/>
             <a:ext cx="1691640" cy="438912"/>
           </a:xfrm>
           <a:prstGeom prst="rect">
@@ -28099,18 +28452,18 @@
               <a:buNone/>
             </a:pPr>
             <a:r>
-              <a:rPr lang="en-US" sz="850" i="1" dirty="0">
+              <a:rPr lang="en-US" sz="1100" i="1" dirty="0">
                 <a:solidFill>
                   <a:srgbClr val="374151"/>
                 </a:solidFill>
-                <a:latin typeface="Roboto Slab" pitchFamily="2" charset="0"/>
+                <a:latin typeface="Aptos" panose="020B0004020202020204" pitchFamily="34" charset="0"/>
                 <a:ea typeface="Roboto Slab" pitchFamily="2" charset="0"/>
                 <a:cs typeface="Roboto Slab" pitchFamily="2" charset="0"/>
               </a:rPr>
               <a:t>Minutes after upload</a:t>
             </a:r>
-            <a:endParaRPr lang="en-US" sz="850" dirty="0">
-              <a:latin typeface="Roboto Slab" pitchFamily="2" charset="0"/>
+            <a:endParaRPr lang="en-US" sz="1100" dirty="0">
+              <a:latin typeface="Aptos" panose="020B0004020202020204" pitchFamily="34" charset="0"/>
               <a:ea typeface="Roboto Slab" pitchFamily="2" charset="0"/>
               <a:cs typeface="Roboto Slab" pitchFamily="2" charset="0"/>
             </a:endParaRPr>
@@ -28131,7 +28484,7 @@
         </p:nvSpPr>
         <p:spPr>
           <a:xfrm>
-            <a:off x="7643922" y="2399573"/>
+            <a:off x="7643922" y="2767127"/>
             <a:ext cx="1874520" cy="438912"/>
           </a:xfrm>
           <a:prstGeom prst="rect">
@@ -28151,8 +28504,8 @@
           <a:bodyPr/>
           <a:lstStyle/>
           <a:p>
-            <a:endParaRPr lang="en-US">
-              <a:latin typeface="Roboto Slab" pitchFamily="2" charset="0"/>
+            <a:endParaRPr lang="en-US" sz="3200">
+              <a:latin typeface="Aptos" panose="020B0004020202020204" pitchFamily="34" charset="0"/>
               <a:ea typeface="Roboto Slab" pitchFamily="2" charset="0"/>
               <a:cs typeface="Roboto Slab" pitchFamily="2" charset="0"/>
             </a:endParaRPr>
@@ -28173,7 +28526,7 @@
         </p:nvSpPr>
         <p:spPr>
           <a:xfrm>
-            <a:off x="7735362" y="2399573"/>
+            <a:off x="7735362" y="2767127"/>
             <a:ext cx="1691640" cy="438912"/>
           </a:xfrm>
           <a:prstGeom prst="rect">
@@ -28190,18 +28543,18 @@
               <a:buNone/>
             </a:pPr>
             <a:r>
-              <a:rPr lang="en-US" sz="850" i="1" dirty="0">
+              <a:rPr lang="en-US" sz="1100" i="1" dirty="0">
                 <a:solidFill>
                   <a:srgbClr val="374151"/>
                 </a:solidFill>
-                <a:latin typeface="Roboto Slab" pitchFamily="2" charset="0"/>
+                <a:latin typeface="Aptos" panose="020B0004020202020204" pitchFamily="34" charset="0"/>
                 <a:ea typeface="Roboto Slab" pitchFamily="2" charset="0"/>
                 <a:cs typeface="Roboto Slab" pitchFamily="2" charset="0"/>
               </a:rPr>
               <a:t>Near real-time</a:t>
             </a:r>
-            <a:endParaRPr lang="en-US" sz="850" dirty="0">
-              <a:latin typeface="Roboto Slab" pitchFamily="2" charset="0"/>
+            <a:endParaRPr lang="en-US" sz="1100" dirty="0">
+              <a:latin typeface="Aptos" panose="020B0004020202020204" pitchFamily="34" charset="0"/>
               <a:ea typeface="Roboto Slab" pitchFamily="2" charset="0"/>
               <a:cs typeface="Roboto Slab" pitchFamily="2" charset="0"/>
             </a:endParaRPr>
@@ -28222,7 +28575,7 @@
         </p:nvSpPr>
         <p:spPr>
           <a:xfrm>
-            <a:off x="1517442" y="2875061"/>
+            <a:off x="1517442" y="3242615"/>
             <a:ext cx="2377440" cy="438912"/>
           </a:xfrm>
           <a:prstGeom prst="rect">
@@ -28242,8 +28595,8 @@
           <a:bodyPr/>
           <a:lstStyle/>
           <a:p>
-            <a:endParaRPr lang="en-US">
-              <a:latin typeface="Roboto Slab" pitchFamily="2" charset="0"/>
+            <a:endParaRPr lang="en-US" sz="3200">
+              <a:latin typeface="Aptos" panose="020B0004020202020204" pitchFamily="34" charset="0"/>
               <a:ea typeface="Roboto Slab" pitchFamily="2" charset="0"/>
               <a:cs typeface="Roboto Slab" pitchFamily="2" charset="0"/>
             </a:endParaRPr>
@@ -28264,7 +28617,7 @@
         </p:nvSpPr>
         <p:spPr>
           <a:xfrm>
-            <a:off x="1608882" y="2875061"/>
+            <a:off x="1608882" y="3242615"/>
             <a:ext cx="2194560" cy="438912"/>
           </a:xfrm>
           <a:prstGeom prst="rect">
@@ -28281,18 +28634,18 @@
               <a:buNone/>
             </a:pPr>
             <a:r>
-              <a:rPr lang="en-US" sz="900" b="1" dirty="0">
+              <a:rPr lang="en-US" sz="1200" b="1" dirty="0">
                 <a:solidFill>
                   <a:srgbClr val="1A2B5E"/>
                 </a:solidFill>
-                <a:latin typeface="Roboto Slab" pitchFamily="2" charset="0"/>
+                <a:latin typeface="Aptos" panose="020B0004020202020204" pitchFamily="34" charset="0"/>
                 <a:ea typeface="Roboto Slab" pitchFamily="2" charset="0"/>
                 <a:cs typeface="Roboto Slab" pitchFamily="2" charset="0"/>
               </a:rPr>
               <a:t>Ungrounded AI claims in flags</a:t>
             </a:r>
-            <a:endParaRPr lang="en-US" sz="900" dirty="0">
-              <a:latin typeface="Roboto Slab" pitchFamily="2" charset="0"/>
+            <a:endParaRPr lang="en-US" sz="1200" dirty="0">
+              <a:latin typeface="Aptos" panose="020B0004020202020204" pitchFamily="34" charset="0"/>
               <a:ea typeface="Roboto Slab" pitchFamily="2" charset="0"/>
               <a:cs typeface="Roboto Slab" pitchFamily="2" charset="0"/>
             </a:endParaRPr>
@@ -28313,7 +28666,7 @@
         </p:nvSpPr>
         <p:spPr>
           <a:xfrm>
-            <a:off x="3894882" y="2875061"/>
+            <a:off x="3894882" y="3242615"/>
             <a:ext cx="1874520" cy="438912"/>
           </a:xfrm>
           <a:prstGeom prst="rect">
@@ -28333,8 +28686,8 @@
           <a:bodyPr/>
           <a:lstStyle/>
           <a:p>
-            <a:endParaRPr lang="en-US">
-              <a:latin typeface="Roboto Slab" pitchFamily="2" charset="0"/>
+            <a:endParaRPr lang="en-US" sz="3200">
+              <a:latin typeface="Aptos" panose="020B0004020202020204" pitchFamily="34" charset="0"/>
               <a:ea typeface="Roboto Slab" pitchFamily="2" charset="0"/>
               <a:cs typeface="Roboto Slab" pitchFamily="2" charset="0"/>
             </a:endParaRPr>
@@ -28355,7 +28708,7 @@
         </p:nvSpPr>
         <p:spPr>
           <a:xfrm>
-            <a:off x="3986322" y="2875061"/>
+            <a:off x="3986322" y="3242615"/>
             <a:ext cx="1691640" cy="438912"/>
           </a:xfrm>
           <a:prstGeom prst="rect">
@@ -28372,18 +28725,18 @@
               <a:buNone/>
             </a:pPr>
             <a:r>
-              <a:rPr lang="en-US" sz="850" i="1" dirty="0">
+              <a:rPr lang="en-US" sz="1100" i="1" dirty="0">
                 <a:solidFill>
                   <a:srgbClr val="374151"/>
                 </a:solidFill>
-                <a:latin typeface="Roboto Slab" pitchFamily="2" charset="0"/>
+                <a:latin typeface="Aptos" panose="020B0004020202020204" pitchFamily="34" charset="0"/>
                 <a:ea typeface="Roboto Slab" pitchFamily="2" charset="0"/>
                 <a:cs typeface="Roboto Slab" pitchFamily="2" charset="0"/>
               </a:rPr>
               <a:t>Uncontrolled</a:t>
             </a:r>
-            <a:endParaRPr lang="en-US" sz="850" dirty="0">
-              <a:latin typeface="Roboto Slab" pitchFamily="2" charset="0"/>
+            <a:endParaRPr lang="en-US" sz="1100" dirty="0">
+              <a:latin typeface="Aptos" panose="020B0004020202020204" pitchFamily="34" charset="0"/>
               <a:ea typeface="Roboto Slab" pitchFamily="2" charset="0"/>
               <a:cs typeface="Roboto Slab" pitchFamily="2" charset="0"/>
             </a:endParaRPr>
@@ -28404,7 +28757,7 @@
         </p:nvSpPr>
         <p:spPr>
           <a:xfrm>
-            <a:off x="5769402" y="2875061"/>
+            <a:off x="5769402" y="3242615"/>
             <a:ext cx="1874520" cy="438912"/>
           </a:xfrm>
           <a:prstGeom prst="rect">
@@ -28424,8 +28777,8 @@
           <a:bodyPr/>
           <a:lstStyle/>
           <a:p>
-            <a:endParaRPr lang="en-US">
-              <a:latin typeface="Roboto Slab" pitchFamily="2" charset="0"/>
+            <a:endParaRPr lang="en-US" sz="3200">
+              <a:latin typeface="Aptos" panose="020B0004020202020204" pitchFamily="34" charset="0"/>
               <a:ea typeface="Roboto Slab" pitchFamily="2" charset="0"/>
               <a:cs typeface="Roboto Slab" pitchFamily="2" charset="0"/>
             </a:endParaRPr>
@@ -28446,7 +28799,7 @@
         </p:nvSpPr>
         <p:spPr>
           <a:xfrm>
-            <a:off x="5860842" y="2875061"/>
+            <a:off x="5860842" y="3242615"/>
             <a:ext cx="1691640" cy="438912"/>
           </a:xfrm>
           <a:prstGeom prst="rect">
@@ -28463,18 +28816,18 @@
               <a:buNone/>
             </a:pPr>
             <a:r>
-              <a:rPr lang="en-US" sz="850" i="1" dirty="0">
+              <a:rPr lang="en-US" sz="1100" i="1" dirty="0">
                 <a:solidFill>
                   <a:srgbClr val="374151"/>
                 </a:solidFill>
-                <a:latin typeface="Roboto Slab" pitchFamily="2" charset="0"/>
+                <a:latin typeface="Aptos" panose="020B0004020202020204" pitchFamily="34" charset="0"/>
                 <a:ea typeface="Roboto Slab" pitchFamily="2" charset="0"/>
                 <a:cs typeface="Roboto Slab" pitchFamily="2" charset="0"/>
               </a:rPr>
               <a:t>Quote + case ID required</a:t>
             </a:r>
-            <a:endParaRPr lang="en-US" sz="850" dirty="0">
-              <a:latin typeface="Roboto Slab" pitchFamily="2" charset="0"/>
+            <a:endParaRPr lang="en-US" sz="1100" dirty="0">
+              <a:latin typeface="Aptos" panose="020B0004020202020204" pitchFamily="34" charset="0"/>
               <a:ea typeface="Roboto Slab" pitchFamily="2" charset="0"/>
               <a:cs typeface="Roboto Slab" pitchFamily="2" charset="0"/>
             </a:endParaRPr>
@@ -28495,7 +28848,7 @@
         </p:nvSpPr>
         <p:spPr>
           <a:xfrm>
-            <a:off x="7643922" y="2875061"/>
+            <a:off x="7643922" y="3242615"/>
             <a:ext cx="1874520" cy="438912"/>
           </a:xfrm>
           <a:prstGeom prst="rect">
@@ -28515,8 +28868,8 @@
           <a:bodyPr/>
           <a:lstStyle/>
           <a:p>
-            <a:endParaRPr lang="en-US">
-              <a:latin typeface="Roboto Slab" pitchFamily="2" charset="0"/>
+            <a:endParaRPr lang="en-US" sz="3200">
+              <a:latin typeface="Aptos" panose="020B0004020202020204" pitchFamily="34" charset="0"/>
               <a:ea typeface="Roboto Slab" pitchFamily="2" charset="0"/>
               <a:cs typeface="Roboto Slab" pitchFamily="2" charset="0"/>
             </a:endParaRPr>
@@ -28537,7 +28890,7 @@
         </p:nvSpPr>
         <p:spPr>
           <a:xfrm>
-            <a:off x="7735362" y="2875061"/>
+            <a:off x="7735362" y="3242615"/>
             <a:ext cx="1691640" cy="438912"/>
           </a:xfrm>
           <a:prstGeom prst="rect">
@@ -28554,18 +28907,18 @@
               <a:buNone/>
             </a:pPr>
             <a:r>
-              <a:rPr lang="en-US" sz="850" i="1" dirty="0">
+              <a:rPr lang="en-US" sz="1100" i="1" dirty="0">
                 <a:solidFill>
                   <a:srgbClr val="374151"/>
                 </a:solidFill>
-                <a:latin typeface="Roboto Slab" pitchFamily="2" charset="0"/>
+                <a:latin typeface="Aptos" panose="020B0004020202020204" pitchFamily="34" charset="0"/>
                 <a:ea typeface="Roboto Slab" pitchFamily="2" charset="0"/>
                 <a:cs typeface="Roboto Slab" pitchFamily="2" charset="0"/>
               </a:rPr>
               <a:t>100% mechanically checked</a:t>
             </a:r>
-            <a:endParaRPr lang="en-US" sz="850" dirty="0">
-              <a:latin typeface="Roboto Slab" pitchFamily="2" charset="0"/>
+            <a:endParaRPr lang="en-US" sz="1100" dirty="0">
+              <a:latin typeface="Aptos" panose="020B0004020202020204" pitchFamily="34" charset="0"/>
               <a:ea typeface="Roboto Slab" pitchFamily="2" charset="0"/>
               <a:cs typeface="Roboto Slab" pitchFamily="2" charset="0"/>
             </a:endParaRPr>
@@ -28586,7 +28939,7 @@
         </p:nvSpPr>
         <p:spPr>
           <a:xfrm>
-            <a:off x="1517442" y="3350549"/>
+            <a:off x="1517442" y="3718103"/>
             <a:ext cx="2377440" cy="438912"/>
           </a:xfrm>
           <a:prstGeom prst="rect">
@@ -28606,8 +28959,8 @@
           <a:bodyPr/>
           <a:lstStyle/>
           <a:p>
-            <a:endParaRPr lang="en-US">
-              <a:latin typeface="Roboto Slab" pitchFamily="2" charset="0"/>
+            <a:endParaRPr lang="en-US" sz="3200">
+              <a:latin typeface="Aptos" panose="020B0004020202020204" pitchFamily="34" charset="0"/>
               <a:ea typeface="Roboto Slab" pitchFamily="2" charset="0"/>
               <a:cs typeface="Roboto Slab" pitchFamily="2" charset="0"/>
             </a:endParaRPr>
@@ -28628,7 +28981,7 @@
         </p:nvSpPr>
         <p:spPr>
           <a:xfrm>
-            <a:off x="1608882" y="3350549"/>
+            <a:off x="1608882" y="3718103"/>
             <a:ext cx="2194560" cy="438912"/>
           </a:xfrm>
           <a:prstGeom prst="rect">
@@ -28645,18 +28998,18 @@
               <a:buNone/>
             </a:pPr>
             <a:r>
-              <a:rPr lang="en-US" sz="900" b="1" dirty="0">
+              <a:rPr lang="en-US" sz="1200" b="1" dirty="0">
                 <a:solidFill>
                   <a:srgbClr val="1A2B5E"/>
                 </a:solidFill>
-                <a:latin typeface="Roboto Slab" pitchFamily="2" charset="0"/>
+                <a:latin typeface="Aptos" panose="020B0004020202020204" pitchFamily="34" charset="0"/>
                 <a:ea typeface="Roboto Slab" pitchFamily="2" charset="0"/>
                 <a:cs typeface="Roboto Slab" pitchFamily="2" charset="0"/>
               </a:rPr>
               <a:t>Candidate PII sent to models</a:t>
             </a:r>
-            <a:endParaRPr lang="en-US" sz="900" dirty="0">
-              <a:latin typeface="Roboto Slab" pitchFamily="2" charset="0"/>
+            <a:endParaRPr lang="en-US" sz="1200" dirty="0">
+              <a:latin typeface="Aptos" panose="020B0004020202020204" pitchFamily="34" charset="0"/>
               <a:ea typeface="Roboto Slab" pitchFamily="2" charset="0"/>
               <a:cs typeface="Roboto Slab" pitchFamily="2" charset="0"/>
             </a:endParaRPr>
@@ -28677,7 +29030,7 @@
         </p:nvSpPr>
         <p:spPr>
           <a:xfrm>
-            <a:off x="3894882" y="3350549"/>
+            <a:off x="3894882" y="3718103"/>
             <a:ext cx="1874520" cy="438912"/>
           </a:xfrm>
           <a:prstGeom prst="rect">
@@ -28697,8 +29050,8 @@
           <a:bodyPr/>
           <a:lstStyle/>
           <a:p>
-            <a:endParaRPr lang="en-US">
-              <a:latin typeface="Roboto Slab" pitchFamily="2" charset="0"/>
+            <a:endParaRPr lang="en-US" sz="3200">
+              <a:latin typeface="Aptos" panose="020B0004020202020204" pitchFamily="34" charset="0"/>
               <a:ea typeface="Roboto Slab" pitchFamily="2" charset="0"/>
               <a:cs typeface="Roboto Slab" pitchFamily="2" charset="0"/>
             </a:endParaRPr>
@@ -28719,7 +29072,7 @@
         </p:nvSpPr>
         <p:spPr>
           <a:xfrm>
-            <a:off x="3986322" y="3350549"/>
+            <a:off x="3986322" y="3718103"/>
             <a:ext cx="1691640" cy="438912"/>
           </a:xfrm>
           <a:prstGeom prst="rect">
@@ -28736,18 +29089,18 @@
               <a:buNone/>
             </a:pPr>
             <a:r>
-              <a:rPr lang="en-US" sz="850" i="1" dirty="0">
+              <a:rPr lang="en-US" sz="1100" i="1" dirty="0">
                 <a:solidFill>
                   <a:srgbClr val="374151"/>
                 </a:solidFill>
-                <a:latin typeface="Roboto Slab" pitchFamily="2" charset="0"/>
+                <a:latin typeface="Aptos" panose="020B0004020202020204" pitchFamily="34" charset="0"/>
                 <a:ea typeface="Roboto Slab" pitchFamily="2" charset="0"/>
                 <a:cs typeface="Roboto Slab" pitchFamily="2" charset="0"/>
               </a:rPr>
               <a:t>Full documents</a:t>
             </a:r>
-            <a:endParaRPr lang="en-US" sz="850" dirty="0">
-              <a:latin typeface="Roboto Slab" pitchFamily="2" charset="0"/>
+            <a:endParaRPr lang="en-US" sz="1100" dirty="0">
+              <a:latin typeface="Aptos" panose="020B0004020202020204" pitchFamily="34" charset="0"/>
               <a:ea typeface="Roboto Slab" pitchFamily="2" charset="0"/>
               <a:cs typeface="Roboto Slab" pitchFamily="2" charset="0"/>
             </a:endParaRPr>
@@ -28768,7 +29121,7 @@
         </p:nvSpPr>
         <p:spPr>
           <a:xfrm>
-            <a:off x="5769402" y="3350549"/>
+            <a:off x="5769402" y="3718103"/>
             <a:ext cx="1874520" cy="438912"/>
           </a:xfrm>
           <a:prstGeom prst="rect">
@@ -28788,8 +29141,8 @@
           <a:bodyPr/>
           <a:lstStyle/>
           <a:p>
-            <a:endParaRPr lang="en-US">
-              <a:latin typeface="Roboto Slab" pitchFamily="2" charset="0"/>
+            <a:endParaRPr lang="en-US" sz="3200">
+              <a:latin typeface="Aptos" panose="020B0004020202020204" pitchFamily="34" charset="0"/>
               <a:ea typeface="Roboto Slab" pitchFamily="2" charset="0"/>
               <a:cs typeface="Roboto Slab" pitchFamily="2" charset="0"/>
             </a:endParaRPr>
@@ -28810,7 +29163,7 @@
         </p:nvSpPr>
         <p:spPr>
           <a:xfrm>
-            <a:off x="5860842" y="3350549"/>
+            <a:off x="5860842" y="3718103"/>
             <a:ext cx="1691640" cy="438912"/>
           </a:xfrm>
           <a:prstGeom prst="rect">
@@ -28827,18 +29180,18 @@
               <a:buNone/>
             </a:pPr>
             <a:r>
-              <a:rPr lang="en-US" sz="850" i="1" dirty="0">
+              <a:rPr lang="en-US" sz="1100" i="1" dirty="0">
                 <a:solidFill>
                   <a:srgbClr val="374151"/>
                 </a:solidFill>
-                <a:latin typeface="Roboto Slab" pitchFamily="2" charset="0"/>
+                <a:latin typeface="Aptos" panose="020B0004020202020204" pitchFamily="34" charset="0"/>
                 <a:ea typeface="Roboto Slab" pitchFamily="2" charset="0"/>
                 <a:cs typeface="Roboto Slab" pitchFamily="2" charset="0"/>
               </a:rPr>
               <a:t>Filtered at boundary</a:t>
             </a:r>
-            <a:endParaRPr lang="en-US" sz="850" dirty="0">
-              <a:latin typeface="Roboto Slab" pitchFamily="2" charset="0"/>
+            <a:endParaRPr lang="en-US" sz="1100" dirty="0">
+              <a:latin typeface="Aptos" panose="020B0004020202020204" pitchFamily="34" charset="0"/>
               <a:ea typeface="Roboto Slab" pitchFamily="2" charset="0"/>
               <a:cs typeface="Roboto Slab" pitchFamily="2" charset="0"/>
             </a:endParaRPr>
@@ -28859,7 +29212,7 @@
         </p:nvSpPr>
         <p:spPr>
           <a:xfrm>
-            <a:off x="7643922" y="3350549"/>
+            <a:off x="7643922" y="3718103"/>
             <a:ext cx="1874520" cy="438912"/>
           </a:xfrm>
           <a:prstGeom prst="rect">
@@ -28879,8 +29232,8 @@
           <a:bodyPr/>
           <a:lstStyle/>
           <a:p>
-            <a:endParaRPr lang="en-US">
-              <a:latin typeface="Roboto Slab" pitchFamily="2" charset="0"/>
+            <a:endParaRPr lang="en-US" sz="3200">
+              <a:latin typeface="Aptos" panose="020B0004020202020204" pitchFamily="34" charset="0"/>
               <a:ea typeface="Roboto Slab" pitchFamily="2" charset="0"/>
               <a:cs typeface="Roboto Slab" pitchFamily="2" charset="0"/>
             </a:endParaRPr>
@@ -28901,7 +29254,7 @@
         </p:nvSpPr>
         <p:spPr>
           <a:xfrm>
-            <a:off x="7735362" y="3350549"/>
+            <a:off x="7735362" y="3718103"/>
             <a:ext cx="1691640" cy="438912"/>
           </a:xfrm>
           <a:prstGeom prst="rect">
@@ -28918,18 +29271,18 @@
               <a:buNone/>
             </a:pPr>
             <a:r>
-              <a:rPr lang="en-US" sz="850" i="1" dirty="0">
+              <a:rPr lang="en-US" sz="1100" i="1" dirty="0">
                 <a:solidFill>
                   <a:srgbClr val="374151"/>
                 </a:solidFill>
-                <a:latin typeface="Roboto Slab" pitchFamily="2" charset="0"/>
+                <a:latin typeface="Aptos" panose="020B0004020202020204" pitchFamily="34" charset="0"/>
                 <a:ea typeface="Roboto Slab" pitchFamily="2" charset="0"/>
                 <a:cs typeface="Roboto Slab" pitchFamily="2" charset="0"/>
               </a:rPr>
               <a:t>0 PII by design</a:t>
             </a:r>
-            <a:endParaRPr lang="en-US" sz="850" dirty="0">
-              <a:latin typeface="Roboto Slab" pitchFamily="2" charset="0"/>
+            <a:endParaRPr lang="en-US" sz="1100" dirty="0">
+              <a:latin typeface="Aptos" panose="020B0004020202020204" pitchFamily="34" charset="0"/>
               <a:ea typeface="Roboto Slab" pitchFamily="2" charset="0"/>
               <a:cs typeface="Roboto Slab" pitchFamily="2" charset="0"/>
             </a:endParaRPr>
@@ -28950,7 +29303,7 @@
         </p:nvSpPr>
         <p:spPr>
           <a:xfrm>
-            <a:off x="1517442" y="3826037"/>
+            <a:off x="1517442" y="4193591"/>
             <a:ext cx="2377440" cy="438912"/>
           </a:xfrm>
           <a:prstGeom prst="rect">
@@ -28970,8 +29323,8 @@
           <a:bodyPr/>
           <a:lstStyle/>
           <a:p>
-            <a:endParaRPr lang="en-US">
-              <a:latin typeface="Roboto Slab" pitchFamily="2" charset="0"/>
+            <a:endParaRPr lang="en-US" sz="3200">
+              <a:latin typeface="Aptos" panose="020B0004020202020204" pitchFamily="34" charset="0"/>
               <a:ea typeface="Roboto Slab" pitchFamily="2" charset="0"/>
               <a:cs typeface="Roboto Slab" pitchFamily="2" charset="0"/>
             </a:endParaRPr>
@@ -28992,7 +29345,7 @@
         </p:nvSpPr>
         <p:spPr>
           <a:xfrm>
-            <a:off x="1608882" y="3826037"/>
+            <a:off x="1608882" y="4193591"/>
             <a:ext cx="2194560" cy="438912"/>
           </a:xfrm>
           <a:prstGeom prst="rect">
@@ -29009,18 +29362,18 @@
               <a:buNone/>
             </a:pPr>
             <a:r>
-              <a:rPr lang="en-US" sz="900" b="1" dirty="0">
+              <a:rPr lang="en-US" sz="1200" b="1" dirty="0">
                 <a:solidFill>
                   <a:srgbClr val="1A2B5E"/>
                 </a:solidFill>
-                <a:latin typeface="Roboto Slab" pitchFamily="2" charset="0"/>
+                <a:latin typeface="Aptos" panose="020B0004020202020204" pitchFamily="34" charset="0"/>
                 <a:ea typeface="Roboto Slab" pitchFamily="2" charset="0"/>
                 <a:cs typeface="Roboto Slab" pitchFamily="2" charset="0"/>
               </a:rPr>
               <a:t>Reviewer effort per decision</a:t>
             </a:r>
-            <a:endParaRPr lang="en-US" sz="900" dirty="0">
-              <a:latin typeface="Roboto Slab" pitchFamily="2" charset="0"/>
+            <a:endParaRPr lang="en-US" sz="1200" dirty="0">
+              <a:latin typeface="Aptos" panose="020B0004020202020204" pitchFamily="34" charset="0"/>
               <a:ea typeface="Roboto Slab" pitchFamily="2" charset="0"/>
               <a:cs typeface="Roboto Slab" pitchFamily="2" charset="0"/>
             </a:endParaRPr>
@@ -29041,7 +29394,7 @@
         </p:nvSpPr>
         <p:spPr>
           <a:xfrm>
-            <a:off x="3894882" y="3826037"/>
+            <a:off x="3894882" y="4193591"/>
             <a:ext cx="1874520" cy="438912"/>
           </a:xfrm>
           <a:prstGeom prst="rect">
@@ -29061,8 +29414,8 @@
           <a:bodyPr/>
           <a:lstStyle/>
           <a:p>
-            <a:endParaRPr lang="en-US">
-              <a:latin typeface="Roboto Slab" pitchFamily="2" charset="0"/>
+            <a:endParaRPr lang="en-US" sz="3200">
+              <a:latin typeface="Aptos" panose="020B0004020202020204" pitchFamily="34" charset="0"/>
               <a:ea typeface="Roboto Slab" pitchFamily="2" charset="0"/>
               <a:cs typeface="Roboto Slab" pitchFamily="2" charset="0"/>
             </a:endParaRPr>
@@ -29083,7 +29436,7 @@
         </p:nvSpPr>
         <p:spPr>
           <a:xfrm>
-            <a:off x="3986322" y="3826037"/>
+            <a:off x="3986322" y="4193591"/>
             <a:ext cx="1691640" cy="438912"/>
           </a:xfrm>
           <a:prstGeom prst="rect">
@@ -29100,18 +29453,18 @@
               <a:buNone/>
             </a:pPr>
             <a:r>
-              <a:rPr lang="en-US" sz="850" i="1" dirty="0">
+              <a:rPr lang="en-US" sz="1100" i="1" dirty="0">
                 <a:solidFill>
                   <a:srgbClr val="374151"/>
                 </a:solidFill>
-                <a:latin typeface="Roboto Slab" pitchFamily="2" charset="0"/>
+                <a:latin typeface="Aptos" panose="020B0004020202020204" pitchFamily="34" charset="0"/>
                 <a:ea typeface="Roboto Slab" pitchFamily="2" charset="0"/>
                 <a:cs typeface="Roboto Slab" pitchFamily="2" charset="0"/>
               </a:rPr>
               <a:t>Assemble manually</a:t>
             </a:r>
-            <a:endParaRPr lang="en-US" sz="850" dirty="0">
-              <a:latin typeface="Roboto Slab" pitchFamily="2" charset="0"/>
+            <a:endParaRPr lang="en-US" sz="1100" dirty="0">
+              <a:latin typeface="Aptos" panose="020B0004020202020204" pitchFamily="34" charset="0"/>
               <a:ea typeface="Roboto Slab" pitchFamily="2" charset="0"/>
               <a:cs typeface="Roboto Slab" pitchFamily="2" charset="0"/>
             </a:endParaRPr>
@@ -29132,7 +29485,7 @@
         </p:nvSpPr>
         <p:spPr>
           <a:xfrm>
-            <a:off x="5769402" y="3826037"/>
+            <a:off x="5769402" y="4193591"/>
             <a:ext cx="1874520" cy="438912"/>
           </a:xfrm>
           <a:prstGeom prst="rect">
@@ -29152,8 +29505,8 @@
           <a:bodyPr/>
           <a:lstStyle/>
           <a:p>
-            <a:endParaRPr lang="en-US">
-              <a:latin typeface="Roboto Slab" pitchFamily="2" charset="0"/>
+            <a:endParaRPr lang="en-US" sz="3200">
+              <a:latin typeface="Aptos" panose="020B0004020202020204" pitchFamily="34" charset="0"/>
               <a:ea typeface="Roboto Slab" pitchFamily="2" charset="0"/>
               <a:cs typeface="Roboto Slab" pitchFamily="2" charset="0"/>
             </a:endParaRPr>
@@ -29174,7 +29527,7 @@
         </p:nvSpPr>
         <p:spPr>
           <a:xfrm>
-            <a:off x="5860842" y="3826037"/>
+            <a:off x="5860842" y="4193591"/>
             <a:ext cx="1691640" cy="438912"/>
           </a:xfrm>
           <a:prstGeom prst="rect">
@@ -29191,18 +29544,18 @@
               <a:buNone/>
             </a:pPr>
             <a:r>
-              <a:rPr lang="en-US" sz="850" i="1" dirty="0">
+              <a:rPr lang="en-US" sz="1100" i="1" dirty="0">
                 <a:solidFill>
                   <a:srgbClr val="374151"/>
                 </a:solidFill>
-                <a:latin typeface="Roboto Slab" pitchFamily="2" charset="0"/>
+                <a:latin typeface="Aptos" panose="020B0004020202020204" pitchFamily="34" charset="0"/>
                 <a:ea typeface="Roboto Slab" pitchFamily="2" charset="0"/>
                 <a:cs typeface="Roboto Slab" pitchFamily="2" charset="0"/>
               </a:rPr>
               <a:t>Pre-built packet</a:t>
             </a:r>
-            <a:endParaRPr lang="en-US" sz="850" dirty="0">
-              <a:latin typeface="Roboto Slab" pitchFamily="2" charset="0"/>
+            <a:endParaRPr lang="en-US" sz="1100" dirty="0">
+              <a:latin typeface="Aptos" panose="020B0004020202020204" pitchFamily="34" charset="0"/>
               <a:ea typeface="Roboto Slab" pitchFamily="2" charset="0"/>
               <a:cs typeface="Roboto Slab" pitchFamily="2" charset="0"/>
             </a:endParaRPr>
@@ -29223,7 +29576,7 @@
         </p:nvSpPr>
         <p:spPr>
           <a:xfrm>
-            <a:off x="7643922" y="3826037"/>
+            <a:off x="7643922" y="4193591"/>
             <a:ext cx="1874520" cy="438912"/>
           </a:xfrm>
           <a:prstGeom prst="rect">
@@ -29243,8 +29596,8 @@
           <a:bodyPr/>
           <a:lstStyle/>
           <a:p>
-            <a:endParaRPr lang="en-US">
-              <a:latin typeface="Roboto Slab" pitchFamily="2" charset="0"/>
+            <a:endParaRPr lang="en-US" sz="3200">
+              <a:latin typeface="Aptos" panose="020B0004020202020204" pitchFamily="34" charset="0"/>
               <a:ea typeface="Roboto Slab" pitchFamily="2" charset="0"/>
               <a:cs typeface="Roboto Slab" pitchFamily="2" charset="0"/>
             </a:endParaRPr>
@@ -29265,7 +29618,7 @@
         </p:nvSpPr>
         <p:spPr>
           <a:xfrm>
-            <a:off x="7735362" y="3826037"/>
+            <a:off x="7735362" y="4193591"/>
             <a:ext cx="1691640" cy="438912"/>
           </a:xfrm>
           <a:prstGeom prst="rect">
@@ -29282,18 +29635,18 @@
               <a:buNone/>
             </a:pPr>
             <a:r>
-              <a:rPr lang="en-US" sz="850" i="1" dirty="0">
+              <a:rPr lang="en-US" sz="1100" i="1" dirty="0">
                 <a:solidFill>
                   <a:srgbClr val="374151"/>
                 </a:solidFill>
-                <a:latin typeface="Roboto Slab" pitchFamily="2" charset="0"/>
+                <a:latin typeface="Aptos" panose="020B0004020202020204" pitchFamily="34" charset="0"/>
                 <a:ea typeface="Roboto Slab" pitchFamily="2" charset="0"/>
                 <a:cs typeface="Roboto Slab" pitchFamily="2" charset="0"/>
               </a:rPr>
               <a:t>Single review step</a:t>
             </a:r>
-            <a:endParaRPr lang="en-US" sz="850" dirty="0">
-              <a:latin typeface="Roboto Slab" pitchFamily="2" charset="0"/>
+            <a:endParaRPr lang="en-US" sz="1100" dirty="0">
+              <a:latin typeface="Aptos" panose="020B0004020202020204" pitchFamily="34" charset="0"/>
               <a:ea typeface="Roboto Slab" pitchFamily="2" charset="0"/>
               <a:cs typeface="Roboto Slab" pitchFamily="2" charset="0"/>
             </a:endParaRPr>

</xml_diff>

<commit_message>
optimized and pptx updated
</commit_message>
<xml_diff>
--- a/documentation/HireLens_Capstone_Final_Submission.pptx
+++ b/documentation/HireLens_Capstone_Final_Submission.pptx
@@ -216,7 +216,7 @@
           <a:p>
             <a:fld id="{2C04DF3A-0132-4104-943D-4F8CBB4A4F3A}" type="datetimeFigureOut">
               <a:rPr lang="en-IN" smtClean="0"/>
-              <a:t>23-09-2026</a:t>
+              <a:t>24-09-2026</a:t>
             </a:fld>
             <a:endParaRPr lang="en-IN"/>
           </a:p>
@@ -831,7 +831,7 @@
           <a:p>
             <a:fld id="{AAC11897-8BC6-4790-9AEE-8382E829BD46}" type="datetimeFigureOut">
               <a:rPr lang="en-IN" smtClean="0"/>
-              <a:t>23-09-2026</a:t>
+              <a:t>24-09-2026</a:t>
             </a:fld>
             <a:endParaRPr lang="en-IN"/>
           </a:p>
@@ -1875,7 +1875,7 @@
           <a:p>
             <a:fld id="{AAC11897-8BC6-4790-9AEE-8382E829BD46}" type="datetimeFigureOut">
               <a:rPr lang="en-IN" smtClean="0"/>
-              <a:t>23-09-2026</a:t>
+              <a:t>24-09-2026</a:t>
             </a:fld>
             <a:endParaRPr lang="en-IN"/>
           </a:p>
@@ -2063,7 +2063,7 @@
           <a:p>
             <a:fld id="{F935C567-AFCF-4E1C-AA0E-C8D9AC99B565}" type="datetime1">
               <a:rPr lang="en-IN" smtClean="0"/>
-              <a:t>23-09-2026</a:t>
+              <a:t>24-09-2026</a:t>
             </a:fld>
             <a:endParaRPr lang="en-IN"/>
           </a:p>
@@ -10669,7 +10669,7 @@
           <a:p>
             <a:fld id="{AAC11897-8BC6-4790-9AEE-8382E829BD46}" type="datetimeFigureOut">
               <a:rPr lang="en-IN" smtClean="0"/>
-              <a:t>23-09-2026</a:t>
+              <a:t>24-09-2026</a:t>
             </a:fld>
             <a:endParaRPr lang="en-IN"/>
           </a:p>
@@ -11535,7 +11535,7 @@
                 <a:ea typeface="Roboto Slab" pitchFamily="2" charset="0"/>
                 <a:cs typeface="Roboto Slab" pitchFamily="2" charset="0"/>
               </a:rPr>
-              <a:t>Project Title:  HireLens — Agentic Recruitment Intelligence</a:t>
+              <a:t>Project Title:  HireLens — Agentic Evidence-Based Screening</a:t>
             </a:r>
           </a:p>
         </p:txBody>
@@ -12522,7 +12522,7 @@
         <p:spPr>
           <a:xfrm>
             <a:off x="6309360" y="1600200"/>
-            <a:ext cx="5486400" cy="2723566"/>
+            <a:ext cx="5486400" cy="3098028"/>
           </a:xfrm>
           <a:prstGeom prst="rect">
             <a:avLst/>
@@ -12625,6 +12625,55 @@
               </a:rPr>
               <a:t>•  Role-based access and per-team workspaces on top of the shared model.</a:t>
             </a:r>
+            <a:endParaRPr lang="en-US" sz="1400" dirty="0">
+              <a:solidFill>
+                <a:srgbClr val="333333"/>
+              </a:solidFill>
+              <a:latin typeface="Aptos" panose="020B0004020202020204" pitchFamily="34" charset="0"/>
+            </a:endParaRPr>
+          </a:p>
+          <a:p>
+            <a:pPr>
+              <a:lnSpc>
+                <a:spcPct val="150000"/>
+              </a:lnSpc>
+              <a:spcAft>
+                <a:spcPts val="400"/>
+              </a:spcAft>
+            </a:pPr>
+            <a:r>
+              <a:rPr lang="en-US" sz="1400" dirty="0">
+                <a:solidFill>
+                  <a:srgbClr val="333333"/>
+                </a:solidFill>
+                <a:latin typeface="Aptos" panose="020B0004020202020204" pitchFamily="34" charset="0"/>
+              </a:rPr>
+              <a:t>• Forward and backward integration in </a:t>
+            </a:r>
+            <a:r>
+              <a:rPr lang="en-US" sz="1400">
+                <a:solidFill>
+                  <a:srgbClr val="333333"/>
+                </a:solidFill>
+                <a:latin typeface="Aptos" panose="020B0004020202020204" pitchFamily="34" charset="0"/>
+              </a:rPr>
+              <a:t>the entire hiring </a:t>
+            </a:r>
+            <a:r>
+              <a:rPr lang="en-US" sz="1400" dirty="0">
+                <a:solidFill>
+                  <a:srgbClr val="333333"/>
+                </a:solidFill>
+                <a:latin typeface="Aptos" panose="020B0004020202020204" pitchFamily="34" charset="0"/>
+              </a:rPr>
+              <a:t>process.</a:t>
+            </a:r>
+            <a:endParaRPr sz="1400" dirty="0">
+              <a:solidFill>
+                <a:srgbClr val="333333"/>
+              </a:solidFill>
+              <a:latin typeface="Aptos" panose="020B0004020202020204" pitchFamily="34" charset="0"/>
+            </a:endParaRPr>
           </a:p>
         </p:txBody>
       </p:sp>
@@ -13044,25 +13093,7 @@
                 </a:solidFill>
                 <a:latin typeface="Aptos" panose="020B0004020202020204" pitchFamily="34" charset="0"/>
               </a:rPr>
-              <a:t>•  Project documentation — PRD, multi-agent architecture notes, token usage </a:t>
-            </a:r>
-            <a:r>
-              <a:rPr sz="1400" dirty="0" err="1">
-                <a:solidFill>
-                  <a:srgbClr val="333333"/>
-                </a:solidFill>
-                <a:latin typeface="Aptos" panose="020B0004020202020204" pitchFamily="34" charset="0"/>
-              </a:rPr>
-              <a:t>optimisation</a:t>
-            </a:r>
-            <a:r>
-              <a:rPr sz="1400" dirty="0">
-                <a:solidFill>
-                  <a:srgbClr val="333333"/>
-                </a:solidFill>
-                <a:latin typeface="Aptos" panose="020B0004020202020204" pitchFamily="34" charset="0"/>
-              </a:rPr>
-              <a:t> plan, knowledge-base usage guide (documentation/ folder).</a:t>
+              <a:t>•  Project documentation — PRD, multi-agent architecture notes, token usage optimization plan, knowledge-base usage guide (documentation/ folder).</a:t>
             </a:r>
           </a:p>
           <a:p>
@@ -13256,8 +13287,8 @@
         </p:nvSpPr>
         <p:spPr>
           <a:xfrm>
-            <a:off x="457200" y="2743200"/>
-            <a:ext cx="11247120" cy="1097280"/>
+            <a:off x="586509" y="5347855"/>
+            <a:ext cx="11247120" cy="515526"/>
           </a:xfrm>
           <a:prstGeom prst="rect">
             <a:avLst/>
@@ -13276,10 +13307,7 @@
               </a:spcBef>
             </a:pPr>
             <a:r>
-              <a:rPr sz="1500" b="1">
-                <a:solidFill>
-                  <a:srgbClr val="4A4C55"/>
-                </a:solidFill>
+              <a:rPr sz="1500" b="1" dirty="0">
                 <a:latin typeface="Roboto Slab"/>
               </a:rPr>
               <a:t>Thank you — questions welcome</a:t>
@@ -13292,12 +13320,12 @@
               </a:spcAft>
             </a:pPr>
             <a:r>
-              <a:rPr sz="1250">
-                <a:solidFill>
-                  <a:srgbClr val="333333"/>
-                </a:solidFill>
-              </a:rPr>
-              <a:t>HireLens: privacy-aware, evidence-grounded agentic recruitment intelligence.</a:t>
+              <a:rPr sz="1250" dirty="0" err="1"/>
+              <a:t>HireLens</a:t>
+            </a:r>
+            <a:r>
+              <a:rPr sz="1250" dirty="0"/>
+              <a:t>: privacy-aware, evidence-grounded agentic recruitment intelligence.</a:t>
             </a:r>
           </a:p>
         </p:txBody>
@@ -22007,7 +22035,7 @@
         <p:spPr>
           <a:xfrm>
             <a:off x="457200" y="1600200"/>
-            <a:ext cx="5577840" cy="3288080"/>
+            <a:ext cx="5577840" cy="3662541"/>
           </a:xfrm>
           <a:prstGeom prst="rect">
             <a:avLst/>
@@ -22034,6 +22062,25 @@
               </a:rPr>
               <a:t>Personas &amp; stakeholders</a:t>
             </a:r>
+            <a:endParaRPr lang="en-US" sz="1600" b="1" dirty="0">
+              <a:solidFill>
+                <a:srgbClr val="4A4C55"/>
+              </a:solidFill>
+              <a:latin typeface="Aptos" panose="020B0004020202020204" pitchFamily="34" charset="0"/>
+            </a:endParaRPr>
+          </a:p>
+          <a:p>
+            <a:pPr>
+              <a:spcBef>
+                <a:spcPts val="1000"/>
+              </a:spcBef>
+            </a:pPr>
+            <a:endParaRPr sz="1600" b="1" dirty="0">
+              <a:solidFill>
+                <a:srgbClr val="4A4C55"/>
+              </a:solidFill>
+              <a:latin typeface="Aptos" panose="020B0004020202020204" pitchFamily="34" charset="0"/>
+            </a:endParaRPr>
           </a:p>
           <a:p>
             <a:pPr>
@@ -22048,7 +22095,25 @@
                 </a:solidFill>
                 <a:latin typeface="Aptos" panose="020B0004020202020204" pitchFamily="34" charset="0"/>
               </a:rPr>
-              <a:t>•  Recruiters / talent partners — screen every resume manually against loosely structured JDs.</a:t>
+              <a:t>•  </a:t>
+            </a:r>
+            <a:r>
+              <a:rPr sz="1400" b="1" dirty="0">
+                <a:solidFill>
+                  <a:srgbClr val="333333"/>
+                </a:solidFill>
+                <a:latin typeface="Aptos" panose="020B0004020202020204" pitchFamily="34" charset="0"/>
+              </a:rPr>
+              <a:t>Recruiters</a:t>
+            </a:r>
+            <a:r>
+              <a:rPr sz="1400" dirty="0">
+                <a:solidFill>
+                  <a:srgbClr val="333333"/>
+                </a:solidFill>
+                <a:latin typeface="Aptos" panose="020B0004020202020204" pitchFamily="34" charset="0"/>
+              </a:rPr>
+              <a:t> / talent partners — screen every resume manually against loosely structured JDs.</a:t>
             </a:r>
           </a:p>
           <a:p>
@@ -22064,7 +22129,25 @@
                 </a:solidFill>
                 <a:latin typeface="Aptos" panose="020B0004020202020204" pitchFamily="34" charset="0"/>
               </a:rPr>
-              <a:t>•  Hiring managers — receive inconsistent, unverifiable interview feedback.</a:t>
+              <a:t>•  </a:t>
+            </a:r>
+            <a:r>
+              <a:rPr sz="1400" b="1" dirty="0">
+                <a:solidFill>
+                  <a:srgbClr val="333333"/>
+                </a:solidFill>
+                <a:latin typeface="Aptos" panose="020B0004020202020204" pitchFamily="34" charset="0"/>
+              </a:rPr>
+              <a:t>Hiring managers</a:t>
+            </a:r>
+            <a:r>
+              <a:rPr sz="1400" dirty="0">
+                <a:solidFill>
+                  <a:srgbClr val="333333"/>
+                </a:solidFill>
+                <a:latin typeface="Aptos" panose="020B0004020202020204" pitchFamily="34" charset="0"/>
+              </a:rPr>
+              <a:t> — receive inconsistent, unverifiable interview feedback.</a:t>
             </a:r>
           </a:p>
           <a:p>
@@ -22080,7 +22163,25 @@
                 </a:solidFill>
                 <a:latin typeface="Aptos" panose="020B0004020202020204" pitchFamily="34" charset="0"/>
               </a:rPr>
-              <a:t>•  Reviewers — make final calls with no audit trail of how AI reached them.</a:t>
+              <a:t>•  Reviewers — make final calls with no audit trail of how </a:t>
+            </a:r>
+            <a:r>
+              <a:rPr lang="en-US" sz="1400" dirty="0">
+                <a:solidFill>
+                  <a:srgbClr val="333333"/>
+                </a:solidFill>
+                <a:latin typeface="Aptos" panose="020B0004020202020204" pitchFamily="34" charset="0"/>
+              </a:rPr>
+              <a:t>an interviewer or </a:t>
+            </a:r>
+            <a:r>
+              <a:rPr sz="1400" dirty="0">
+                <a:solidFill>
+                  <a:srgbClr val="333333"/>
+                </a:solidFill>
+                <a:latin typeface="Aptos" panose="020B0004020202020204" pitchFamily="34" charset="0"/>
+              </a:rPr>
+              <a:t>AI reached them.</a:t>
             </a:r>
           </a:p>
           <a:p>
@@ -22128,7 +22229,25 @@
                 </a:solidFill>
                 <a:latin typeface="Aptos" panose="020B0004020202020204" pitchFamily="34" charset="0"/>
               </a:rPr>
-              <a:t>Hiring quality and compliance pressure demand evidence, consistency, and privacy — agentic AI can deliver all three while humans keep the final decision.</a:t>
+              <a:t>Hiring quality and compliance pressure demand</a:t>
+            </a:r>
+            <a:r>
+              <a:rPr lang="en-US" sz="1400" dirty="0">
+                <a:solidFill>
+                  <a:srgbClr val="333333"/>
+                </a:solidFill>
+                <a:latin typeface="Aptos" panose="020B0004020202020204" pitchFamily="34" charset="0"/>
+              </a:rPr>
+              <a:t>s</a:t>
+            </a:r>
+            <a:r>
+              <a:rPr sz="1400" dirty="0">
+                <a:solidFill>
+                  <a:srgbClr val="333333"/>
+                </a:solidFill>
+                <a:latin typeface="Aptos" panose="020B0004020202020204" pitchFamily="34" charset="0"/>
+              </a:rPr>
+              <a:t> evidence, consistency, and privacy — agentic AI can deliver all three while humans keep the final decision.</a:t>
             </a:r>
           </a:p>
         </p:txBody>
@@ -22142,7 +22261,7 @@
         <p:spPr>
           <a:xfrm>
             <a:off x="6309360" y="1600200"/>
-            <a:ext cx="5486400" cy="3529171"/>
+            <a:ext cx="5486400" cy="3903633"/>
           </a:xfrm>
           <a:prstGeom prst="rect">
             <a:avLst/>
@@ -22169,6 +22288,25 @@
               </a:rPr>
               <a:t>Problem statement</a:t>
             </a:r>
+            <a:endParaRPr lang="en-US" sz="1600" b="1" dirty="0">
+              <a:solidFill>
+                <a:srgbClr val="4A4C55"/>
+              </a:solidFill>
+              <a:latin typeface="Aptos" panose="020B0004020202020204" pitchFamily="34" charset="0"/>
+            </a:endParaRPr>
+          </a:p>
+          <a:p>
+            <a:pPr>
+              <a:spcBef>
+                <a:spcPts val="1000"/>
+              </a:spcBef>
+            </a:pPr>
+            <a:endParaRPr sz="1600" b="1" dirty="0">
+              <a:solidFill>
+                <a:srgbClr val="4A4C55"/>
+              </a:solidFill>
+              <a:latin typeface="Aptos" panose="020B0004020202020204" pitchFamily="34" charset="0"/>
+            </a:endParaRPr>
           </a:p>
           <a:p>
             <a:pPr>
@@ -22485,53 +22623,6 @@
       </p:sp>
       <p:sp>
         <p:nvSpPr>
-          <p:cNvPr id="7" name="TextBox 6">
-            <a:extLst>
-              <a:ext uri="{FF2B5EF4-FFF2-40B4-BE49-F238E27FC236}">
-                <a16:creationId xmlns:a16="http://schemas.microsoft.com/office/drawing/2014/main" id="{BCCC67C7-4ACD-02A9-CCC4-BD32F1A6595C}"/>
-              </a:ext>
-            </a:extLst>
-          </p:cNvPr>
-          <p:cNvSpPr txBox="1"/>
-          <p:nvPr/>
-        </p:nvSpPr>
-        <p:spPr>
-          <a:xfrm>
-            <a:off x="402336" y="1062452"/>
-            <a:ext cx="8149382" cy="369332"/>
-          </a:xfrm>
-          <a:prstGeom prst="rect">
-            <a:avLst/>
-          </a:prstGeom>
-          <a:noFill/>
-        </p:spPr>
-        <p:txBody>
-          <a:bodyPr wrap="square">
-            <a:spAutoFit/>
-          </a:bodyPr>
-          <a:lstStyle/>
-          <a:p>
-            <a:pPr>
-              <a:tabLst>
-                <a:tab pos="361950" algn="l"/>
-              </a:tabLst>
-            </a:pPr>
-            <a:r>
-              <a:rPr lang="en-IN" sz="1800" dirty="0">
-                <a:solidFill>
-                  <a:srgbClr val="4A4C55"/>
-                </a:solidFill>
-                <a:latin typeface="Aptos" panose="020B0004020202020204" pitchFamily="34" charset="0"/>
-                <a:ea typeface="Roboto Slab" pitchFamily="2" charset="0"/>
-                <a:cs typeface="Poppins" panose="00000500000000000000" pitchFamily="2" charset="0"/>
-              </a:rPr>
-              <a:t>3-4 execution objectives with action verbs on end outcomes. </a:t>
-            </a:r>
-          </a:p>
-        </p:txBody>
-      </p:sp>
-      <p:sp>
-        <p:nvSpPr>
           <p:cNvPr id="4" name="TextBox 3">
             <a:extLst>
               <a:ext uri="{FF2B5EF4-FFF2-40B4-BE49-F238E27FC236}">
@@ -22544,8 +22635,8 @@
         </p:nvSpPr>
         <p:spPr>
           <a:xfrm>
-            <a:off x="883227" y="1894259"/>
-            <a:ext cx="10092634" cy="2492990"/>
+            <a:off x="551533" y="1087436"/>
+            <a:ext cx="10092634" cy="3708708"/>
           </a:xfrm>
           <a:prstGeom prst="rect">
             <a:avLst/>
@@ -22573,26 +22664,30 @@
                 </a:solidFill>
                 <a:latin typeface="Aptos" panose="020B0004020202020204" pitchFamily="34" charset="0"/>
               </a:rPr>
-              <a:t>1.  Automate structured extraction of weighted job requirements and </a:t>
+              <a:t>1.  Automate structured extraction of weighted job requirements and anonymized candidate profiles, filtering PII before any content reaches a model provider.</a:t>
             </a:r>
-            <a:r>
-              <a:rPr sz="1400" dirty="0" err="1">
-                <a:solidFill>
-                  <a:srgbClr val="000000"/>
-                </a:solidFill>
-                <a:latin typeface="Aptos" panose="020B0004020202020204" pitchFamily="34" charset="0"/>
-              </a:rPr>
-              <a:t>anonymised</a:t>
-            </a:r>
-            <a:r>
-              <a:rPr sz="1400" dirty="0">
-                <a:solidFill>
-                  <a:srgbClr val="000000"/>
-                </a:solidFill>
-                <a:latin typeface="Aptos" panose="020B0004020202020204" pitchFamily="34" charset="0"/>
-              </a:rPr>
-              <a:t> candidate profiles, filtering PII before any content reaches a model provider.</a:t>
-            </a:r>
+            <a:endParaRPr lang="en-US" sz="1400" dirty="0">
+              <a:solidFill>
+                <a:srgbClr val="000000"/>
+              </a:solidFill>
+              <a:latin typeface="Aptos" panose="020B0004020202020204" pitchFamily="34" charset="0"/>
+            </a:endParaRPr>
+          </a:p>
+          <a:p>
+            <a:pPr algn="l">
+              <a:lnSpc>
+                <a:spcPct val="150000"/>
+              </a:lnSpc>
+              <a:spcAft>
+                <a:spcPts val="1200"/>
+              </a:spcAft>
+            </a:pPr>
+            <a:endParaRPr sz="1400" dirty="0">
+              <a:solidFill>
+                <a:srgbClr val="000000"/>
+              </a:solidFill>
+              <a:latin typeface="Aptos" panose="020B0004020202020204" pitchFamily="34" charset="0"/>
+            </a:endParaRPr>
           </a:p>
           <a:p>
             <a:pPr>
@@ -22607,8 +22702,45 @@
                 </a:solidFill>
                 <a:latin typeface="Aptos" panose="020B0004020202020204" pitchFamily="34" charset="0"/>
               </a:rPr>
-              <a:t>2.  Generate evidence-grounded match analyses and tailored interview plans using intent-driven Agentic RAG over a privacy-filtered case knowledge base.</a:t>
+              <a:t>2.  Generate evidence-grounded match analys</a:t>
             </a:r>
+            <a:r>
+              <a:rPr lang="en-US" sz="1400" dirty="0">
+                <a:solidFill>
+                  <a:srgbClr val="000000"/>
+                </a:solidFill>
+                <a:latin typeface="Aptos" panose="020B0004020202020204" pitchFamily="34" charset="0"/>
+              </a:rPr>
+              <a:t>e</a:t>
+            </a:r>
+            <a:r>
+              <a:rPr sz="1400" dirty="0">
+                <a:solidFill>
+                  <a:srgbClr val="000000"/>
+                </a:solidFill>
+                <a:latin typeface="Aptos" panose="020B0004020202020204" pitchFamily="34" charset="0"/>
+              </a:rPr>
+              <a:t>s and tailored interview plans using intent-driven Agentic RAG over a privacy-filtered case knowledge base.</a:t>
+            </a:r>
+            <a:endParaRPr lang="en-US" sz="1400" dirty="0">
+              <a:solidFill>
+                <a:srgbClr val="000000"/>
+              </a:solidFill>
+              <a:latin typeface="Aptos" panose="020B0004020202020204" pitchFamily="34" charset="0"/>
+            </a:endParaRPr>
+          </a:p>
+          <a:p>
+            <a:pPr>
+              <a:spcAft>
+                <a:spcPts val="1200"/>
+              </a:spcAft>
+            </a:pPr>
+            <a:endParaRPr sz="1400" dirty="0">
+              <a:solidFill>
+                <a:srgbClr val="000000"/>
+              </a:solidFill>
+              <a:latin typeface="Aptos" panose="020B0004020202020204" pitchFamily="34" charset="0"/>
+            </a:endParaRPr>
           </a:p>
           <a:p>
             <a:pPr>
@@ -22625,6 +22757,25 @@
               </a:rPr>
               <a:t>3.  Evaluate interview transcripts with quote-grounded scoring and case-grounded red-flag detection, keeping a human reviewer in control of every outcome.</a:t>
             </a:r>
+            <a:endParaRPr lang="en-US" sz="1400" dirty="0">
+              <a:solidFill>
+                <a:srgbClr val="000000"/>
+              </a:solidFill>
+              <a:latin typeface="Aptos" panose="020B0004020202020204" pitchFamily="34" charset="0"/>
+            </a:endParaRPr>
+          </a:p>
+          <a:p>
+            <a:pPr>
+              <a:spcAft>
+                <a:spcPts val="1200"/>
+              </a:spcAft>
+            </a:pPr>
+            <a:endParaRPr sz="1400" dirty="0">
+              <a:solidFill>
+                <a:srgbClr val="000000"/>
+              </a:solidFill>
+              <a:latin typeface="Aptos" panose="020B0004020202020204" pitchFamily="34" charset="0"/>
+            </a:endParaRPr>
           </a:p>
           <a:p>
             <a:pPr>

</xml_diff>